<commit_message>
Clarify the AC/DC hackathon purpose on the first slide
</commit_message>
<xml_diff>
--- a/docs/hackathon-pitch.pptx
+++ b/docs/hackathon-pitch.pptx
@@ -3999,6 +3999,7 @@
               </a:defRPr>
             </a:defPPr>
             <a:lvl1pPr>
+              <a:buNone/>
               <a:defRPr sz="1500" b="1">
                 <a:solidFill>
                   <a:srgbClr val="D8B44E"/>
@@ -4009,6 +4010,7 @@
               </a:defRPr>
             </a:lvl1pPr>
             <a:lvl2pPr>
+              <a:buNone/>
               <a:defRPr sz="1500" b="1">
                 <a:solidFill>
                   <a:srgbClr val="D8B44E"/>
@@ -4019,6 +4021,7 @@
               </a:defRPr>
             </a:lvl2pPr>
             <a:lvl3pPr>
+              <a:buNone/>
               <a:defRPr sz="1500" b="1">
                 <a:solidFill>
                   <a:srgbClr val="D8B44E"/>
@@ -4029,6 +4032,7 @@
               </a:defRPr>
             </a:lvl3pPr>
             <a:lvl4pPr>
+              <a:buNone/>
               <a:defRPr sz="1500" b="1">
                 <a:solidFill>
                   <a:srgbClr val="D8B44E"/>
@@ -4039,6 +4043,7 @@
               </a:defRPr>
             </a:lvl4pPr>
             <a:lvl5pPr>
+              <a:buNone/>
               <a:defRPr sz="1500" b="1">
                 <a:solidFill>
                   <a:srgbClr val="D8B44E"/>
@@ -4049,6 +4054,7 @@
               </a:defRPr>
             </a:lvl5pPr>
             <a:lvl6pPr>
+              <a:buNone/>
               <a:defRPr sz="1500" b="1">
                 <a:solidFill>
                   <a:srgbClr val="D8B44E"/>
@@ -4059,6 +4065,7 @@
               </a:defRPr>
             </a:lvl6pPr>
             <a:lvl7pPr>
+              <a:buNone/>
               <a:defRPr sz="1500" b="1">
                 <a:solidFill>
                   <a:srgbClr val="D8B44E"/>
@@ -4069,6 +4076,7 @@
               </a:defRPr>
             </a:lvl7pPr>
             <a:lvl8pPr>
+              <a:buNone/>
               <a:defRPr sz="1500" b="1">
                 <a:solidFill>
                   <a:srgbClr val="D8B44E"/>
@@ -4079,6 +4087,7 @@
               </a:defRPr>
             </a:lvl8pPr>
             <a:lvl9pPr>
+              <a:buNone/>
               <a:defRPr sz="1500" b="1">
                 <a:solidFill>
                   <a:srgbClr val="D8B44E"/>
@@ -4091,6 +4100,7 @@
           </a:lstStyle>
           <a:p xmlns:a="http://schemas.openxmlformats.org/drawingml/2006/main">
             <a:pPr>
+              <a:buNone/>
               <a:defRPr sz="1500" b="1">
                 <a:solidFill>
                   <a:srgbClr val="D8B44E"/>
@@ -4109,7 +4119,7 @@
                 <a:ea typeface="Helvetica Neue"/>
                 <a:cs typeface="Helvetica Neue"/>
               </a:rPr>
-              <a:t>BUILT AT THIS HACKATHON</a:t>
+              <a:t>TEAM AC/DC</a:t>
             </a:r>
           </a:p>
         </p:txBody>
@@ -4130,8 +4140,8 @@
         </p:nvSpPr>
         <p:spPr>
           <a:xfrm xmlns:a="http://schemas.openxmlformats.org/drawingml/2006/main">
-            <a:off x="609600" y="1638300"/>
-            <a:ext cx="4857750" cy="1619250"/>
+            <a:off x="609600" y="1428750"/>
+            <a:ext cx="4857750" cy="1257300"/>
           </a:xfrm>
           <a:prstGeom xmlns:a="http://schemas.openxmlformats.org/drawingml/2006/main" prst="rect">
             <a:avLst/>
@@ -4142,9 +4152,22 @@
           </a:ln>
         </p:spPr>
         <p:txBody>
-          <a:bodyPr xmlns:a="http://schemas.openxmlformats.org/drawingml/2006/main"/>
+          <a:bodyPr xmlns:a="http://schemas.openxmlformats.org/drawingml/2006/main" wrap="square" lIns="85725" tIns="0" rIns="0" bIns="0" anchor="t">
+            <a:normAutofit fontScale="100000"/>
+          </a:bodyPr>
           <a:lstStyle xmlns:a="http://schemas.openxmlformats.org/drawingml/2006/main">
-            <a:defPPr>
+            <a:defPPr algn="l">
+              <a:defRPr sz="3600" b="1">
+                <a:solidFill>
+                  <a:srgbClr val="F2F0E5"/>
+                </a:solidFill>
+                <a:latin typeface="Helvetica Neue"/>
+                <a:ea typeface="Helvetica Neue"/>
+                <a:cs typeface="Helvetica Neue"/>
+              </a:defRPr>
+            </a:defPPr>
+            <a:lvl1pPr algn="l">
+              <a:buNone/>
               <a:defRPr sz="4650" b="1">
                 <a:solidFill>
                   <a:srgbClr val="F2F0E5"/>
@@ -4153,8 +4176,9 @@
                 <a:ea typeface="Helvetica Neue"/>
                 <a:cs typeface="Helvetica Neue"/>
               </a:defRPr>
-            </a:defPPr>
-            <a:lvl1pPr>
+            </a:lvl1pPr>
+            <a:lvl2pPr algn="l">
+              <a:buNone/>
               <a:defRPr sz="4650" b="1">
                 <a:solidFill>
                   <a:srgbClr val="F2F0E5"/>
@@ -4163,8 +4187,9 @@
                 <a:ea typeface="Helvetica Neue"/>
                 <a:cs typeface="Helvetica Neue"/>
               </a:defRPr>
-            </a:lvl1pPr>
-            <a:lvl2pPr>
+            </a:lvl2pPr>
+            <a:lvl3pPr algn="l">
+              <a:buNone/>
               <a:defRPr sz="4650" b="1">
                 <a:solidFill>
                   <a:srgbClr val="F2F0E5"/>
@@ -4173,8 +4198,9 @@
                 <a:ea typeface="Helvetica Neue"/>
                 <a:cs typeface="Helvetica Neue"/>
               </a:defRPr>
-            </a:lvl2pPr>
-            <a:lvl3pPr>
+            </a:lvl3pPr>
+            <a:lvl4pPr algn="l">
+              <a:buNone/>
               <a:defRPr sz="4650" b="1">
                 <a:solidFill>
                   <a:srgbClr val="F2F0E5"/>
@@ -4183,8 +4209,9 @@
                 <a:ea typeface="Helvetica Neue"/>
                 <a:cs typeface="Helvetica Neue"/>
               </a:defRPr>
-            </a:lvl3pPr>
-            <a:lvl4pPr>
+            </a:lvl4pPr>
+            <a:lvl5pPr algn="l">
+              <a:buNone/>
               <a:defRPr sz="4650" b="1">
                 <a:solidFill>
                   <a:srgbClr val="F2F0E5"/>
@@ -4193,8 +4220,9 @@
                 <a:ea typeface="Helvetica Neue"/>
                 <a:cs typeface="Helvetica Neue"/>
               </a:defRPr>
-            </a:lvl4pPr>
-            <a:lvl5pPr>
+            </a:lvl5pPr>
+            <a:lvl6pPr algn="l">
+              <a:buNone/>
               <a:defRPr sz="4650" b="1">
                 <a:solidFill>
                   <a:srgbClr val="F2F0E5"/>
@@ -4203,8 +4231,9 @@
                 <a:ea typeface="Helvetica Neue"/>
                 <a:cs typeface="Helvetica Neue"/>
               </a:defRPr>
-            </a:lvl5pPr>
-            <a:lvl6pPr>
+            </a:lvl6pPr>
+            <a:lvl7pPr algn="l">
+              <a:buNone/>
               <a:defRPr sz="4650" b="1">
                 <a:solidFill>
                   <a:srgbClr val="F2F0E5"/>
@@ -4213,8 +4242,9 @@
                 <a:ea typeface="Helvetica Neue"/>
                 <a:cs typeface="Helvetica Neue"/>
               </a:defRPr>
-            </a:lvl6pPr>
-            <a:lvl7pPr>
+            </a:lvl7pPr>
+            <a:lvl8pPr algn="l">
+              <a:buNone/>
               <a:defRPr sz="4650" b="1">
                 <a:solidFill>
                   <a:srgbClr val="F2F0E5"/>
@@ -4223,18 +4253,9 @@
                 <a:ea typeface="Helvetica Neue"/>
                 <a:cs typeface="Helvetica Neue"/>
               </a:defRPr>
-            </a:lvl7pPr>
-            <a:lvl8pPr>
-              <a:defRPr sz="4650" b="1">
-                <a:solidFill>
-                  <a:srgbClr val="F2F0E5"/>
-                </a:solidFill>
-                <a:latin typeface="Helvetica Neue"/>
-                <a:ea typeface="Helvetica Neue"/>
-                <a:cs typeface="Helvetica Neue"/>
-              </a:defRPr>
             </a:lvl8pPr>
-            <a:lvl9pPr>
+            <a:lvl9pPr algn="l">
+              <a:buNone/>
               <a:defRPr sz="4650" b="1">
                 <a:solidFill>
                   <a:srgbClr val="F2F0E5"/>
@@ -4246,8 +4267,9 @@
             </a:lvl9pPr>
           </a:lstStyle>
           <a:p xmlns:a="http://schemas.openxmlformats.org/drawingml/2006/main">
-            <a:pPr>
-              <a:defRPr sz="4650" b="1">
+            <a:pPr algn="l">
+              <a:buNone/>
+              <a:defRPr sz="3600" b="1">
                 <a:solidFill>
                   <a:srgbClr val="F2F0E5"/>
                 </a:solidFill>
@@ -4257,7 +4279,7 @@
               </a:defRPr>
             </a:pPr>
             <a:r>
-              <a:rPr sz="4650" b="1">
+              <a:rPr sz="3600" b="1">
                 <a:solidFill>
                   <a:srgbClr val="F2F0E5"/>
                 </a:solidFill>
@@ -4265,12 +4287,13 @@
                 <a:ea typeface="Helvetica Neue"/>
                 <a:cs typeface="Helvetica Neue"/>
               </a:rPr>
-              <a:t>AI energy</a:t>
+              <a:t>Measuring electricity</a:t>
             </a:r>
           </a:p>
           <a:p xmlns:a="http://schemas.openxmlformats.org/drawingml/2006/main">
-            <a:pPr>
-              <a:defRPr sz="4650" b="1">
+            <a:pPr algn="l">
+              <a:buNone/>
+              <a:defRPr sz="3600" b="1">
                 <a:solidFill>
                   <a:srgbClr val="F2F0E5"/>
                 </a:solidFill>
@@ -4280,7 +4303,7 @@
               </a:defRPr>
             </a:pPr>
             <a:r>
-              <a:rPr sz="4650" b="1">
+              <a:rPr sz="3600" b="1">
                 <a:solidFill>
                   <a:srgbClr val="F2F0E5"/>
                 </a:solidFill>
@@ -4288,7 +4311,7 @@
                 <a:ea typeface="Helvetica Neue"/>
                 <a:cs typeface="Helvetica Neue"/>
               </a:rPr>
-              <a:t>audit prototype</a:t>
+              <a:t>per LLM token</a:t>
             </a:r>
           </a:p>
         </p:txBody>
@@ -4309,8 +4332,8 @@
         </p:nvSpPr>
         <p:spPr>
           <a:xfrm xmlns:a="http://schemas.openxmlformats.org/drawingml/2006/main">
-            <a:off x="609600" y="3657600"/>
-            <a:ext cx="4857750" cy="1714500"/>
+            <a:off x="609600" y="2952750"/>
+            <a:ext cx="4857750" cy="1562100"/>
           </a:xfrm>
           <a:prstGeom xmlns:a="http://schemas.openxmlformats.org/drawingml/2006/main" prst="rect">
             <a:avLst/>
@@ -4321,9 +4344,22 @@
           </a:ln>
         </p:spPr>
         <p:txBody>
-          <a:bodyPr xmlns:a="http://schemas.openxmlformats.org/drawingml/2006/main"/>
+          <a:bodyPr xmlns:a="http://schemas.openxmlformats.org/drawingml/2006/main" wrap="square" lIns="85725" tIns="0" rIns="0" bIns="0" anchor="t">
+            <a:normAutofit fontScale="100000"/>
+          </a:bodyPr>
           <a:lstStyle xmlns:a="http://schemas.openxmlformats.org/drawingml/2006/main">
-            <a:defPPr>
+            <a:defPPr algn="l">
+              <a:defRPr sz="1950" b="0">
+                <a:solidFill>
+                  <a:srgbClr val="F2F0E5"/>
+                </a:solidFill>
+                <a:latin typeface="Helvetica Neue"/>
+                <a:ea typeface="Helvetica Neue"/>
+                <a:cs typeface="Helvetica Neue"/>
+              </a:defRPr>
+            </a:defPPr>
+            <a:lvl1pPr algn="l">
+              <a:buNone/>
               <a:defRPr sz="2175" b="0">
                 <a:solidFill>
                   <a:srgbClr val="F2F0E5"/>
@@ -4332,8 +4368,9 @@
                 <a:ea typeface="Helvetica Neue"/>
                 <a:cs typeface="Helvetica Neue"/>
               </a:defRPr>
-            </a:defPPr>
-            <a:lvl1pPr>
+            </a:lvl1pPr>
+            <a:lvl2pPr algn="l">
+              <a:buNone/>
               <a:defRPr sz="2175" b="0">
                 <a:solidFill>
                   <a:srgbClr val="F2F0E5"/>
@@ -4342,8 +4379,9 @@
                 <a:ea typeface="Helvetica Neue"/>
                 <a:cs typeface="Helvetica Neue"/>
               </a:defRPr>
-            </a:lvl1pPr>
-            <a:lvl2pPr>
+            </a:lvl2pPr>
+            <a:lvl3pPr algn="l">
+              <a:buNone/>
               <a:defRPr sz="2175" b="0">
                 <a:solidFill>
                   <a:srgbClr val="F2F0E5"/>
@@ -4352,8 +4390,9 @@
                 <a:ea typeface="Helvetica Neue"/>
                 <a:cs typeface="Helvetica Neue"/>
               </a:defRPr>
-            </a:lvl2pPr>
-            <a:lvl3pPr>
+            </a:lvl3pPr>
+            <a:lvl4pPr algn="l">
+              <a:buNone/>
               <a:defRPr sz="2175" b="0">
                 <a:solidFill>
                   <a:srgbClr val="F2F0E5"/>
@@ -4362,8 +4401,9 @@
                 <a:ea typeface="Helvetica Neue"/>
                 <a:cs typeface="Helvetica Neue"/>
               </a:defRPr>
-            </a:lvl3pPr>
-            <a:lvl4pPr>
+            </a:lvl4pPr>
+            <a:lvl5pPr algn="l">
+              <a:buNone/>
               <a:defRPr sz="2175" b="0">
                 <a:solidFill>
                   <a:srgbClr val="F2F0E5"/>
@@ -4372,8 +4412,9 @@
                 <a:ea typeface="Helvetica Neue"/>
                 <a:cs typeface="Helvetica Neue"/>
               </a:defRPr>
-            </a:lvl4pPr>
-            <a:lvl5pPr>
+            </a:lvl5pPr>
+            <a:lvl6pPr algn="l">
+              <a:buNone/>
               <a:defRPr sz="2175" b="0">
                 <a:solidFill>
                   <a:srgbClr val="F2F0E5"/>
@@ -4382,8 +4423,9 @@
                 <a:ea typeface="Helvetica Neue"/>
                 <a:cs typeface="Helvetica Neue"/>
               </a:defRPr>
-            </a:lvl5pPr>
-            <a:lvl6pPr>
+            </a:lvl6pPr>
+            <a:lvl7pPr algn="l">
+              <a:buNone/>
               <a:defRPr sz="2175" b="0">
                 <a:solidFill>
                   <a:srgbClr val="F2F0E5"/>
@@ -4392,8 +4434,9 @@
                 <a:ea typeface="Helvetica Neue"/>
                 <a:cs typeface="Helvetica Neue"/>
               </a:defRPr>
-            </a:lvl6pPr>
-            <a:lvl7pPr>
+            </a:lvl7pPr>
+            <a:lvl8pPr algn="l">
+              <a:buNone/>
               <a:defRPr sz="2175" b="0">
                 <a:solidFill>
                   <a:srgbClr val="F2F0E5"/>
@@ -4402,18 +4445,9 @@
                 <a:ea typeface="Helvetica Neue"/>
                 <a:cs typeface="Helvetica Neue"/>
               </a:defRPr>
-            </a:lvl7pPr>
-            <a:lvl8pPr>
-              <a:defRPr sz="2175" b="0">
-                <a:solidFill>
-                  <a:srgbClr val="F2F0E5"/>
-                </a:solidFill>
-                <a:latin typeface="Helvetica Neue"/>
-                <a:ea typeface="Helvetica Neue"/>
-                <a:cs typeface="Helvetica Neue"/>
-              </a:defRPr>
             </a:lvl8pPr>
-            <a:lvl9pPr>
+            <a:lvl9pPr algn="l">
+              <a:buNone/>
               <a:defRPr sz="2175" b="0">
                 <a:solidFill>
                   <a:srgbClr val="F2F0E5"/>
@@ -4425,8 +4459,9 @@
             </a:lvl9pPr>
           </a:lstStyle>
           <a:p xmlns:a="http://schemas.openxmlformats.org/drawingml/2006/main">
-            <a:pPr>
-              <a:defRPr sz="2175" b="0">
+            <a:pPr algn="l">
+              <a:buNone/>
+              <a:defRPr sz="1950" b="0">
                 <a:solidFill>
                   <a:srgbClr val="F2F0E5"/>
                 </a:solidFill>
@@ -4436,7 +4471,7 @@
               </a:defRPr>
             </a:pPr>
             <a:r>
-              <a:rPr sz="2175" b="0">
+              <a:rPr sz="1950" b="0">
                 <a:solidFill>
                   <a:srgbClr val="F2F0E5"/>
                 </a:solidFill>
@@ -4444,7 +4479,7 @@
                 <a:ea typeface="Helvetica Neue"/>
                 <a:cs typeface="Helvetica Neue"/>
               </a:rPr>
-              <a:t>At this hackathon, we built an open-source prototype that compares electricity per successful AI task for data centers with limited power.</a:t>
+              <a:t>At this hackathon, we built an open-source project to show how electricity becomes LLM tokens and help data centers use limited power more efficiently.</a:t>
             </a:r>
           </a:p>
         </p:txBody>
@@ -4454,7 +4489,7 @@
           <p:cNvPr id="4" name="">
             <a:extLst xmlns:a="http://schemas.openxmlformats.org/drawingml/2006/main">
               <a:ext uri="{FF2B5EF4-FFF2-40B4-BE49-F238E27FC236}">
-                <a16:creationId xmlns:a16="http://schemas.microsoft.com/office/drawing/2014/main" id="{CA28B787-B6FD-4FFC-8C74-3C0093456BCF}"/>
+                <a16:creationId xmlns:a16="http://schemas.microsoft.com/office/drawing/2014/main" id="{E531FE47-8FC1-49D1-808D-AD63057D0BAB}"/>
               </a:ext>
             </a:extLst>
           </p:cNvPr>
@@ -4518,6 +4553,7 @@
               </a:defRPr>
             </a:defPPr>
             <a:lvl1pPr>
+              <a:buNone/>
               <a:defRPr sz="1500" b="0">
                 <a:solidFill>
                   <a:srgbClr val="C5CABC"/>
@@ -4528,6 +4564,7 @@
               </a:defRPr>
             </a:lvl1pPr>
             <a:lvl2pPr>
+              <a:buNone/>
               <a:defRPr sz="1500" b="0">
                 <a:solidFill>
                   <a:srgbClr val="C5CABC"/>
@@ -4538,6 +4575,7 @@
               </a:defRPr>
             </a:lvl2pPr>
             <a:lvl3pPr>
+              <a:buNone/>
               <a:defRPr sz="1500" b="0">
                 <a:solidFill>
                   <a:srgbClr val="C5CABC"/>
@@ -4548,6 +4586,7 @@
               </a:defRPr>
             </a:lvl3pPr>
             <a:lvl4pPr>
+              <a:buNone/>
               <a:defRPr sz="1500" b="0">
                 <a:solidFill>
                   <a:srgbClr val="C5CABC"/>
@@ -4558,6 +4597,7 @@
               </a:defRPr>
             </a:lvl4pPr>
             <a:lvl5pPr>
+              <a:buNone/>
               <a:defRPr sz="1500" b="0">
                 <a:solidFill>
                   <a:srgbClr val="C5CABC"/>
@@ -4568,6 +4608,7 @@
               </a:defRPr>
             </a:lvl5pPr>
             <a:lvl6pPr>
+              <a:buNone/>
               <a:defRPr sz="1500" b="0">
                 <a:solidFill>
                   <a:srgbClr val="C5CABC"/>
@@ -4578,6 +4619,7 @@
               </a:defRPr>
             </a:lvl6pPr>
             <a:lvl7pPr>
+              <a:buNone/>
               <a:defRPr sz="1500" b="0">
                 <a:solidFill>
                   <a:srgbClr val="C5CABC"/>
@@ -4588,6 +4630,7 @@
               </a:defRPr>
             </a:lvl7pPr>
             <a:lvl8pPr>
+              <a:buNone/>
               <a:defRPr sz="1500" b="0">
                 <a:solidFill>
                   <a:srgbClr val="C5CABC"/>
@@ -4598,6 +4641,7 @@
               </a:defRPr>
             </a:lvl8pPr>
             <a:lvl9pPr>
+              <a:buNone/>
               <a:defRPr sz="1500" b="0">
                 <a:solidFill>
                   <a:srgbClr val="C5CABC"/>
@@ -4610,6 +4654,7 @@
           </a:lstStyle>
           <a:p xmlns:a="http://schemas.openxmlformats.org/drawingml/2006/main">
             <a:pPr>
+              <a:buNone/>
               <a:defRPr sz="1500" b="0">
                 <a:solidFill>
                   <a:srgbClr val="C5CABC"/>
@@ -4628,7 +4673,7 @@
                 <a:ea typeface="Helvetica Neue"/>
                 <a:cs typeface="Helvetica Neue"/>
               </a:rPr>
-              <a:t>Building the prototype at the hackathon</a:t>
+              <a:t>Team AC/DC at the hackathon.</a:t>
             </a:r>
           </a:p>
         </p:txBody>
@@ -4649,8 +4694,8 @@
         </p:nvSpPr>
         <p:spPr>
           <a:xfrm xmlns:a="http://schemas.openxmlformats.org/drawingml/2006/main">
-            <a:off x="609600" y="6362700"/>
-            <a:ext cx="10668000" cy="285750"/>
+            <a:off x="609600" y="6115050"/>
+            <a:ext cx="10972800" cy="552450"/>
           </a:xfrm>
           <a:prstGeom xmlns:a="http://schemas.openxmlformats.org/drawingml/2006/main" prst="rect">
             <a:avLst/>
@@ -4661,9 +4706,22 @@
           </a:ln>
         </p:spPr>
         <p:txBody>
-          <a:bodyPr xmlns:a="http://schemas.openxmlformats.org/drawingml/2006/main"/>
+          <a:bodyPr xmlns:a="http://schemas.openxmlformats.org/drawingml/2006/main" wrap="square" lIns="85725" tIns="0" rIns="0" bIns="0" anchor="ctr">
+            <a:normAutofit fontScale="100000"/>
+          </a:bodyPr>
           <a:lstStyle xmlns:a="http://schemas.openxmlformats.org/drawingml/2006/main">
-            <a:defPPr>
+            <a:defPPr algn="l">
+              <a:defRPr sz="1800" b="0">
+                <a:solidFill>
+                  <a:srgbClr val="C5CABC"/>
+                </a:solidFill>
+                <a:latin typeface="Helvetica Neue"/>
+                <a:ea typeface="Helvetica Neue"/>
+                <a:cs typeface="Helvetica Neue"/>
+              </a:defRPr>
+            </a:defPPr>
+            <a:lvl1pPr algn="l">
+              <a:buNone/>
               <a:defRPr sz="1350" b="0">
                 <a:solidFill>
                   <a:srgbClr val="C5CABC"/>
@@ -4672,8 +4730,9 @@
                 <a:ea typeface="Helvetica Neue"/>
                 <a:cs typeface="Helvetica Neue"/>
               </a:defRPr>
-            </a:defPPr>
-            <a:lvl1pPr>
+            </a:lvl1pPr>
+            <a:lvl2pPr algn="l">
+              <a:buNone/>
               <a:defRPr sz="1350" b="0">
                 <a:solidFill>
                   <a:srgbClr val="C5CABC"/>
@@ -4682,8 +4741,9 @@
                 <a:ea typeface="Helvetica Neue"/>
                 <a:cs typeface="Helvetica Neue"/>
               </a:defRPr>
-            </a:lvl1pPr>
-            <a:lvl2pPr>
+            </a:lvl2pPr>
+            <a:lvl3pPr algn="l">
+              <a:buNone/>
               <a:defRPr sz="1350" b="0">
                 <a:solidFill>
                   <a:srgbClr val="C5CABC"/>
@@ -4692,8 +4752,9 @@
                 <a:ea typeface="Helvetica Neue"/>
                 <a:cs typeface="Helvetica Neue"/>
               </a:defRPr>
-            </a:lvl2pPr>
-            <a:lvl3pPr>
+            </a:lvl3pPr>
+            <a:lvl4pPr algn="l">
+              <a:buNone/>
               <a:defRPr sz="1350" b="0">
                 <a:solidFill>
                   <a:srgbClr val="C5CABC"/>
@@ -4702,8 +4763,9 @@
                 <a:ea typeface="Helvetica Neue"/>
                 <a:cs typeface="Helvetica Neue"/>
               </a:defRPr>
-            </a:lvl3pPr>
-            <a:lvl4pPr>
+            </a:lvl4pPr>
+            <a:lvl5pPr algn="l">
+              <a:buNone/>
               <a:defRPr sz="1350" b="0">
                 <a:solidFill>
                   <a:srgbClr val="C5CABC"/>
@@ -4712,8 +4774,9 @@
                 <a:ea typeface="Helvetica Neue"/>
                 <a:cs typeface="Helvetica Neue"/>
               </a:defRPr>
-            </a:lvl4pPr>
-            <a:lvl5pPr>
+            </a:lvl5pPr>
+            <a:lvl6pPr algn="l">
+              <a:buNone/>
               <a:defRPr sz="1350" b="0">
                 <a:solidFill>
                   <a:srgbClr val="C5CABC"/>
@@ -4722,8 +4785,9 @@
                 <a:ea typeface="Helvetica Neue"/>
                 <a:cs typeface="Helvetica Neue"/>
               </a:defRPr>
-            </a:lvl5pPr>
-            <a:lvl6pPr>
+            </a:lvl6pPr>
+            <a:lvl7pPr algn="l">
+              <a:buNone/>
               <a:defRPr sz="1350" b="0">
                 <a:solidFill>
                   <a:srgbClr val="C5CABC"/>
@@ -4732,8 +4796,9 @@
                 <a:ea typeface="Helvetica Neue"/>
                 <a:cs typeface="Helvetica Neue"/>
               </a:defRPr>
-            </a:lvl6pPr>
-            <a:lvl7pPr>
+            </a:lvl7pPr>
+            <a:lvl8pPr algn="l">
+              <a:buNone/>
               <a:defRPr sz="1350" b="0">
                 <a:solidFill>
                   <a:srgbClr val="C5CABC"/>
@@ -4742,18 +4807,9 @@
                 <a:ea typeface="Helvetica Neue"/>
                 <a:cs typeface="Helvetica Neue"/>
               </a:defRPr>
-            </a:lvl7pPr>
-            <a:lvl8pPr>
-              <a:defRPr sz="1350" b="0">
-                <a:solidFill>
-                  <a:srgbClr val="C5CABC"/>
-                </a:solidFill>
-                <a:latin typeface="Helvetica Neue"/>
-                <a:ea typeface="Helvetica Neue"/>
-                <a:cs typeface="Helvetica Neue"/>
-              </a:defRPr>
             </a:lvl8pPr>
-            <a:lvl9pPr>
+            <a:lvl9pPr algn="l">
+              <a:buNone/>
               <a:defRPr sz="1350" b="0">
                 <a:solidFill>
                   <a:srgbClr val="C5CABC"/>
@@ -4765,8 +4821,9 @@
             </a:lvl9pPr>
           </a:lstStyle>
           <a:p xmlns:a="http://schemas.openxmlformats.org/drawingml/2006/main">
-            <a:pPr>
-              <a:defRPr sz="1350" b="0">
+            <a:pPr algn="l">
+              <a:buNone/>
+              <a:defRPr sz="1800" b="0">
                 <a:solidFill>
                   <a:srgbClr val="C5CABC"/>
                 </a:solidFill>
@@ -4776,7 +4833,7 @@
               </a:defRPr>
             </a:pPr>
             <a:r>
-              <a:rPr sz="1350" b="0">
+              <a:rPr sz="1800" b="0">
                 <a:solidFill>
                   <a:srgbClr val="C5CABC"/>
                 </a:solidFill>
@@ -4784,7 +4841,166 @@
                 <a:ea typeface="Helvetica Neue"/>
                 <a:cs typeface="Helvetica Neue"/>
               </a:rPr>
-              <a:t>CODE + DEMO + PITCH IN ONE PUBLIC REPOSITORY</a:t>
+              <a:t>Estimate Wh = 116 V AC × current (A) × true PF × run time (h).</a:t>
+            </a:r>
+          </a:p>
+        </p:txBody>
+      </p:sp>
+      <p:sp>
+        <p:nvSpPr>
+          <p:cNvPr id="8" name="Manual batch energy and token comparison">
+            <a:extLst xmlns:a="http://schemas.openxmlformats.org/drawingml/2006/main">
+              <a:ext uri="{FF2B5EF4-FFF2-40B4-BE49-F238E27FC236}">
+                <a16:creationId xmlns:a16="http://schemas.microsoft.com/office/drawing/2014/main" id="{41234268-E101-454B-A169-DF502CE639C4}"/>
+              </a:ext>
+            </a:extLst>
+          </p:cNvPr>
+          <p:cNvSpPr>
+            <a:spLocks xmlns:a="http://schemas.openxmlformats.org/drawingml/2006/main" noGrp="1"/>
+          </p:cNvSpPr>
+          <p:nvPr/>
+        </p:nvSpPr>
+        <p:spPr>
+          <a:xfrm xmlns:a="http://schemas.openxmlformats.org/drawingml/2006/main">
+            <a:off x="609600" y="4572000"/>
+            <a:ext cx="4857750" cy="647700"/>
+          </a:xfrm>
+          <a:prstGeom xmlns:a="http://schemas.openxmlformats.org/drawingml/2006/main" prst="rect">
+            <a:avLst/>
+          </a:prstGeom>
+          <a:noFill xmlns:a="http://schemas.openxmlformats.org/drawingml/2006/main"/>
+          <a:ln xmlns:a="http://schemas.openxmlformats.org/drawingml/2006/main" w="0">
+            <a:noFill/>
+            <a:prstDash val="solid"/>
+          </a:ln>
+        </p:spPr>
+        <p:txBody>
+          <a:bodyPr xmlns:a="http://schemas.openxmlformats.org/drawingml/2006/main" wrap="square" lIns="85725" tIns="0" rIns="0" bIns="0" anchor="t">
+            <a:normAutofit fontScale="100000"/>
+          </a:bodyPr>
+          <a:lstStyle xmlns:a="http://schemas.openxmlformats.org/drawingml/2006/main">
+            <a:defPPr algn="l">
+              <a:defRPr sz="1800">
+                <a:solidFill>
+                  <a:srgbClr val="C5CABC"/>
+                </a:solidFill>
+                <a:latin typeface="Helvetica Neue"/>
+                <a:ea typeface="Helvetica Neue"/>
+                <a:cs typeface="Helvetica Neue"/>
+              </a:defRPr>
+            </a:defPPr>
+            <a:lvl1pPr algn="l">
+              <a:defRPr sz="1800">
+                <a:solidFill>
+                  <a:srgbClr val="C5CABC"/>
+                </a:solidFill>
+                <a:latin typeface="Helvetica Neue"/>
+                <a:ea typeface="Helvetica Neue"/>
+                <a:cs typeface="Helvetica Neue"/>
+              </a:defRPr>
+            </a:lvl1pPr>
+            <a:lvl2pPr algn="l">
+              <a:defRPr sz="1800">
+                <a:solidFill>
+                  <a:srgbClr val="C5CABC"/>
+                </a:solidFill>
+                <a:latin typeface="Helvetica Neue"/>
+                <a:ea typeface="Helvetica Neue"/>
+                <a:cs typeface="Helvetica Neue"/>
+              </a:defRPr>
+            </a:lvl2pPr>
+            <a:lvl3pPr algn="l">
+              <a:defRPr sz="1800">
+                <a:solidFill>
+                  <a:srgbClr val="C5CABC"/>
+                </a:solidFill>
+                <a:latin typeface="Helvetica Neue"/>
+                <a:ea typeface="Helvetica Neue"/>
+                <a:cs typeface="Helvetica Neue"/>
+              </a:defRPr>
+            </a:lvl3pPr>
+            <a:lvl4pPr algn="l">
+              <a:defRPr sz="1800">
+                <a:solidFill>
+                  <a:srgbClr val="C5CABC"/>
+                </a:solidFill>
+                <a:latin typeface="Helvetica Neue"/>
+                <a:ea typeface="Helvetica Neue"/>
+                <a:cs typeface="Helvetica Neue"/>
+              </a:defRPr>
+            </a:lvl4pPr>
+            <a:lvl5pPr algn="l">
+              <a:defRPr sz="1800">
+                <a:solidFill>
+                  <a:srgbClr val="C5CABC"/>
+                </a:solidFill>
+                <a:latin typeface="Helvetica Neue"/>
+                <a:ea typeface="Helvetica Neue"/>
+                <a:cs typeface="Helvetica Neue"/>
+              </a:defRPr>
+            </a:lvl5pPr>
+            <a:lvl6pPr algn="l">
+              <a:defRPr sz="1800">
+                <a:solidFill>
+                  <a:srgbClr val="C5CABC"/>
+                </a:solidFill>
+                <a:latin typeface="Helvetica Neue"/>
+                <a:ea typeface="Helvetica Neue"/>
+                <a:cs typeface="Helvetica Neue"/>
+              </a:defRPr>
+            </a:lvl6pPr>
+            <a:lvl7pPr algn="l">
+              <a:defRPr sz="1800">
+                <a:solidFill>
+                  <a:srgbClr val="C5CABC"/>
+                </a:solidFill>
+                <a:latin typeface="Helvetica Neue"/>
+                <a:ea typeface="Helvetica Neue"/>
+                <a:cs typeface="Helvetica Neue"/>
+              </a:defRPr>
+            </a:lvl7pPr>
+            <a:lvl8pPr algn="l">
+              <a:defRPr sz="1800">
+                <a:solidFill>
+                  <a:srgbClr val="C5CABC"/>
+                </a:solidFill>
+                <a:latin typeface="Helvetica Neue"/>
+                <a:ea typeface="Helvetica Neue"/>
+                <a:cs typeface="Helvetica Neue"/>
+              </a:defRPr>
+            </a:lvl8pPr>
+            <a:lvl9pPr algn="l">
+              <a:defRPr sz="1800">
+                <a:solidFill>
+                  <a:srgbClr val="C5CABC"/>
+                </a:solidFill>
+                <a:latin typeface="Helvetica Neue"/>
+                <a:ea typeface="Helvetica Neue"/>
+                <a:cs typeface="Helvetica Neue"/>
+              </a:defRPr>
+            </a:lvl9pPr>
+          </a:lstStyle>
+          <a:p xmlns:a="http://schemas.openxmlformats.org/drawingml/2006/main">
+            <a:pPr algn="l">
+              <a:defRPr sz="1800">
+                <a:solidFill>
+                  <a:srgbClr val="C5CABC"/>
+                </a:solidFill>
+                <a:latin typeface="Helvetica Neue"/>
+                <a:ea typeface="Helvetica Neue"/>
+                <a:cs typeface="Helvetica Neue"/>
+              </a:defRPr>
+            </a:pPr>
+            <a:r>
+              <a:rPr sz="1800">
+                <a:solidFill>
+                  <a:srgbClr val="C5CABC"/>
+                </a:solidFill>
+                <a:latin typeface="Helvetica Neue"/>
+                <a:ea typeface="Helvetica Neue"/>
+                <a:cs typeface="Helvetica Neue"/>
+              </a:rPr>
+              <a:t>Compare batch energy (Wh) with token output (tokens/kWh).</a:t>
             </a:r>
           </a:p>
         </p:txBody>

</xml_diff>

<commit_message>
Add hackathon measurement trace and update Power per LLM token pitch
</commit_message>
<xml_diff>
--- a/docs/hackathon-pitch.pptx
+++ b/docs/hackathon-pitch.pptx
@@ -9,10 +9,10 @@
   </p:notesMasterIdLst>
   <p:sldIdLst>
     <p:sldId xmlns:r="http://schemas.openxmlformats.org/officeDocument/2006/relationships" id="256" r:id="R660419e85dd74a48"/>
+    <p:sldId xmlns:r="http://schemas.openxmlformats.org/officeDocument/2006/relationships" id="261" r:id="R52456b13680949ee"/>
     <p:sldId xmlns:r="http://schemas.openxmlformats.org/officeDocument/2006/relationships" id="257" r:id="Rfe21568811e04f53"/>
     <p:sldId xmlns:r="http://schemas.openxmlformats.org/officeDocument/2006/relationships" id="258" r:id="R1955cd6be8b14f23"/>
     <p:sldId xmlns:r="http://schemas.openxmlformats.org/officeDocument/2006/relationships" id="259" r:id="Rddb042aa9ef1403a"/>
-    <p:sldId xmlns:r="http://schemas.openxmlformats.org/officeDocument/2006/relationships" id="260" r:id="R98f2572615744b38"/>
   </p:sldIdLst>
   <p:sldSz cx="12192000" cy="6858000"/>
   <p:notesSz cx="6858000" cy="9144000"/>
@@ -446,7 +446,7 @@
           <a:lstStyle xmlns:a="http://schemas.openxmlformats.org/drawingml/2006/main"/>
           <a:p xmlns:a="http://schemas.openxmlformats.org/drawingml/2006/main">
             <a:r>
-              <a:t>Photo supplied by the project owner in this conversation, used without alteration. Prototype scope confirmed by the published browser code: manual input comparison and calculations. The phrase successful AI task corresponds to a task passing a fixed quality acceptance test. No physical measurement, energy savings, customer adoption or GPU integration is claimed. Repository: https://github.com/maxchamp2005-sudo/llm-energy-efficiency</a:t>
+              <a:t>Photo supplied by the project owner in this conversation, used without alteration. The published browser code provides manual-input comparisons and calculations. The phrase successful AI task corresponds to a task passing a fixed quality acceptance test. Slide 2 shows a user-supplied UT61B apparent-power trace from the reported completed local Gemma 4 GPU test; it does not show true PF, Wh, token counts, or energy per token. No energy savings, customer adoption, or GPU integration is claimed. Repository: https://github.com/maxchamp2005-sudo/llm-energy-efficiency</a:t>
             </a:r>
           </a:p>
         </p:txBody>
@@ -686,7 +686,7 @@
 </p:notes>
 </file>
 
-<file path=ppt/notesSlides/notesSlide5.xml><?xml version="1.0" encoding="utf-8"?>
+<file path=ppt/notesSlides/notesSlide6.xml><?xml version="1.0" encoding="utf-8"?>
 <p:notes xmlns:p="http://schemas.openxmlformats.org/presentationml/2006/main">
   <p:cSld>
     <p:spTree>
@@ -726,7 +726,22 @@
           <a:lstStyle xmlns:a="http://schemas.openxmlformats.org/drawingml/2006/main"/>
           <a:p xmlns:a="http://schemas.openxmlformats.org/drawingml/2006/main">
             <a:r>
-              <a:t>Next-step measurement plan, not completed integration. The team photo documents the hackathon working context, not a measurement result. Use a suitable real-power/energy instrument at the agreed supply boundary and synchronized task logs; include idle, failures and retries in batch energy. Keep nested GPU energy separate from whole-system supply energy to prevent double counting. A clamp current measurement alone is insufficient to establish real watts or watt-hours without voltage, true PF or simultaneous waveforms and integration. Repeatability, collector overhead and uncertainty need to be evaluated. Existing published prototype and five-slide deck: https://github.com/maxchamp2005-sudo/llm-energy-efficiency .</a:t>
+              <a:t>User-supplied raster source figure: PHOTO-2026-10-17-16-11-41.jpg.</a:t>
+            </a:r>
+          </a:p>
+          <a:p xmlns:a="http://schemas.openxmlformats.org/drawingml/2006/main">
+            <a:r>
+              <a:t>The user reports this figure came from a completed local Gemma 4 GPU test using a USB-connected UT61B. The plotted series is labeled apparent power (VA) at 116 V RMS over elapsed time.</a:t>
+            </a:r>
+          </a:p>
+          <a:p xmlns:a="http://schemas.openxmlformats.org/drawingml/2006/main">
+            <a:r>
+              <a:t>Apparent power is not real power or cumulative energy. The figure supplies no true power factor, raw samples, token counts, workload boundary, or synchronized timing. It does not support a real-power or Wh result, energy per token, tokens per kWh, or an energy-savings claim.</a:t>
+            </a:r>
+          </a:p>
+          <a:p xmlns:a="http://schemas.openxmlformats.org/drawingml/2006/main">
+            <a:r>
+              <a:t>The supplied figure is displayed as-is without redrawing or digitizing its trace.</a:t>
             </a:r>
           </a:p>
         </p:txBody>
@@ -4287,7 +4302,7 @@
                 <a:ea typeface="Helvetica Neue"/>
                 <a:cs typeface="Helvetica Neue"/>
               </a:rPr>
-              <a:t>Measuring electricity</a:t>
+              <a:t>Measuring Power</a:t>
             </a:r>
           </a:p>
           <a:p xmlns:a="http://schemas.openxmlformats.org/drawingml/2006/main">
@@ -5497,7 +5512,7 @@
                 <a:ea typeface="Helvetica Neue"/>
                 <a:cs typeface="Helvetica Neue"/>
               </a:rPr>
-              <a:t>AI ENERGY AUDIT · HACKATHON PROTOTYPE</a:t>
+              <a:t>TEAM AC/DC · HACKATHON PROJECT</a:t>
             </a:r>
           </a:p>
         </p:txBody>
@@ -5653,7 +5668,7 @@
                 <a:ea typeface="Helvetica Neue"/>
                 <a:cs typeface="Helvetica Neue"/>
               </a:rPr>
-              <a:t>2 / 5</a:t>
+              <a:t>3 / 5</a:t>
             </a:r>
           </a:p>
         </p:txBody>
@@ -6952,7 +6967,7 @@
                 <a:ea typeface="Helvetica Neue"/>
                 <a:cs typeface="Helvetica Neue"/>
               </a:rPr>
-              <a:t>AI ENERGY AUDIT · HACKATHON PROTOTYPE</a:t>
+              <a:t>TEAM AC/DC · HACKATHON PROJECT</a:t>
             </a:r>
           </a:p>
         </p:txBody>
@@ -7108,7 +7123,7 @@
                 <a:ea typeface="Helvetica Neue"/>
                 <a:cs typeface="Helvetica Neue"/>
               </a:rPr>
-              <a:t>3 / 5</a:t>
+              <a:t>4 / 5</a:t>
             </a:r>
           </a:p>
         </p:txBody>
@@ -8697,7 +8712,7 @@
                 <a:ea typeface="Helvetica Neue"/>
                 <a:cs typeface="Helvetica Neue"/>
               </a:rPr>
-              <a:t>AI ENERGY AUDIT · HACKATHON PROTOTYPE</a:t>
+              <a:t>TEAM AC/DC · HACKATHON PROJECT</a:t>
             </a:r>
           </a:p>
         </p:txBody>
@@ -8853,7 +8868,7 @@
                 <a:ea typeface="Helvetica Neue"/>
                 <a:cs typeface="Helvetica Neue"/>
               </a:rPr>
-              <a:t>4 / 5</a:t>
+              <a:t>5 / 5</a:t>
             </a:r>
           </a:p>
         </p:txBody>
@@ -9804,7 +9819,7 @@
 </p:sld>
 </file>
 
-<file path=ppt/slides/slide5.xml><?xml version="1.0" encoding="utf-8"?>
+<file path=ppt/slides/slide6.xml><?xml version="1.0" encoding="utf-8"?>
 <p:sld xmlns:p="http://schemas.openxmlformats.org/presentationml/2006/main">
   <p:cSld>
     <p:bg>
@@ -9825,10 +9840,10 @@
       </p:grpSpPr>
       <p:sp>
         <p:nvSpPr>
-          <p:cNvPr id="12" name="">
+          <p:cNvPr id="6" name="Run context">
             <a:extLst xmlns:a="http://schemas.openxmlformats.org/drawingml/2006/main">
               <a:ext uri="{FF2B5EF4-FFF2-40B4-BE49-F238E27FC236}">
-                <a16:creationId xmlns:a16="http://schemas.microsoft.com/office/drawing/2014/main" id="{E7C050CB-71CE-4FA6-93EE-5F7E71007803}"/>
+                <a16:creationId xmlns:a16="http://schemas.microsoft.com/office/drawing/2014/main" id="{B7F2DF59-AADF-490E-92AB-79903E847F86}"/>
               </a:ext>
             </a:extLst>
           </p:cNvPr>
@@ -9839,8 +9854,8 @@
         </p:nvSpPr>
         <p:spPr>
           <a:xfrm xmlns:a="http://schemas.openxmlformats.org/drawingml/2006/main">
-            <a:off x="609600" y="400050"/>
-            <a:ext cx="10972800" cy="323850"/>
+            <a:off x="609600" y="371475"/>
+            <a:ext cx="10972800" cy="285750"/>
           </a:xfrm>
           <a:prstGeom xmlns:a="http://schemas.openxmlformats.org/drawingml/2006/main" prst="rect">
             <a:avLst/>
@@ -9848,13 +9863,16 @@
           <a:noFill xmlns:a="http://schemas.openxmlformats.org/drawingml/2006/main"/>
           <a:ln xmlns:a="http://schemas.openxmlformats.org/drawingml/2006/main" w="0">
             <a:noFill/>
+            <a:prstDash val="solid"/>
           </a:ln>
         </p:spPr>
         <p:txBody>
-          <a:bodyPr xmlns:a="http://schemas.openxmlformats.org/drawingml/2006/main"/>
+          <a:bodyPr xmlns:a="http://schemas.openxmlformats.org/drawingml/2006/main" wrap="square" lIns="85725" tIns="0" rIns="0" bIns="0" anchor="t">
+            <a:normAutofit fontScale="100000"/>
+          </a:bodyPr>
           <a:lstStyle xmlns:a="http://schemas.openxmlformats.org/drawingml/2006/main">
-            <a:defPPr>
-              <a:defRPr sz="1425" b="1">
+            <a:defPPr algn="l">
+              <a:defRPr sz="1350" b="1">
                 <a:solidFill>
                   <a:srgbClr val="D8B44E"/>
                 </a:solidFill>
@@ -9863,8 +9881,8 @@
                 <a:cs typeface="Helvetica Neue"/>
               </a:defRPr>
             </a:defPPr>
-            <a:lvl1pPr>
-              <a:defRPr sz="1425" b="1">
+            <a:lvl1pPr algn="l">
+              <a:defRPr sz="1350" b="1">
                 <a:solidFill>
                   <a:srgbClr val="D8B44E"/>
                 </a:solidFill>
@@ -9873,8 +9891,8 @@
                 <a:cs typeface="Helvetica Neue"/>
               </a:defRPr>
             </a:lvl1pPr>
-            <a:lvl2pPr>
-              <a:defRPr sz="1425" b="1">
+            <a:lvl2pPr algn="l">
+              <a:defRPr sz="1350" b="1">
                 <a:solidFill>
                   <a:srgbClr val="D8B44E"/>
                 </a:solidFill>
@@ -9883,8 +9901,8 @@
                 <a:cs typeface="Helvetica Neue"/>
               </a:defRPr>
             </a:lvl2pPr>
-            <a:lvl3pPr>
-              <a:defRPr sz="1425" b="1">
+            <a:lvl3pPr algn="l">
+              <a:defRPr sz="1350" b="1">
                 <a:solidFill>
                   <a:srgbClr val="D8B44E"/>
                 </a:solidFill>
@@ -9893,8 +9911,8 @@
                 <a:cs typeface="Helvetica Neue"/>
               </a:defRPr>
             </a:lvl3pPr>
-            <a:lvl4pPr>
-              <a:defRPr sz="1425" b="1">
+            <a:lvl4pPr algn="l">
+              <a:defRPr sz="1350" b="1">
                 <a:solidFill>
                   <a:srgbClr val="D8B44E"/>
                 </a:solidFill>
@@ -9903,8 +9921,8 @@
                 <a:cs typeface="Helvetica Neue"/>
               </a:defRPr>
             </a:lvl4pPr>
-            <a:lvl5pPr>
-              <a:defRPr sz="1425" b="1">
+            <a:lvl5pPr algn="l">
+              <a:defRPr sz="1350" b="1">
                 <a:solidFill>
                   <a:srgbClr val="D8B44E"/>
                 </a:solidFill>
@@ -9913,8 +9931,8 @@
                 <a:cs typeface="Helvetica Neue"/>
               </a:defRPr>
             </a:lvl5pPr>
-            <a:lvl6pPr>
-              <a:defRPr sz="1425" b="1">
+            <a:lvl6pPr algn="l">
+              <a:defRPr sz="1350" b="1">
                 <a:solidFill>
                   <a:srgbClr val="D8B44E"/>
                 </a:solidFill>
@@ -9923,8 +9941,8 @@
                 <a:cs typeface="Helvetica Neue"/>
               </a:defRPr>
             </a:lvl6pPr>
-            <a:lvl7pPr>
-              <a:defRPr sz="1425" b="1">
+            <a:lvl7pPr algn="l">
+              <a:defRPr sz="1350" b="1">
                 <a:solidFill>
                   <a:srgbClr val="D8B44E"/>
                 </a:solidFill>
@@ -9933,8 +9951,8 @@
                 <a:cs typeface="Helvetica Neue"/>
               </a:defRPr>
             </a:lvl7pPr>
-            <a:lvl8pPr>
-              <a:defRPr sz="1425" b="1">
+            <a:lvl8pPr algn="l">
+              <a:defRPr sz="1350" b="1">
                 <a:solidFill>
                   <a:srgbClr val="D8B44E"/>
                 </a:solidFill>
@@ -9943,8 +9961,8 @@
                 <a:cs typeface="Helvetica Neue"/>
               </a:defRPr>
             </a:lvl8pPr>
-            <a:lvl9pPr>
-              <a:defRPr sz="1425" b="1">
+            <a:lvl9pPr algn="l">
+              <a:defRPr sz="1350" b="1">
                 <a:solidFill>
                   <a:srgbClr val="D8B44E"/>
                 </a:solidFill>
@@ -9955,8 +9973,8 @@
             </a:lvl9pPr>
           </a:lstStyle>
           <a:p xmlns:a="http://schemas.openxmlformats.org/drawingml/2006/main">
-            <a:pPr>
-              <a:defRPr sz="1425" b="1">
+            <a:pPr algn="l">
+              <a:defRPr sz="1350" b="1">
                 <a:solidFill>
                   <a:srgbClr val="D8B44E"/>
                 </a:solidFill>
@@ -9966,7 +9984,7 @@
               </a:defRPr>
             </a:pPr>
             <a:r>
-              <a:rPr sz="1425" b="1">
+              <a:rPr sz="1350" b="1">
                 <a:solidFill>
                   <a:srgbClr val="D8B44E"/>
                 </a:solidFill>
@@ -9974,17 +9992,17 @@
                 <a:ea typeface="Helvetica Neue"/>
                 <a:cs typeface="Helvetica Neue"/>
               </a:rPr>
-              <a:t>NEXT VALIDATION</a:t>
+              <a:t>COMPLETED LOCAL GEMMA 4 GPU TEST</a:t>
             </a:r>
           </a:p>
         </p:txBody>
       </p:sp>
       <p:sp>
         <p:nvSpPr>
-          <p:cNvPr id="2" name="">
+          <p:cNvPr id="2" name="Slide title">
             <a:extLst xmlns:a="http://schemas.openxmlformats.org/drawingml/2006/main">
               <a:ext uri="{FF2B5EF4-FFF2-40B4-BE49-F238E27FC236}">
-                <a16:creationId xmlns:a16="http://schemas.microsoft.com/office/drawing/2014/main" id="{0D7481D0-C55B-4909-825D-006E2AAA29DF}"/>
+                <a16:creationId xmlns:a16="http://schemas.microsoft.com/office/drawing/2014/main" id="{7672F991-48AE-4703-BE36-B9EEBFD5011A}"/>
               </a:ext>
             </a:extLst>
           </p:cNvPr>
@@ -9995,8 +10013,8 @@
         </p:nvSpPr>
         <p:spPr>
           <a:xfrm xmlns:a="http://schemas.openxmlformats.org/drawingml/2006/main">
-            <a:off x="609600" y="1000125"/>
-            <a:ext cx="10972800" cy="1314450"/>
+            <a:off x="609600" y="771525"/>
+            <a:ext cx="10972800" cy="514350"/>
           </a:xfrm>
           <a:prstGeom xmlns:a="http://schemas.openxmlformats.org/drawingml/2006/main" prst="rect">
             <a:avLst/>
@@ -10004,13 +10022,16 @@
           <a:noFill xmlns:a="http://schemas.openxmlformats.org/drawingml/2006/main"/>
           <a:ln xmlns:a="http://schemas.openxmlformats.org/drawingml/2006/main" w="0">
             <a:noFill/>
+            <a:prstDash val="solid"/>
           </a:ln>
         </p:spPr>
         <p:txBody>
-          <a:bodyPr xmlns:a="http://schemas.openxmlformats.org/drawingml/2006/main"/>
+          <a:bodyPr xmlns:a="http://schemas.openxmlformats.org/drawingml/2006/main" wrap="square" lIns="85725" tIns="0" rIns="0" bIns="0" anchor="t">
+            <a:normAutofit fontScale="100000"/>
+          </a:bodyPr>
           <a:lstStyle xmlns:a="http://schemas.openxmlformats.org/drawingml/2006/main">
-            <a:defPPr>
-              <a:defRPr sz="4050" b="0">
+            <a:defPPr algn="l">
+              <a:defRPr sz="3150" b="1">
                 <a:solidFill>
                   <a:srgbClr val="F2F0E5"/>
                 </a:solidFill>
@@ -10019,8 +10040,8 @@
                 <a:cs typeface="Helvetica Neue"/>
               </a:defRPr>
             </a:defPPr>
-            <a:lvl1pPr>
-              <a:defRPr sz="4050" b="0">
+            <a:lvl1pPr algn="l">
+              <a:defRPr sz="3150" b="1">
                 <a:solidFill>
                   <a:srgbClr val="F2F0E5"/>
                 </a:solidFill>
@@ -10029,8 +10050,8 @@
                 <a:cs typeface="Helvetica Neue"/>
               </a:defRPr>
             </a:lvl1pPr>
-            <a:lvl2pPr>
-              <a:defRPr sz="4050" b="0">
+            <a:lvl2pPr algn="l">
+              <a:defRPr sz="3150" b="1">
                 <a:solidFill>
                   <a:srgbClr val="F2F0E5"/>
                 </a:solidFill>
@@ -10039,8 +10060,8 @@
                 <a:cs typeface="Helvetica Neue"/>
               </a:defRPr>
             </a:lvl2pPr>
-            <a:lvl3pPr>
-              <a:defRPr sz="4050" b="0">
+            <a:lvl3pPr algn="l">
+              <a:defRPr sz="3150" b="1">
                 <a:solidFill>
                   <a:srgbClr val="F2F0E5"/>
                 </a:solidFill>
@@ -10049,8 +10070,8 @@
                 <a:cs typeface="Helvetica Neue"/>
               </a:defRPr>
             </a:lvl3pPr>
-            <a:lvl4pPr>
-              <a:defRPr sz="4050" b="0">
+            <a:lvl4pPr algn="l">
+              <a:defRPr sz="3150" b="1">
                 <a:solidFill>
                   <a:srgbClr val="F2F0E5"/>
                 </a:solidFill>
@@ -10059,8 +10080,8 @@
                 <a:cs typeface="Helvetica Neue"/>
               </a:defRPr>
             </a:lvl4pPr>
-            <a:lvl5pPr>
-              <a:defRPr sz="4050" b="0">
+            <a:lvl5pPr algn="l">
+              <a:defRPr sz="3150" b="1">
                 <a:solidFill>
                   <a:srgbClr val="F2F0E5"/>
                 </a:solidFill>
@@ -10069,8 +10090,8 @@
                 <a:cs typeface="Helvetica Neue"/>
               </a:defRPr>
             </a:lvl5pPr>
-            <a:lvl6pPr>
-              <a:defRPr sz="4050" b="0">
+            <a:lvl6pPr algn="l">
+              <a:defRPr sz="3150" b="1">
                 <a:solidFill>
                   <a:srgbClr val="F2F0E5"/>
                 </a:solidFill>
@@ -10079,8 +10100,8 @@
                 <a:cs typeface="Helvetica Neue"/>
               </a:defRPr>
             </a:lvl6pPr>
-            <a:lvl7pPr>
-              <a:defRPr sz="4050" b="0">
+            <a:lvl7pPr algn="l">
+              <a:defRPr sz="3150" b="1">
                 <a:solidFill>
                   <a:srgbClr val="F2F0E5"/>
                 </a:solidFill>
@@ -10089,8 +10110,8 @@
                 <a:cs typeface="Helvetica Neue"/>
               </a:defRPr>
             </a:lvl7pPr>
-            <a:lvl8pPr>
-              <a:defRPr sz="4050" b="0">
+            <a:lvl8pPr algn="l">
+              <a:defRPr sz="3150" b="1">
                 <a:solidFill>
                   <a:srgbClr val="F2F0E5"/>
                 </a:solidFill>
@@ -10099,8 +10120,8 @@
                 <a:cs typeface="Helvetica Neue"/>
               </a:defRPr>
             </a:lvl8pPr>
-            <a:lvl9pPr>
-              <a:defRPr sz="4050" b="0">
+            <a:lvl9pPr algn="l">
+              <a:defRPr sz="3150" b="1">
                 <a:solidFill>
                   <a:srgbClr val="F2F0E5"/>
                 </a:solidFill>
@@ -10111,8 +10132,8 @@
             </a:lvl9pPr>
           </a:lstStyle>
           <a:p xmlns:a="http://schemas.openxmlformats.org/drawingml/2006/main">
-            <a:pPr>
-              <a:defRPr sz="4050" b="0">
+            <a:pPr algn="l">
+              <a:defRPr sz="3150" b="1">
                 <a:solidFill>
                   <a:srgbClr val="F2F0E5"/>
                 </a:solidFill>
@@ -10122,7 +10143,7 @@
               </a:defRPr>
             </a:pPr>
             <a:r>
-              <a:rPr sz="4050" b="0">
+              <a:rPr sz="3150" b="1">
                 <a:solidFill>
                   <a:srgbClr val="F2F0E5"/>
                 </a:solidFill>
@@ -10130,17 +10151,45 @@
                 <a:ea typeface="Helvetica Neue"/>
                 <a:cs typeface="Helvetica Neue"/>
               </a:rPr>
-              <a:t>Test on the actual system</a:t>
+              <a:t>UT61B apparent-power trace</a:t>
             </a:r>
           </a:p>
         </p:txBody>
       </p:sp>
-      <p:sp>
-        <p:nvSpPr>
+      <p:pic>
+        <p:nvPicPr>
           <p:cNvPr id="3" name="">
             <a:extLst xmlns:a="http://schemas.openxmlformats.org/drawingml/2006/main">
               <a:ext uri="{FF2B5EF4-FFF2-40B4-BE49-F238E27FC236}">
-                <a16:creationId xmlns:a16="http://schemas.microsoft.com/office/drawing/2014/main" id="{4B05C233-F52D-44A6-A7AC-3E443323AEE2}"/>
+                <a16:creationId xmlns:a16="http://schemas.microsoft.com/office/drawing/2014/main" id="{C8DD6927-ED88-45FE-8B54-DDC6F7793A5C}"/>
+              </a:ext>
+            </a:extLst>
+          </p:cNvPr>
+          <p:cNvPicPr>
+            <a:picLocks xmlns:a="http://schemas.openxmlformats.org/drawingml/2006/main" noChangeAspect="1"/>
+          </p:cNvPicPr>
+          <p:nvPr/>
+        </p:nvPicPr>
+        <p:blipFill>
+          <a:blip xmlns:r="http://schemas.openxmlformats.org/officeDocument/2006/relationships" xmlns:a="http://schemas.openxmlformats.org/drawingml/2006/main" r:embed="R67377863c75a4476"/>
+          <a:stretch xmlns:a="http://schemas.openxmlformats.org/drawingml/2006/main"/>
+        </p:blipFill>
+        <p:spPr>
+          <a:xfrm xmlns:a="http://schemas.openxmlformats.org/drawingml/2006/main">
+            <a:off x="613137" y="1409700"/>
+            <a:ext cx="10965725" cy="4429125"/>
+          </a:xfrm>
+          <a:prstGeom xmlns:a="http://schemas.openxmlformats.org/drawingml/2006/main" prst="rect">
+            <a:avLst/>
+          </a:prstGeom>
+        </p:spPr>
+      </p:pic>
+      <p:sp>
+        <p:nvSpPr>
+          <p:cNvPr id="4" name="Power relationship">
+            <a:extLst xmlns:a="http://schemas.openxmlformats.org/drawingml/2006/main">
+              <a:ext uri="{FF2B5EF4-FFF2-40B4-BE49-F238E27FC236}">
+                <a16:creationId xmlns:a16="http://schemas.microsoft.com/office/drawing/2014/main" id="{ECDE03C1-C725-41C8-9CE2-AE3B82850238}"/>
               </a:ext>
             </a:extLst>
           </p:cNvPr>
@@ -10151,8 +10200,8 @@
         </p:nvSpPr>
         <p:spPr>
           <a:xfrm xmlns:a="http://schemas.openxmlformats.org/drawingml/2006/main">
-            <a:off x="609600" y="6362700"/>
-            <a:ext cx="10001250" cy="266700"/>
+            <a:off x="609600" y="5934075"/>
+            <a:ext cx="10972800" cy="257175"/>
           </a:xfrm>
           <a:prstGeom xmlns:a="http://schemas.openxmlformats.org/drawingml/2006/main" prst="rect">
             <a:avLst/>
@@ -10160,105 +10209,108 @@
           <a:noFill xmlns:a="http://schemas.openxmlformats.org/drawingml/2006/main"/>
           <a:ln xmlns:a="http://schemas.openxmlformats.org/drawingml/2006/main" w="0">
             <a:noFill/>
+            <a:prstDash val="solid"/>
           </a:ln>
         </p:spPr>
         <p:txBody>
-          <a:bodyPr xmlns:a="http://schemas.openxmlformats.org/drawingml/2006/main"/>
+          <a:bodyPr xmlns:a="http://schemas.openxmlformats.org/drawingml/2006/main" wrap="square" lIns="85725" tIns="0" rIns="0" bIns="0" anchor="t">
+            <a:normAutofit fontScale="100000"/>
+          </a:bodyPr>
           <a:lstStyle xmlns:a="http://schemas.openxmlformats.org/drawingml/2006/main">
-            <a:defPPr>
-              <a:defRPr sz="1350" b="0">
-                <a:solidFill>
-                  <a:srgbClr val="C5CABC"/>
+            <a:defPPr algn="l">
+              <a:defRPr sz="1350">
+                <a:solidFill>
+                  <a:srgbClr val="F2F0E5"/>
                 </a:solidFill>
                 <a:latin typeface="Helvetica Neue"/>
                 <a:ea typeface="Helvetica Neue"/>
                 <a:cs typeface="Helvetica Neue"/>
               </a:defRPr>
             </a:defPPr>
-            <a:lvl1pPr>
-              <a:defRPr sz="1350" b="0">
-                <a:solidFill>
-                  <a:srgbClr val="C5CABC"/>
+            <a:lvl1pPr algn="l">
+              <a:defRPr sz="1350">
+                <a:solidFill>
+                  <a:srgbClr val="F2F0E5"/>
                 </a:solidFill>
                 <a:latin typeface="Helvetica Neue"/>
                 <a:ea typeface="Helvetica Neue"/>
                 <a:cs typeface="Helvetica Neue"/>
               </a:defRPr>
             </a:lvl1pPr>
-            <a:lvl2pPr>
-              <a:defRPr sz="1350" b="0">
-                <a:solidFill>
-                  <a:srgbClr val="C5CABC"/>
+            <a:lvl2pPr algn="l">
+              <a:defRPr sz="1350">
+                <a:solidFill>
+                  <a:srgbClr val="F2F0E5"/>
                 </a:solidFill>
                 <a:latin typeface="Helvetica Neue"/>
                 <a:ea typeface="Helvetica Neue"/>
                 <a:cs typeface="Helvetica Neue"/>
               </a:defRPr>
             </a:lvl2pPr>
-            <a:lvl3pPr>
-              <a:defRPr sz="1350" b="0">
-                <a:solidFill>
-                  <a:srgbClr val="C5CABC"/>
+            <a:lvl3pPr algn="l">
+              <a:defRPr sz="1350">
+                <a:solidFill>
+                  <a:srgbClr val="F2F0E5"/>
                 </a:solidFill>
                 <a:latin typeface="Helvetica Neue"/>
                 <a:ea typeface="Helvetica Neue"/>
                 <a:cs typeface="Helvetica Neue"/>
               </a:defRPr>
             </a:lvl3pPr>
-            <a:lvl4pPr>
-              <a:defRPr sz="1350" b="0">
-                <a:solidFill>
-                  <a:srgbClr val="C5CABC"/>
+            <a:lvl4pPr algn="l">
+              <a:defRPr sz="1350">
+                <a:solidFill>
+                  <a:srgbClr val="F2F0E5"/>
                 </a:solidFill>
                 <a:latin typeface="Helvetica Neue"/>
                 <a:ea typeface="Helvetica Neue"/>
                 <a:cs typeface="Helvetica Neue"/>
               </a:defRPr>
             </a:lvl4pPr>
-            <a:lvl5pPr>
-              <a:defRPr sz="1350" b="0">
-                <a:solidFill>
-                  <a:srgbClr val="C5CABC"/>
+            <a:lvl5pPr algn="l">
+              <a:defRPr sz="1350">
+                <a:solidFill>
+                  <a:srgbClr val="F2F0E5"/>
                 </a:solidFill>
                 <a:latin typeface="Helvetica Neue"/>
                 <a:ea typeface="Helvetica Neue"/>
                 <a:cs typeface="Helvetica Neue"/>
               </a:defRPr>
             </a:lvl5pPr>
-            <a:lvl6pPr>
-              <a:defRPr sz="1350" b="0">
-                <a:solidFill>
-                  <a:srgbClr val="C5CABC"/>
+            <a:lvl6pPr algn="l">
+              <a:defRPr sz="1350">
+                <a:solidFill>
+                  <a:srgbClr val="F2F0E5"/>
                 </a:solidFill>
                 <a:latin typeface="Helvetica Neue"/>
                 <a:ea typeface="Helvetica Neue"/>
                 <a:cs typeface="Helvetica Neue"/>
               </a:defRPr>
             </a:lvl6pPr>
-            <a:lvl7pPr>
-              <a:defRPr sz="1350" b="0">
-                <a:solidFill>
-                  <a:srgbClr val="C5CABC"/>
+            <a:lvl7pPr algn="l">
+              <a:defRPr sz="1350">
+                <a:solidFill>
+                  <a:srgbClr val="F2F0E5"/>
                 </a:solidFill>
                 <a:latin typeface="Helvetica Neue"/>
                 <a:ea typeface="Helvetica Neue"/>
                 <a:cs typeface="Helvetica Neue"/>
               </a:defRPr>
             </a:lvl7pPr>
-            <a:lvl8pPr>
-              <a:defRPr sz="1350" b="0">
-                <a:solidFill>
-                  <a:srgbClr val="C5CABC"/>
+            <a:lvl8pPr algn="l">
+              <a:defRPr sz="1350">
+                <a:solidFill>
+                  <a:srgbClr val="F2F0E5"/>
                 </a:solidFill>
                 <a:latin typeface="Helvetica Neue"/>
                 <a:ea typeface="Helvetica Neue"/>
                 <a:cs typeface="Helvetica Neue"/>
               </a:defRPr>
             </a:lvl8pPr>
-            <a:lvl9pPr>
-              <a:defRPr sz="1350" b="0">
-                <a:solidFill>
-                  <a:srgbClr val="C5CABC"/>
+            <a:lvl9pPr algn="l">
+              <a:defRPr sz="1350">
+                <a:solidFill>
+                  <a:srgbClr val="F2F0E5"/>
                 </a:solidFill>
                 <a:latin typeface="Helvetica Neue"/>
                 <a:ea typeface="Helvetica Neue"/>
@@ -10267,10 +10319,10 @@
             </a:lvl9pPr>
           </a:lstStyle>
           <a:p xmlns:a="http://schemas.openxmlformats.org/drawingml/2006/main">
-            <a:pPr>
-              <a:defRPr sz="1350" b="0">
-                <a:solidFill>
-                  <a:srgbClr val="C5CABC"/>
+            <a:pPr algn="l">
+              <a:defRPr sz="1350">
+                <a:solidFill>
+                  <a:srgbClr val="F2F0E5"/>
                 </a:solidFill>
                 <a:latin typeface="Helvetica Neue"/>
                 <a:ea typeface="Helvetica Neue"/>
@@ -10278,25 +10330,25 @@
               </a:defRPr>
             </a:pPr>
             <a:r>
-              <a:rPr sz="1350" b="0">
-                <a:solidFill>
-                  <a:srgbClr val="C5CABC"/>
+              <a:rPr sz="1350">
+                <a:solidFill>
+                  <a:srgbClr val="F2F0E5"/>
                 </a:solidFill>
                 <a:latin typeface="Helvetica Neue"/>
                 <a:ea typeface="Helvetica Neue"/>
                 <a:cs typeface="Helvetica Neue"/>
               </a:rPr>
-              <a:t>AI ENERGY AUDIT · HACKATHON PROTOTYPE</a:t>
+              <a:t>Apparent power (VA) at 116 V RMS. Real power (W) = apparent power (VA) × true PF.</a:t>
             </a:r>
           </a:p>
         </p:txBody>
       </p:sp>
       <p:sp>
         <p:nvSpPr>
-          <p:cNvPr id="4" name="">
+          <p:cNvPr id="5" name="Source figure limitation">
             <a:extLst xmlns:a="http://schemas.openxmlformats.org/drawingml/2006/main">
               <a:ext uri="{FF2B5EF4-FFF2-40B4-BE49-F238E27FC236}">
-                <a16:creationId xmlns:a16="http://schemas.microsoft.com/office/drawing/2014/main" id="{8959E559-EC8B-4BB7-AA83-76186B5C4CE8}"/>
+                <a16:creationId xmlns:a16="http://schemas.microsoft.com/office/drawing/2014/main" id="{53EC50F9-2950-42AE-BBC4-B1A3F3E9874D}"/>
               </a:ext>
             </a:extLst>
           </p:cNvPr>
@@ -10307,8 +10359,8 @@
         </p:nvSpPr>
         <p:spPr>
           <a:xfrm xmlns:a="http://schemas.openxmlformats.org/drawingml/2006/main">
-            <a:off x="10858500" y="6362700"/>
-            <a:ext cx="762000" cy="266700"/>
+            <a:off x="609600" y="6257925"/>
+            <a:ext cx="10972800" cy="228600"/>
           </a:xfrm>
           <a:prstGeom xmlns:a="http://schemas.openxmlformats.org/drawingml/2006/main" prst="rect">
             <a:avLst/>
@@ -10316,13 +10368,16 @@
           <a:noFill xmlns:a="http://schemas.openxmlformats.org/drawingml/2006/main"/>
           <a:ln xmlns:a="http://schemas.openxmlformats.org/drawingml/2006/main" w="0">
             <a:noFill/>
+            <a:prstDash val="solid"/>
           </a:ln>
         </p:spPr>
         <p:txBody>
-          <a:bodyPr xmlns:a="http://schemas.openxmlformats.org/drawingml/2006/main"/>
+          <a:bodyPr xmlns:a="http://schemas.openxmlformats.org/drawingml/2006/main" wrap="square" lIns="85725" tIns="0" rIns="0" bIns="0" anchor="t">
+            <a:normAutofit fontScale="100000"/>
+          </a:bodyPr>
           <a:lstStyle xmlns:a="http://schemas.openxmlformats.org/drawingml/2006/main">
-            <a:defPPr>
-              <a:defRPr sz="1350" b="0">
+            <a:defPPr algn="l">
+              <a:defRPr sz="1125">
                 <a:solidFill>
                   <a:srgbClr val="C5CABC"/>
                 </a:solidFill>
@@ -10331,8 +10386,8 @@
                 <a:cs typeface="Helvetica Neue"/>
               </a:defRPr>
             </a:defPPr>
-            <a:lvl1pPr>
-              <a:defRPr sz="1350" b="0">
+            <a:lvl1pPr algn="l">
+              <a:defRPr sz="1125">
                 <a:solidFill>
                   <a:srgbClr val="C5CABC"/>
                 </a:solidFill>
@@ -10341,8 +10396,8 @@
                 <a:cs typeface="Helvetica Neue"/>
               </a:defRPr>
             </a:lvl1pPr>
-            <a:lvl2pPr>
-              <a:defRPr sz="1350" b="0">
+            <a:lvl2pPr algn="l">
+              <a:defRPr sz="1125">
                 <a:solidFill>
                   <a:srgbClr val="C5CABC"/>
                 </a:solidFill>
@@ -10351,8 +10406,8 @@
                 <a:cs typeface="Helvetica Neue"/>
               </a:defRPr>
             </a:lvl2pPr>
-            <a:lvl3pPr>
-              <a:defRPr sz="1350" b="0">
+            <a:lvl3pPr algn="l">
+              <a:defRPr sz="1125">
                 <a:solidFill>
                   <a:srgbClr val="C5CABC"/>
                 </a:solidFill>
@@ -10361,8 +10416,8 @@
                 <a:cs typeface="Helvetica Neue"/>
               </a:defRPr>
             </a:lvl3pPr>
-            <a:lvl4pPr>
-              <a:defRPr sz="1350" b="0">
+            <a:lvl4pPr algn="l">
+              <a:defRPr sz="1125">
                 <a:solidFill>
                   <a:srgbClr val="C5CABC"/>
                 </a:solidFill>
@@ -10371,8 +10426,8 @@
                 <a:cs typeface="Helvetica Neue"/>
               </a:defRPr>
             </a:lvl4pPr>
-            <a:lvl5pPr>
-              <a:defRPr sz="1350" b="0">
+            <a:lvl5pPr algn="l">
+              <a:defRPr sz="1125">
                 <a:solidFill>
                   <a:srgbClr val="C5CABC"/>
                 </a:solidFill>
@@ -10381,8 +10436,8 @@
                 <a:cs typeface="Helvetica Neue"/>
               </a:defRPr>
             </a:lvl5pPr>
-            <a:lvl6pPr>
-              <a:defRPr sz="1350" b="0">
+            <a:lvl6pPr algn="l">
+              <a:defRPr sz="1125">
                 <a:solidFill>
                   <a:srgbClr val="C5CABC"/>
                 </a:solidFill>
@@ -10391,8 +10446,8 @@
                 <a:cs typeface="Helvetica Neue"/>
               </a:defRPr>
             </a:lvl6pPr>
-            <a:lvl7pPr>
-              <a:defRPr sz="1350" b="0">
+            <a:lvl7pPr algn="l">
+              <a:defRPr sz="1125">
                 <a:solidFill>
                   <a:srgbClr val="C5CABC"/>
                 </a:solidFill>
@@ -10401,8 +10456,8 @@
                 <a:cs typeface="Helvetica Neue"/>
               </a:defRPr>
             </a:lvl7pPr>
-            <a:lvl8pPr>
-              <a:defRPr sz="1350" b="0">
+            <a:lvl8pPr algn="l">
+              <a:defRPr sz="1125">
                 <a:solidFill>
                   <a:srgbClr val="C5CABC"/>
                 </a:solidFill>
@@ -10411,8 +10466,8 @@
                 <a:cs typeface="Helvetica Neue"/>
               </a:defRPr>
             </a:lvl8pPr>
-            <a:lvl9pPr>
-              <a:defRPr sz="1350" b="0">
+            <a:lvl9pPr algn="l">
+              <a:defRPr sz="1125">
                 <a:solidFill>
                   <a:srgbClr val="C5CABC"/>
                 </a:solidFill>
@@ -10423,8 +10478,8 @@
             </a:lvl9pPr>
           </a:lstStyle>
           <a:p xmlns:a="http://schemas.openxmlformats.org/drawingml/2006/main">
-            <a:pPr>
-              <a:defRPr sz="1350" b="0">
+            <a:pPr algn="l">
+              <a:defRPr sz="1125">
                 <a:solidFill>
                   <a:srgbClr val="C5CABC"/>
                 </a:solidFill>
@@ -10434,7 +10489,7 @@
               </a:defRPr>
             </a:pPr>
             <a:r>
-              <a:rPr sz="1350" b="0">
+              <a:rPr sz="1125">
                 <a:solidFill>
                   <a:srgbClr val="C5CABC"/>
                 </a:solidFill>
@@ -10442,1099 +10497,7 @@
                 <a:ea typeface="Helvetica Neue"/>
                 <a:cs typeface="Helvetica Neue"/>
               </a:rPr>
-              <a:t>5 / 5</a:t>
-            </a:r>
-          </a:p>
-        </p:txBody>
-      </p:sp>
-      <p:sp>
-        <p:nvSpPr>
-          <p:cNvPr id="5" name="">
-            <a:extLst xmlns:a="http://schemas.openxmlformats.org/drawingml/2006/main">
-              <a:ext uri="{FF2B5EF4-FFF2-40B4-BE49-F238E27FC236}">
-                <a16:creationId xmlns:a16="http://schemas.microsoft.com/office/drawing/2014/main" id="{C64328F8-BED4-45DF-BC49-E5ABFDD9B383}"/>
-              </a:ext>
-            </a:extLst>
-          </p:cNvPr>
-          <p:cNvSpPr>
-            <a:spLocks xmlns:a="http://schemas.openxmlformats.org/drawingml/2006/main" noGrp="1"/>
-          </p:cNvSpPr>
-          <p:nvPr/>
-        </p:nvSpPr>
-        <p:spPr>
-          <a:xfrm xmlns:a="http://schemas.openxmlformats.org/drawingml/2006/main">
-            <a:off x="609600" y="2571750"/>
-            <a:ext cx="857250" cy="476250"/>
-          </a:xfrm>
-          <a:prstGeom xmlns:a="http://schemas.openxmlformats.org/drawingml/2006/main" prst="rect">
-            <a:avLst/>
-          </a:prstGeom>
-          <a:noFill xmlns:a="http://schemas.openxmlformats.org/drawingml/2006/main"/>
-          <a:ln xmlns:a="http://schemas.openxmlformats.org/drawingml/2006/main" w="0">
-            <a:noFill/>
-          </a:ln>
-        </p:spPr>
-        <p:txBody>
-          <a:bodyPr xmlns:a="http://schemas.openxmlformats.org/drawingml/2006/main"/>
-          <a:lstStyle xmlns:a="http://schemas.openxmlformats.org/drawingml/2006/main">
-            <a:defPPr>
-              <a:defRPr sz="2400" b="1">
-                <a:solidFill>
-                  <a:srgbClr val="D8B44E"/>
-                </a:solidFill>
-                <a:latin typeface="Helvetica Neue"/>
-                <a:ea typeface="Helvetica Neue"/>
-                <a:cs typeface="Helvetica Neue"/>
-              </a:defRPr>
-            </a:defPPr>
-            <a:lvl1pPr>
-              <a:defRPr sz="2400" b="1">
-                <a:solidFill>
-                  <a:srgbClr val="D8B44E"/>
-                </a:solidFill>
-                <a:latin typeface="Helvetica Neue"/>
-                <a:ea typeface="Helvetica Neue"/>
-                <a:cs typeface="Helvetica Neue"/>
-              </a:defRPr>
-            </a:lvl1pPr>
-            <a:lvl2pPr>
-              <a:defRPr sz="2400" b="1">
-                <a:solidFill>
-                  <a:srgbClr val="D8B44E"/>
-                </a:solidFill>
-                <a:latin typeface="Helvetica Neue"/>
-                <a:ea typeface="Helvetica Neue"/>
-                <a:cs typeface="Helvetica Neue"/>
-              </a:defRPr>
-            </a:lvl2pPr>
-            <a:lvl3pPr>
-              <a:defRPr sz="2400" b="1">
-                <a:solidFill>
-                  <a:srgbClr val="D8B44E"/>
-                </a:solidFill>
-                <a:latin typeface="Helvetica Neue"/>
-                <a:ea typeface="Helvetica Neue"/>
-                <a:cs typeface="Helvetica Neue"/>
-              </a:defRPr>
-            </a:lvl3pPr>
-            <a:lvl4pPr>
-              <a:defRPr sz="2400" b="1">
-                <a:solidFill>
-                  <a:srgbClr val="D8B44E"/>
-                </a:solidFill>
-                <a:latin typeface="Helvetica Neue"/>
-                <a:ea typeface="Helvetica Neue"/>
-                <a:cs typeface="Helvetica Neue"/>
-              </a:defRPr>
-            </a:lvl4pPr>
-            <a:lvl5pPr>
-              <a:defRPr sz="2400" b="1">
-                <a:solidFill>
-                  <a:srgbClr val="D8B44E"/>
-                </a:solidFill>
-                <a:latin typeface="Helvetica Neue"/>
-                <a:ea typeface="Helvetica Neue"/>
-                <a:cs typeface="Helvetica Neue"/>
-              </a:defRPr>
-            </a:lvl5pPr>
-            <a:lvl6pPr>
-              <a:defRPr sz="2400" b="1">
-                <a:solidFill>
-                  <a:srgbClr val="D8B44E"/>
-                </a:solidFill>
-                <a:latin typeface="Helvetica Neue"/>
-                <a:ea typeface="Helvetica Neue"/>
-                <a:cs typeface="Helvetica Neue"/>
-              </a:defRPr>
-            </a:lvl6pPr>
-            <a:lvl7pPr>
-              <a:defRPr sz="2400" b="1">
-                <a:solidFill>
-                  <a:srgbClr val="D8B44E"/>
-                </a:solidFill>
-                <a:latin typeface="Helvetica Neue"/>
-                <a:ea typeface="Helvetica Neue"/>
-                <a:cs typeface="Helvetica Neue"/>
-              </a:defRPr>
-            </a:lvl7pPr>
-            <a:lvl8pPr>
-              <a:defRPr sz="2400" b="1">
-                <a:solidFill>
-                  <a:srgbClr val="D8B44E"/>
-                </a:solidFill>
-                <a:latin typeface="Helvetica Neue"/>
-                <a:ea typeface="Helvetica Neue"/>
-                <a:cs typeface="Helvetica Neue"/>
-              </a:defRPr>
-            </a:lvl8pPr>
-            <a:lvl9pPr>
-              <a:defRPr sz="2400" b="1">
-                <a:solidFill>
-                  <a:srgbClr val="D8B44E"/>
-                </a:solidFill>
-                <a:latin typeface="Helvetica Neue"/>
-                <a:ea typeface="Helvetica Neue"/>
-                <a:cs typeface="Helvetica Neue"/>
-              </a:defRPr>
-            </a:lvl9pPr>
-          </a:lstStyle>
-          <a:p xmlns:a="http://schemas.openxmlformats.org/drawingml/2006/main">
-            <a:pPr>
-              <a:defRPr sz="2400" b="1">
-                <a:solidFill>
-                  <a:srgbClr val="D8B44E"/>
-                </a:solidFill>
-                <a:latin typeface="Helvetica Neue"/>
-                <a:ea typeface="Helvetica Neue"/>
-                <a:cs typeface="Helvetica Neue"/>
-              </a:defRPr>
-            </a:pPr>
-            <a:r>
-              <a:rPr sz="2400" b="1">
-                <a:solidFill>
-                  <a:srgbClr val="D8B44E"/>
-                </a:solidFill>
-                <a:latin typeface="Helvetica Neue"/>
-                <a:ea typeface="Helvetica Neue"/>
-                <a:cs typeface="Helvetica Neue"/>
-              </a:rPr>
-              <a:t>01</a:t>
-            </a:r>
-          </a:p>
-        </p:txBody>
-      </p:sp>
-      <p:sp>
-        <p:nvSpPr>
-          <p:cNvPr id="6" name="">
-            <a:extLst xmlns:a="http://schemas.openxmlformats.org/drawingml/2006/main">
-              <a:ext uri="{FF2B5EF4-FFF2-40B4-BE49-F238E27FC236}">
-                <a16:creationId xmlns:a16="http://schemas.microsoft.com/office/drawing/2014/main" id="{4BC0B483-EC48-47E8-B1DC-5329672403B1}"/>
-              </a:ext>
-            </a:extLst>
-          </p:cNvPr>
-          <p:cNvSpPr>
-            <a:spLocks xmlns:a="http://schemas.openxmlformats.org/drawingml/2006/main" noGrp="1"/>
-          </p:cNvSpPr>
-          <p:nvPr/>
-        </p:nvSpPr>
-        <p:spPr>
-          <a:xfrm xmlns:a="http://schemas.openxmlformats.org/drawingml/2006/main">
-            <a:off x="1714500" y="2543175"/>
-            <a:ext cx="9525000" cy="857250"/>
-          </a:xfrm>
-          <a:prstGeom xmlns:a="http://schemas.openxmlformats.org/drawingml/2006/main" prst="rect">
-            <a:avLst/>
-          </a:prstGeom>
-          <a:noFill xmlns:a="http://schemas.openxmlformats.org/drawingml/2006/main"/>
-          <a:ln xmlns:a="http://schemas.openxmlformats.org/drawingml/2006/main" w="0">
-            <a:noFill/>
-          </a:ln>
-        </p:spPr>
-        <p:txBody>
-          <a:bodyPr xmlns:a="http://schemas.openxmlformats.org/drawingml/2006/main"/>
-          <a:lstStyle xmlns:a="http://schemas.openxmlformats.org/drawingml/2006/main">
-            <a:defPPr>
-              <a:defRPr sz="2325" b="0">
-                <a:solidFill>
-                  <a:srgbClr val="F2F0E5"/>
-                </a:solidFill>
-                <a:latin typeface="Helvetica Neue"/>
-                <a:ea typeface="Helvetica Neue"/>
-                <a:cs typeface="Helvetica Neue"/>
-              </a:defRPr>
-            </a:defPPr>
-            <a:lvl1pPr>
-              <a:defRPr sz="2325" b="0">
-                <a:solidFill>
-                  <a:srgbClr val="F2F0E5"/>
-                </a:solidFill>
-                <a:latin typeface="Helvetica Neue"/>
-                <a:ea typeface="Helvetica Neue"/>
-                <a:cs typeface="Helvetica Neue"/>
-              </a:defRPr>
-            </a:lvl1pPr>
-            <a:lvl2pPr>
-              <a:defRPr sz="2325" b="0">
-                <a:solidFill>
-                  <a:srgbClr val="F2F0E5"/>
-                </a:solidFill>
-                <a:latin typeface="Helvetica Neue"/>
-                <a:ea typeface="Helvetica Neue"/>
-                <a:cs typeface="Helvetica Neue"/>
-              </a:defRPr>
-            </a:lvl2pPr>
-            <a:lvl3pPr>
-              <a:defRPr sz="2325" b="0">
-                <a:solidFill>
-                  <a:srgbClr val="F2F0E5"/>
-                </a:solidFill>
-                <a:latin typeface="Helvetica Neue"/>
-                <a:ea typeface="Helvetica Neue"/>
-                <a:cs typeface="Helvetica Neue"/>
-              </a:defRPr>
-            </a:lvl3pPr>
-            <a:lvl4pPr>
-              <a:defRPr sz="2325" b="0">
-                <a:solidFill>
-                  <a:srgbClr val="F2F0E5"/>
-                </a:solidFill>
-                <a:latin typeface="Helvetica Neue"/>
-                <a:ea typeface="Helvetica Neue"/>
-                <a:cs typeface="Helvetica Neue"/>
-              </a:defRPr>
-            </a:lvl4pPr>
-            <a:lvl5pPr>
-              <a:defRPr sz="2325" b="0">
-                <a:solidFill>
-                  <a:srgbClr val="F2F0E5"/>
-                </a:solidFill>
-                <a:latin typeface="Helvetica Neue"/>
-                <a:ea typeface="Helvetica Neue"/>
-                <a:cs typeface="Helvetica Neue"/>
-              </a:defRPr>
-            </a:lvl5pPr>
-            <a:lvl6pPr>
-              <a:defRPr sz="2325" b="0">
-                <a:solidFill>
-                  <a:srgbClr val="F2F0E5"/>
-                </a:solidFill>
-                <a:latin typeface="Helvetica Neue"/>
-                <a:ea typeface="Helvetica Neue"/>
-                <a:cs typeface="Helvetica Neue"/>
-              </a:defRPr>
-            </a:lvl6pPr>
-            <a:lvl7pPr>
-              <a:defRPr sz="2325" b="0">
-                <a:solidFill>
-                  <a:srgbClr val="F2F0E5"/>
-                </a:solidFill>
-                <a:latin typeface="Helvetica Neue"/>
-                <a:ea typeface="Helvetica Neue"/>
-                <a:cs typeface="Helvetica Neue"/>
-              </a:defRPr>
-            </a:lvl7pPr>
-            <a:lvl8pPr>
-              <a:defRPr sz="2325" b="0">
-                <a:solidFill>
-                  <a:srgbClr val="F2F0E5"/>
-                </a:solidFill>
-                <a:latin typeface="Helvetica Neue"/>
-                <a:ea typeface="Helvetica Neue"/>
-                <a:cs typeface="Helvetica Neue"/>
-              </a:defRPr>
-            </a:lvl8pPr>
-            <a:lvl9pPr>
-              <a:defRPr sz="2325" b="0">
-                <a:solidFill>
-                  <a:srgbClr val="F2F0E5"/>
-                </a:solidFill>
-                <a:latin typeface="Helvetica Neue"/>
-                <a:ea typeface="Helvetica Neue"/>
-                <a:cs typeface="Helvetica Neue"/>
-              </a:defRPr>
-            </a:lvl9pPr>
-          </a:lstStyle>
-          <a:p xmlns:a="http://schemas.openxmlformats.org/drawingml/2006/main">
-            <a:pPr>
-              <a:defRPr sz="2325" b="0">
-                <a:solidFill>
-                  <a:srgbClr val="F2F0E5"/>
-                </a:solidFill>
-                <a:latin typeface="Helvetica Neue"/>
-                <a:ea typeface="Helvetica Neue"/>
-                <a:cs typeface="Helvetica Neue"/>
-              </a:defRPr>
-            </a:pPr>
-            <a:r>
-              <a:rPr sz="2325" b="0">
-                <a:solidFill>
-                  <a:srgbClr val="F2F0E5"/>
-                </a:solidFill>
-                <a:latin typeface="Helvetica Neue"/>
-                <a:ea typeface="Helvetica Neue"/>
-                <a:cs typeface="Helvetica Neue"/>
-              </a:rPr>
-              <a:t>Measure supply W/Wh over the same test window as the task logs.</a:t>
-            </a:r>
-          </a:p>
-        </p:txBody>
-      </p:sp>
-      <p:sp>
-        <p:nvSpPr>
-          <p:cNvPr id="7" name="">
-            <a:extLst xmlns:a="http://schemas.openxmlformats.org/drawingml/2006/main">
-              <a:ext uri="{FF2B5EF4-FFF2-40B4-BE49-F238E27FC236}">
-                <a16:creationId xmlns:a16="http://schemas.microsoft.com/office/drawing/2014/main" id="{C2EA7851-C40D-4DB5-9553-00B6171245BD}"/>
-              </a:ext>
-            </a:extLst>
-          </p:cNvPr>
-          <p:cNvSpPr>
-            <a:spLocks xmlns:a="http://schemas.openxmlformats.org/drawingml/2006/main" noGrp="1"/>
-          </p:cNvSpPr>
-          <p:nvPr/>
-        </p:nvSpPr>
-        <p:spPr>
-          <a:xfrm xmlns:a="http://schemas.openxmlformats.org/drawingml/2006/main">
-            <a:off x="609600" y="3724275"/>
-            <a:ext cx="857250" cy="476250"/>
-          </a:xfrm>
-          <a:prstGeom xmlns:a="http://schemas.openxmlformats.org/drawingml/2006/main" prst="rect">
-            <a:avLst/>
-          </a:prstGeom>
-          <a:noFill xmlns:a="http://schemas.openxmlformats.org/drawingml/2006/main"/>
-          <a:ln xmlns:a="http://schemas.openxmlformats.org/drawingml/2006/main" w="0">
-            <a:noFill/>
-          </a:ln>
-        </p:spPr>
-        <p:txBody>
-          <a:bodyPr xmlns:a="http://schemas.openxmlformats.org/drawingml/2006/main"/>
-          <a:lstStyle xmlns:a="http://schemas.openxmlformats.org/drawingml/2006/main">
-            <a:defPPr>
-              <a:defRPr sz="2400" b="1">
-                <a:solidFill>
-                  <a:srgbClr val="D8B44E"/>
-                </a:solidFill>
-                <a:latin typeface="Helvetica Neue"/>
-                <a:ea typeface="Helvetica Neue"/>
-                <a:cs typeface="Helvetica Neue"/>
-              </a:defRPr>
-            </a:defPPr>
-            <a:lvl1pPr>
-              <a:defRPr sz="2400" b="1">
-                <a:solidFill>
-                  <a:srgbClr val="D8B44E"/>
-                </a:solidFill>
-                <a:latin typeface="Helvetica Neue"/>
-                <a:ea typeface="Helvetica Neue"/>
-                <a:cs typeface="Helvetica Neue"/>
-              </a:defRPr>
-            </a:lvl1pPr>
-            <a:lvl2pPr>
-              <a:defRPr sz="2400" b="1">
-                <a:solidFill>
-                  <a:srgbClr val="D8B44E"/>
-                </a:solidFill>
-                <a:latin typeface="Helvetica Neue"/>
-                <a:ea typeface="Helvetica Neue"/>
-                <a:cs typeface="Helvetica Neue"/>
-              </a:defRPr>
-            </a:lvl2pPr>
-            <a:lvl3pPr>
-              <a:defRPr sz="2400" b="1">
-                <a:solidFill>
-                  <a:srgbClr val="D8B44E"/>
-                </a:solidFill>
-                <a:latin typeface="Helvetica Neue"/>
-                <a:ea typeface="Helvetica Neue"/>
-                <a:cs typeface="Helvetica Neue"/>
-              </a:defRPr>
-            </a:lvl3pPr>
-            <a:lvl4pPr>
-              <a:defRPr sz="2400" b="1">
-                <a:solidFill>
-                  <a:srgbClr val="D8B44E"/>
-                </a:solidFill>
-                <a:latin typeface="Helvetica Neue"/>
-                <a:ea typeface="Helvetica Neue"/>
-                <a:cs typeface="Helvetica Neue"/>
-              </a:defRPr>
-            </a:lvl4pPr>
-            <a:lvl5pPr>
-              <a:defRPr sz="2400" b="1">
-                <a:solidFill>
-                  <a:srgbClr val="D8B44E"/>
-                </a:solidFill>
-                <a:latin typeface="Helvetica Neue"/>
-                <a:ea typeface="Helvetica Neue"/>
-                <a:cs typeface="Helvetica Neue"/>
-              </a:defRPr>
-            </a:lvl5pPr>
-            <a:lvl6pPr>
-              <a:defRPr sz="2400" b="1">
-                <a:solidFill>
-                  <a:srgbClr val="D8B44E"/>
-                </a:solidFill>
-                <a:latin typeface="Helvetica Neue"/>
-                <a:ea typeface="Helvetica Neue"/>
-                <a:cs typeface="Helvetica Neue"/>
-              </a:defRPr>
-            </a:lvl6pPr>
-            <a:lvl7pPr>
-              <a:defRPr sz="2400" b="1">
-                <a:solidFill>
-                  <a:srgbClr val="D8B44E"/>
-                </a:solidFill>
-                <a:latin typeface="Helvetica Neue"/>
-                <a:ea typeface="Helvetica Neue"/>
-                <a:cs typeface="Helvetica Neue"/>
-              </a:defRPr>
-            </a:lvl7pPr>
-            <a:lvl8pPr>
-              <a:defRPr sz="2400" b="1">
-                <a:solidFill>
-                  <a:srgbClr val="D8B44E"/>
-                </a:solidFill>
-                <a:latin typeface="Helvetica Neue"/>
-                <a:ea typeface="Helvetica Neue"/>
-                <a:cs typeface="Helvetica Neue"/>
-              </a:defRPr>
-            </a:lvl8pPr>
-            <a:lvl9pPr>
-              <a:defRPr sz="2400" b="1">
-                <a:solidFill>
-                  <a:srgbClr val="D8B44E"/>
-                </a:solidFill>
-                <a:latin typeface="Helvetica Neue"/>
-                <a:ea typeface="Helvetica Neue"/>
-                <a:cs typeface="Helvetica Neue"/>
-              </a:defRPr>
-            </a:lvl9pPr>
-          </a:lstStyle>
-          <a:p xmlns:a="http://schemas.openxmlformats.org/drawingml/2006/main">
-            <a:pPr>
-              <a:defRPr sz="2400" b="1">
-                <a:solidFill>
-                  <a:srgbClr val="D8B44E"/>
-                </a:solidFill>
-                <a:latin typeface="Helvetica Neue"/>
-                <a:ea typeface="Helvetica Neue"/>
-                <a:cs typeface="Helvetica Neue"/>
-              </a:defRPr>
-            </a:pPr>
-            <a:r>
-              <a:rPr sz="2400" b="1">
-                <a:solidFill>
-                  <a:srgbClr val="D8B44E"/>
-                </a:solidFill>
-                <a:latin typeface="Helvetica Neue"/>
-                <a:ea typeface="Helvetica Neue"/>
-                <a:cs typeface="Helvetica Neue"/>
-              </a:rPr>
-              <a:t>02</a:t>
-            </a:r>
-          </a:p>
-        </p:txBody>
-      </p:sp>
-      <p:sp>
-        <p:nvSpPr>
-          <p:cNvPr id="8" name="">
-            <a:extLst xmlns:a="http://schemas.openxmlformats.org/drawingml/2006/main">
-              <a:ext uri="{FF2B5EF4-FFF2-40B4-BE49-F238E27FC236}">
-                <a16:creationId xmlns:a16="http://schemas.microsoft.com/office/drawing/2014/main" id="{1F844DF1-6539-4681-B2D8-7F1048B81C9D}"/>
-              </a:ext>
-            </a:extLst>
-          </p:cNvPr>
-          <p:cNvSpPr>
-            <a:spLocks xmlns:a="http://schemas.openxmlformats.org/drawingml/2006/main" noGrp="1"/>
-          </p:cNvSpPr>
-          <p:nvPr/>
-        </p:nvSpPr>
-        <p:spPr>
-          <a:xfrm xmlns:a="http://schemas.openxmlformats.org/drawingml/2006/main">
-            <a:off x="1714500" y="3695700"/>
-            <a:ext cx="9525000" cy="857250"/>
-          </a:xfrm>
-          <a:prstGeom xmlns:a="http://schemas.openxmlformats.org/drawingml/2006/main" prst="rect">
-            <a:avLst/>
-          </a:prstGeom>
-          <a:noFill xmlns:a="http://schemas.openxmlformats.org/drawingml/2006/main"/>
-          <a:ln xmlns:a="http://schemas.openxmlformats.org/drawingml/2006/main" w="0">
-            <a:noFill/>
-          </a:ln>
-        </p:spPr>
-        <p:txBody>
-          <a:bodyPr xmlns:a="http://schemas.openxmlformats.org/drawingml/2006/main"/>
-          <a:lstStyle xmlns:a="http://schemas.openxmlformats.org/drawingml/2006/main">
-            <a:defPPr>
-              <a:defRPr sz="2325" b="0">
-                <a:solidFill>
-                  <a:srgbClr val="F2F0E5"/>
-                </a:solidFill>
-                <a:latin typeface="Helvetica Neue"/>
-                <a:ea typeface="Helvetica Neue"/>
-                <a:cs typeface="Helvetica Neue"/>
-              </a:defRPr>
-            </a:defPPr>
-            <a:lvl1pPr>
-              <a:defRPr sz="2325" b="0">
-                <a:solidFill>
-                  <a:srgbClr val="F2F0E5"/>
-                </a:solidFill>
-                <a:latin typeface="Helvetica Neue"/>
-                <a:ea typeface="Helvetica Neue"/>
-                <a:cs typeface="Helvetica Neue"/>
-              </a:defRPr>
-            </a:lvl1pPr>
-            <a:lvl2pPr>
-              <a:defRPr sz="2325" b="0">
-                <a:solidFill>
-                  <a:srgbClr val="F2F0E5"/>
-                </a:solidFill>
-                <a:latin typeface="Helvetica Neue"/>
-                <a:ea typeface="Helvetica Neue"/>
-                <a:cs typeface="Helvetica Neue"/>
-              </a:defRPr>
-            </a:lvl2pPr>
-            <a:lvl3pPr>
-              <a:defRPr sz="2325" b="0">
-                <a:solidFill>
-                  <a:srgbClr val="F2F0E5"/>
-                </a:solidFill>
-                <a:latin typeface="Helvetica Neue"/>
-                <a:ea typeface="Helvetica Neue"/>
-                <a:cs typeface="Helvetica Neue"/>
-              </a:defRPr>
-            </a:lvl3pPr>
-            <a:lvl4pPr>
-              <a:defRPr sz="2325" b="0">
-                <a:solidFill>
-                  <a:srgbClr val="F2F0E5"/>
-                </a:solidFill>
-                <a:latin typeface="Helvetica Neue"/>
-                <a:ea typeface="Helvetica Neue"/>
-                <a:cs typeface="Helvetica Neue"/>
-              </a:defRPr>
-            </a:lvl4pPr>
-            <a:lvl5pPr>
-              <a:defRPr sz="2325" b="0">
-                <a:solidFill>
-                  <a:srgbClr val="F2F0E5"/>
-                </a:solidFill>
-                <a:latin typeface="Helvetica Neue"/>
-                <a:ea typeface="Helvetica Neue"/>
-                <a:cs typeface="Helvetica Neue"/>
-              </a:defRPr>
-            </a:lvl5pPr>
-            <a:lvl6pPr>
-              <a:defRPr sz="2325" b="0">
-                <a:solidFill>
-                  <a:srgbClr val="F2F0E5"/>
-                </a:solidFill>
-                <a:latin typeface="Helvetica Neue"/>
-                <a:ea typeface="Helvetica Neue"/>
-                <a:cs typeface="Helvetica Neue"/>
-              </a:defRPr>
-            </a:lvl6pPr>
-            <a:lvl7pPr>
-              <a:defRPr sz="2325" b="0">
-                <a:solidFill>
-                  <a:srgbClr val="F2F0E5"/>
-                </a:solidFill>
-                <a:latin typeface="Helvetica Neue"/>
-                <a:ea typeface="Helvetica Neue"/>
-                <a:cs typeface="Helvetica Neue"/>
-              </a:defRPr>
-            </a:lvl7pPr>
-            <a:lvl8pPr>
-              <a:defRPr sz="2325" b="0">
-                <a:solidFill>
-                  <a:srgbClr val="F2F0E5"/>
-                </a:solidFill>
-                <a:latin typeface="Helvetica Neue"/>
-                <a:ea typeface="Helvetica Neue"/>
-                <a:cs typeface="Helvetica Neue"/>
-              </a:defRPr>
-            </a:lvl8pPr>
-            <a:lvl9pPr>
-              <a:defRPr sz="2325" b="0">
-                <a:solidFill>
-                  <a:srgbClr val="F2F0E5"/>
-                </a:solidFill>
-                <a:latin typeface="Helvetica Neue"/>
-                <a:ea typeface="Helvetica Neue"/>
-                <a:cs typeface="Helvetica Neue"/>
-              </a:defRPr>
-            </a:lvl9pPr>
-          </a:lstStyle>
-          <a:p xmlns:a="http://schemas.openxmlformats.org/drawingml/2006/main">
-            <a:pPr>
-              <a:defRPr sz="2325" b="0">
-                <a:solidFill>
-                  <a:srgbClr val="F2F0E5"/>
-                </a:solidFill>
-                <a:latin typeface="Helvetica Neue"/>
-                <a:ea typeface="Helvetica Neue"/>
-                <a:cs typeface="Helvetica Neue"/>
-              </a:defRPr>
-            </a:pPr>
-            <a:r>
-              <a:rPr sz="2325" b="0">
-                <a:solidFill>
-                  <a:srgbClr val="F2F0E5"/>
-                </a:solidFill>
-                <a:latin typeface="Helvetica Neue"/>
-                <a:ea typeface="Helvetica Neue"/>
-                <a:cs typeface="Helvetica Neue"/>
-              </a:rPr>
-              <a:t>Repeat a fixed workload with agreed quality and latency limits.</a:t>
-            </a:r>
-          </a:p>
-        </p:txBody>
-      </p:sp>
-      <p:sp>
-        <p:nvSpPr>
-          <p:cNvPr id="9" name="">
-            <a:extLst xmlns:a="http://schemas.openxmlformats.org/drawingml/2006/main">
-              <a:ext uri="{FF2B5EF4-FFF2-40B4-BE49-F238E27FC236}">
-                <a16:creationId xmlns:a16="http://schemas.microsoft.com/office/drawing/2014/main" id="{72A4B619-474C-4AC5-936B-75FD63358318}"/>
-              </a:ext>
-            </a:extLst>
-          </p:cNvPr>
-          <p:cNvSpPr>
-            <a:spLocks xmlns:a="http://schemas.openxmlformats.org/drawingml/2006/main" noGrp="1"/>
-          </p:cNvSpPr>
-          <p:nvPr/>
-        </p:nvSpPr>
-        <p:spPr>
-          <a:xfrm xmlns:a="http://schemas.openxmlformats.org/drawingml/2006/main">
-            <a:off x="609600" y="4876800"/>
-            <a:ext cx="857250" cy="476250"/>
-          </a:xfrm>
-          <a:prstGeom xmlns:a="http://schemas.openxmlformats.org/drawingml/2006/main" prst="rect">
-            <a:avLst/>
-          </a:prstGeom>
-          <a:noFill xmlns:a="http://schemas.openxmlformats.org/drawingml/2006/main"/>
-          <a:ln xmlns:a="http://schemas.openxmlformats.org/drawingml/2006/main" w="0">
-            <a:noFill/>
-          </a:ln>
-        </p:spPr>
-        <p:txBody>
-          <a:bodyPr xmlns:a="http://schemas.openxmlformats.org/drawingml/2006/main"/>
-          <a:lstStyle xmlns:a="http://schemas.openxmlformats.org/drawingml/2006/main">
-            <a:defPPr>
-              <a:defRPr sz="2400" b="1">
-                <a:solidFill>
-                  <a:srgbClr val="D8B44E"/>
-                </a:solidFill>
-                <a:latin typeface="Helvetica Neue"/>
-                <a:ea typeface="Helvetica Neue"/>
-                <a:cs typeface="Helvetica Neue"/>
-              </a:defRPr>
-            </a:defPPr>
-            <a:lvl1pPr>
-              <a:defRPr sz="2400" b="1">
-                <a:solidFill>
-                  <a:srgbClr val="D8B44E"/>
-                </a:solidFill>
-                <a:latin typeface="Helvetica Neue"/>
-                <a:ea typeface="Helvetica Neue"/>
-                <a:cs typeface="Helvetica Neue"/>
-              </a:defRPr>
-            </a:lvl1pPr>
-            <a:lvl2pPr>
-              <a:defRPr sz="2400" b="1">
-                <a:solidFill>
-                  <a:srgbClr val="D8B44E"/>
-                </a:solidFill>
-                <a:latin typeface="Helvetica Neue"/>
-                <a:ea typeface="Helvetica Neue"/>
-                <a:cs typeface="Helvetica Neue"/>
-              </a:defRPr>
-            </a:lvl2pPr>
-            <a:lvl3pPr>
-              <a:defRPr sz="2400" b="1">
-                <a:solidFill>
-                  <a:srgbClr val="D8B44E"/>
-                </a:solidFill>
-                <a:latin typeface="Helvetica Neue"/>
-                <a:ea typeface="Helvetica Neue"/>
-                <a:cs typeface="Helvetica Neue"/>
-              </a:defRPr>
-            </a:lvl3pPr>
-            <a:lvl4pPr>
-              <a:defRPr sz="2400" b="1">
-                <a:solidFill>
-                  <a:srgbClr val="D8B44E"/>
-                </a:solidFill>
-                <a:latin typeface="Helvetica Neue"/>
-                <a:ea typeface="Helvetica Neue"/>
-                <a:cs typeface="Helvetica Neue"/>
-              </a:defRPr>
-            </a:lvl4pPr>
-            <a:lvl5pPr>
-              <a:defRPr sz="2400" b="1">
-                <a:solidFill>
-                  <a:srgbClr val="D8B44E"/>
-                </a:solidFill>
-                <a:latin typeface="Helvetica Neue"/>
-                <a:ea typeface="Helvetica Neue"/>
-                <a:cs typeface="Helvetica Neue"/>
-              </a:defRPr>
-            </a:lvl5pPr>
-            <a:lvl6pPr>
-              <a:defRPr sz="2400" b="1">
-                <a:solidFill>
-                  <a:srgbClr val="D8B44E"/>
-                </a:solidFill>
-                <a:latin typeface="Helvetica Neue"/>
-                <a:ea typeface="Helvetica Neue"/>
-                <a:cs typeface="Helvetica Neue"/>
-              </a:defRPr>
-            </a:lvl6pPr>
-            <a:lvl7pPr>
-              <a:defRPr sz="2400" b="1">
-                <a:solidFill>
-                  <a:srgbClr val="D8B44E"/>
-                </a:solidFill>
-                <a:latin typeface="Helvetica Neue"/>
-                <a:ea typeface="Helvetica Neue"/>
-                <a:cs typeface="Helvetica Neue"/>
-              </a:defRPr>
-            </a:lvl7pPr>
-            <a:lvl8pPr>
-              <a:defRPr sz="2400" b="1">
-                <a:solidFill>
-                  <a:srgbClr val="D8B44E"/>
-                </a:solidFill>
-                <a:latin typeface="Helvetica Neue"/>
-                <a:ea typeface="Helvetica Neue"/>
-                <a:cs typeface="Helvetica Neue"/>
-              </a:defRPr>
-            </a:lvl8pPr>
-            <a:lvl9pPr>
-              <a:defRPr sz="2400" b="1">
-                <a:solidFill>
-                  <a:srgbClr val="D8B44E"/>
-                </a:solidFill>
-                <a:latin typeface="Helvetica Neue"/>
-                <a:ea typeface="Helvetica Neue"/>
-                <a:cs typeface="Helvetica Neue"/>
-              </a:defRPr>
-            </a:lvl9pPr>
-          </a:lstStyle>
-          <a:p xmlns:a="http://schemas.openxmlformats.org/drawingml/2006/main">
-            <a:pPr>
-              <a:defRPr sz="2400" b="1">
-                <a:solidFill>
-                  <a:srgbClr val="D8B44E"/>
-                </a:solidFill>
-                <a:latin typeface="Helvetica Neue"/>
-                <a:ea typeface="Helvetica Neue"/>
-                <a:cs typeface="Helvetica Neue"/>
-              </a:defRPr>
-            </a:pPr>
-            <a:r>
-              <a:rPr sz="2400" b="1">
-                <a:solidFill>
-                  <a:srgbClr val="D8B44E"/>
-                </a:solidFill>
-                <a:latin typeface="Helvetica Neue"/>
-                <a:ea typeface="Helvetica Neue"/>
-                <a:cs typeface="Helvetica Neue"/>
-              </a:rPr>
-              <a:t>03</a:t>
-            </a:r>
-          </a:p>
-        </p:txBody>
-      </p:sp>
-      <p:sp>
-        <p:nvSpPr>
-          <p:cNvPr id="10" name="">
-            <a:extLst xmlns:a="http://schemas.openxmlformats.org/drawingml/2006/main">
-              <a:ext uri="{FF2B5EF4-FFF2-40B4-BE49-F238E27FC236}">
-                <a16:creationId xmlns:a16="http://schemas.microsoft.com/office/drawing/2014/main" id="{3D9646A4-2A7B-4393-93A9-72CA4304546B}"/>
-              </a:ext>
-            </a:extLst>
-          </p:cNvPr>
-          <p:cNvSpPr>
-            <a:spLocks xmlns:a="http://schemas.openxmlformats.org/drawingml/2006/main" noGrp="1"/>
-          </p:cNvSpPr>
-          <p:nvPr/>
-        </p:nvSpPr>
-        <p:spPr>
-          <a:xfrm xmlns:a="http://schemas.openxmlformats.org/drawingml/2006/main">
-            <a:off x="1714500" y="4848225"/>
-            <a:ext cx="9525000" cy="857250"/>
-          </a:xfrm>
-          <a:prstGeom xmlns:a="http://schemas.openxmlformats.org/drawingml/2006/main" prst="rect">
-            <a:avLst/>
-          </a:prstGeom>
-          <a:noFill xmlns:a="http://schemas.openxmlformats.org/drawingml/2006/main"/>
-          <a:ln xmlns:a="http://schemas.openxmlformats.org/drawingml/2006/main" w="0">
-            <a:noFill/>
-          </a:ln>
-        </p:spPr>
-        <p:txBody>
-          <a:bodyPr xmlns:a="http://schemas.openxmlformats.org/drawingml/2006/main"/>
-          <a:lstStyle xmlns:a="http://schemas.openxmlformats.org/drawingml/2006/main">
-            <a:defPPr>
-              <a:defRPr sz="2325" b="0">
-                <a:solidFill>
-                  <a:srgbClr val="F2F0E5"/>
-                </a:solidFill>
-                <a:latin typeface="Helvetica Neue"/>
-                <a:ea typeface="Helvetica Neue"/>
-                <a:cs typeface="Helvetica Neue"/>
-              </a:defRPr>
-            </a:defPPr>
-            <a:lvl1pPr>
-              <a:defRPr sz="2325" b="0">
-                <a:solidFill>
-                  <a:srgbClr val="F2F0E5"/>
-                </a:solidFill>
-                <a:latin typeface="Helvetica Neue"/>
-                <a:ea typeface="Helvetica Neue"/>
-                <a:cs typeface="Helvetica Neue"/>
-              </a:defRPr>
-            </a:lvl1pPr>
-            <a:lvl2pPr>
-              <a:defRPr sz="2325" b="0">
-                <a:solidFill>
-                  <a:srgbClr val="F2F0E5"/>
-                </a:solidFill>
-                <a:latin typeface="Helvetica Neue"/>
-                <a:ea typeface="Helvetica Neue"/>
-                <a:cs typeface="Helvetica Neue"/>
-              </a:defRPr>
-            </a:lvl2pPr>
-            <a:lvl3pPr>
-              <a:defRPr sz="2325" b="0">
-                <a:solidFill>
-                  <a:srgbClr val="F2F0E5"/>
-                </a:solidFill>
-                <a:latin typeface="Helvetica Neue"/>
-                <a:ea typeface="Helvetica Neue"/>
-                <a:cs typeface="Helvetica Neue"/>
-              </a:defRPr>
-            </a:lvl3pPr>
-            <a:lvl4pPr>
-              <a:defRPr sz="2325" b="0">
-                <a:solidFill>
-                  <a:srgbClr val="F2F0E5"/>
-                </a:solidFill>
-                <a:latin typeface="Helvetica Neue"/>
-                <a:ea typeface="Helvetica Neue"/>
-                <a:cs typeface="Helvetica Neue"/>
-              </a:defRPr>
-            </a:lvl4pPr>
-            <a:lvl5pPr>
-              <a:defRPr sz="2325" b="0">
-                <a:solidFill>
-                  <a:srgbClr val="F2F0E5"/>
-                </a:solidFill>
-                <a:latin typeface="Helvetica Neue"/>
-                <a:ea typeface="Helvetica Neue"/>
-                <a:cs typeface="Helvetica Neue"/>
-              </a:defRPr>
-            </a:lvl5pPr>
-            <a:lvl6pPr>
-              <a:defRPr sz="2325" b="0">
-                <a:solidFill>
-                  <a:srgbClr val="F2F0E5"/>
-                </a:solidFill>
-                <a:latin typeface="Helvetica Neue"/>
-                <a:ea typeface="Helvetica Neue"/>
-                <a:cs typeface="Helvetica Neue"/>
-              </a:defRPr>
-            </a:lvl6pPr>
-            <a:lvl7pPr>
-              <a:defRPr sz="2325" b="0">
-                <a:solidFill>
-                  <a:srgbClr val="F2F0E5"/>
-                </a:solidFill>
-                <a:latin typeface="Helvetica Neue"/>
-                <a:ea typeface="Helvetica Neue"/>
-                <a:cs typeface="Helvetica Neue"/>
-              </a:defRPr>
-            </a:lvl7pPr>
-            <a:lvl8pPr>
-              <a:defRPr sz="2325" b="0">
-                <a:solidFill>
-                  <a:srgbClr val="F2F0E5"/>
-                </a:solidFill>
-                <a:latin typeface="Helvetica Neue"/>
-                <a:ea typeface="Helvetica Neue"/>
-                <a:cs typeface="Helvetica Neue"/>
-              </a:defRPr>
-            </a:lvl8pPr>
-            <a:lvl9pPr>
-              <a:defRPr sz="2325" b="0">
-                <a:solidFill>
-                  <a:srgbClr val="F2F0E5"/>
-                </a:solidFill>
-                <a:latin typeface="Helvetica Neue"/>
-                <a:ea typeface="Helvetica Neue"/>
-                <a:cs typeface="Helvetica Neue"/>
-              </a:defRPr>
-            </a:lvl9pPr>
-          </a:lstStyle>
-          <a:p xmlns:a="http://schemas.openxmlformats.org/drawingml/2006/main">
-            <a:pPr>
-              <a:defRPr sz="2325" b="0">
-                <a:solidFill>
-                  <a:srgbClr val="F2F0E5"/>
-                </a:solidFill>
-                <a:latin typeface="Helvetica Neue"/>
-                <a:ea typeface="Helvetica Neue"/>
-                <a:cs typeface="Helvetica Neue"/>
-              </a:defRPr>
-            </a:pPr>
-            <a:r>
-              <a:rPr sz="2325" b="0">
-                <a:solidFill>
-                  <a:srgbClr val="F2F0E5"/>
-                </a:solidFill>
-                <a:latin typeface="Helvetica Neue"/>
-                <a:ea typeface="Helvetica Neue"/>
-                <a:cs typeface="Helvetica Neue"/>
-              </a:rPr>
-              <a:t>Keep GPU telemetry separate from whole-system energy.</a:t>
-            </a:r>
-          </a:p>
-        </p:txBody>
-      </p:sp>
-      <p:sp>
-        <p:nvSpPr>
-          <p:cNvPr id="11" name="">
-            <a:extLst xmlns:a="http://schemas.openxmlformats.org/drawingml/2006/main">
-              <a:ext uri="{FF2B5EF4-FFF2-40B4-BE49-F238E27FC236}">
-                <a16:creationId xmlns:a16="http://schemas.microsoft.com/office/drawing/2014/main" id="{1653CE52-2C12-4A3C-9137-1C7E6564E3A7}"/>
-              </a:ext>
-            </a:extLst>
-          </p:cNvPr>
-          <p:cNvSpPr>
-            <a:spLocks xmlns:a="http://schemas.openxmlformats.org/drawingml/2006/main" noGrp="1"/>
-          </p:cNvSpPr>
-          <p:nvPr/>
-        </p:nvSpPr>
-        <p:spPr>
-          <a:xfrm xmlns:a="http://schemas.openxmlformats.org/drawingml/2006/main">
-            <a:off x="609600" y="5886450"/>
-            <a:ext cx="10972800" cy="333375"/>
-          </a:xfrm>
-          <a:prstGeom xmlns:a="http://schemas.openxmlformats.org/drawingml/2006/main" prst="rect">
-            <a:avLst/>
-          </a:prstGeom>
-          <a:noFill xmlns:a="http://schemas.openxmlformats.org/drawingml/2006/main"/>
-          <a:ln xmlns:a="http://schemas.openxmlformats.org/drawingml/2006/main" w="0">
-            <a:noFill/>
-          </a:ln>
-        </p:spPr>
-        <p:txBody>
-          <a:bodyPr xmlns:a="http://schemas.openxmlformats.org/drawingml/2006/main"/>
-          <a:lstStyle xmlns:a="http://schemas.openxmlformats.org/drawingml/2006/main">
-            <a:defPPr>
-              <a:defRPr sz="1800" b="1">
-                <a:solidFill>
-                  <a:srgbClr val="F2F0E5"/>
-                </a:solidFill>
-                <a:latin typeface="Helvetica Neue"/>
-                <a:ea typeface="Helvetica Neue"/>
-                <a:cs typeface="Helvetica Neue"/>
-              </a:defRPr>
-            </a:defPPr>
-            <a:lvl1pPr>
-              <a:defRPr sz="1800" b="1">
-                <a:solidFill>
-                  <a:srgbClr val="F2F0E5"/>
-                </a:solidFill>
-                <a:latin typeface="Helvetica Neue"/>
-                <a:ea typeface="Helvetica Neue"/>
-                <a:cs typeface="Helvetica Neue"/>
-              </a:defRPr>
-            </a:lvl1pPr>
-            <a:lvl2pPr>
-              <a:defRPr sz="1800" b="1">
-                <a:solidFill>
-                  <a:srgbClr val="F2F0E5"/>
-                </a:solidFill>
-                <a:latin typeface="Helvetica Neue"/>
-                <a:ea typeface="Helvetica Neue"/>
-                <a:cs typeface="Helvetica Neue"/>
-              </a:defRPr>
-            </a:lvl2pPr>
-            <a:lvl3pPr>
-              <a:defRPr sz="1800" b="1">
-                <a:solidFill>
-                  <a:srgbClr val="F2F0E5"/>
-                </a:solidFill>
-                <a:latin typeface="Helvetica Neue"/>
-                <a:ea typeface="Helvetica Neue"/>
-                <a:cs typeface="Helvetica Neue"/>
-              </a:defRPr>
-            </a:lvl3pPr>
-            <a:lvl4pPr>
-              <a:defRPr sz="1800" b="1">
-                <a:solidFill>
-                  <a:srgbClr val="F2F0E5"/>
-                </a:solidFill>
-                <a:latin typeface="Helvetica Neue"/>
-                <a:ea typeface="Helvetica Neue"/>
-                <a:cs typeface="Helvetica Neue"/>
-              </a:defRPr>
-            </a:lvl4pPr>
-            <a:lvl5pPr>
-              <a:defRPr sz="1800" b="1">
-                <a:solidFill>
-                  <a:srgbClr val="F2F0E5"/>
-                </a:solidFill>
-                <a:latin typeface="Helvetica Neue"/>
-                <a:ea typeface="Helvetica Neue"/>
-                <a:cs typeface="Helvetica Neue"/>
-              </a:defRPr>
-            </a:lvl5pPr>
-            <a:lvl6pPr>
-              <a:defRPr sz="1800" b="1">
-                <a:solidFill>
-                  <a:srgbClr val="F2F0E5"/>
-                </a:solidFill>
-                <a:latin typeface="Helvetica Neue"/>
-                <a:ea typeface="Helvetica Neue"/>
-                <a:cs typeface="Helvetica Neue"/>
-              </a:defRPr>
-            </a:lvl6pPr>
-            <a:lvl7pPr>
-              <a:defRPr sz="1800" b="1">
-                <a:solidFill>
-                  <a:srgbClr val="F2F0E5"/>
-                </a:solidFill>
-                <a:latin typeface="Helvetica Neue"/>
-                <a:ea typeface="Helvetica Neue"/>
-                <a:cs typeface="Helvetica Neue"/>
-              </a:defRPr>
-            </a:lvl7pPr>
-            <a:lvl8pPr>
-              <a:defRPr sz="1800" b="1">
-                <a:solidFill>
-                  <a:srgbClr val="F2F0E5"/>
-                </a:solidFill>
-                <a:latin typeface="Helvetica Neue"/>
-                <a:ea typeface="Helvetica Neue"/>
-                <a:cs typeface="Helvetica Neue"/>
-              </a:defRPr>
-            </a:lvl8pPr>
-            <a:lvl9pPr>
-              <a:defRPr sz="1800" b="1">
-                <a:solidFill>
-                  <a:srgbClr val="F2F0E5"/>
-                </a:solidFill>
-                <a:latin typeface="Helvetica Neue"/>
-                <a:ea typeface="Helvetica Neue"/>
-                <a:cs typeface="Helvetica Neue"/>
-              </a:defRPr>
-            </a:lvl9pPr>
-          </a:lstStyle>
-          <a:p xmlns:a="http://schemas.openxmlformats.org/drawingml/2006/main">
-            <a:pPr>
-              <a:defRPr sz="1800" b="1">
-                <a:solidFill>
-                  <a:srgbClr val="F2F0E5"/>
-                </a:solidFill>
-                <a:latin typeface="Helvetica Neue"/>
-                <a:ea typeface="Helvetica Neue"/>
-                <a:cs typeface="Helvetica Neue"/>
-              </a:defRPr>
-            </a:pPr>
-            <a:r>
-              <a:rPr sz="1800" b="1">
-                <a:solidFill>
-                  <a:srgbClr val="F2F0E5"/>
-                </a:solidFill>
-                <a:latin typeface="Helvetica Neue"/>
-                <a:ea typeface="Helvetica Neue"/>
-                <a:cs typeface="Helvetica Neue"/>
-              </a:rPr>
-              <a:t>github.com/maxchamp2005-sudo/llm-energy-efficiency</a:t>
+              <a:t>True power factor and matched token counts are not shown in this trace.</a:t>
             </a:r>
           </a:p>
         </p:txBody>
@@ -11542,7 +10505,7 @@
     </p:spTree>
     <p:extLst>
       <p:ext uri="{BB962C8B-B14F-4D97-AF65-F5344CB8AC3E}">
-        <p14:creationId xmlns:p14="http://schemas.microsoft.com/office/powerpoint/2010/main" val="1209485135"/>
+        <p14:creationId xmlns:p14="http://schemas.microsoft.com/office/powerpoint/2010/main" val="56443760"/>
       </p:ext>
     </p:extLst>
   </p:cSld>

</xml_diff>

<commit_message>
Add isolated enterprise datacenter context and dual-GPU workstation photo
</commit_message>
<xml_diff>
--- a/docs/hackathon-pitch.pptx
+++ b/docs/hackathon-pitch.pptx
@@ -9,6 +9,7 @@
   </p:notesMasterIdLst>
   <p:sldIdLst>
     <p:sldId xmlns:r="http://schemas.openxmlformats.org/officeDocument/2006/relationships" id="256" r:id="R660419e85dd74a48"/>
+    <p:sldId xmlns:r="http://schemas.openxmlformats.org/officeDocument/2006/relationships" id="262" r:id="RisolatedDatacenter"/>
     <p:sldId xmlns:r="http://schemas.openxmlformats.org/officeDocument/2006/relationships" id="261" r:id="R52456b13680949ee"/>
     <p:sldId xmlns:r="http://schemas.openxmlformats.org/officeDocument/2006/relationships" id="257" r:id="Rfe21568811e04f53"/>
     <p:sldId xmlns:r="http://schemas.openxmlformats.org/officeDocument/2006/relationships" id="258" r:id="R1955cd6be8b14f23"/>
@@ -771,6 +772,86 @@
 </p:notes>
 </file>
 
+<file path=ppt/notesSlides/notesSlide7.xml><?xml version="1.0" encoding="utf-8"?>
+<p:notes xmlns:p="http://schemas.openxmlformats.org/presentationml/2006/main">
+  <p:cSld>
+    <p:spTree>
+      <p:nvGrpSpPr>
+        <p:cNvPr id="1" name=""/>
+        <p:cNvGrpSpPr/>
+        <p:nvPr/>
+      </p:nvGrpSpPr>
+      <p:grpSpPr>
+        <a:xfrm xmlns:a="http://schemas.openxmlformats.org/drawingml/2006/main"/>
+      </p:grpSpPr>
+      <p:sp>
+        <p:nvSpPr>
+          <p:cNvPr id="2" name="Slide Image Placeholder 1"/>
+          <p:cNvSpPr>
+            <a:spLocks xmlns:a="http://schemas.openxmlformats.org/drawingml/2006/main" noGrp="1"/>
+          </p:cNvSpPr>
+          <p:nvPr>
+            <p:ph type="sldImg" idx="0"/>
+          </p:nvPr>
+        </p:nvSpPr>
+        <p:spPr/>
+      </p:sp>
+      <p:sp>
+        <p:nvSpPr>
+          <p:cNvPr id="3" name="Notes Placeholder 2"/>
+          <p:cNvSpPr>
+            <a:spLocks xmlns:a="http://schemas.openxmlformats.org/drawingml/2006/main" noGrp="1"/>
+          </p:cNvSpPr>
+          <p:nvPr>
+            <p:ph type="body" idx="1"/>
+          </p:nvPr>
+        </p:nvSpPr>
+        <p:spPr/>
+        <p:txBody>
+          <a:bodyPr xmlns:a="http://schemas.openxmlformats.org/drawingml/2006/main"/>
+          <a:lstStyle xmlns:a="http://schemas.openxmlformats.org/drawingml/2006/main"/>
+          <a:p xmlns:a="http://schemas.openxmlformats.org/drawingml/2006/main">
+            <a:r>
+              <a:t>The data-center context and wording on this slide were supplied by the project owner. No independent air-gap or network-isolation audit, facility power budget, inference capacity measurement, energy measurement, savings, or deployment result is presented.</a:t>
+            </a:r>
+          </a:p>
+          <a:p xmlns:a="http://schemas.openxmlformats.org/drawingml/2006/main">
+            <a:r>
+              <a:t>The project owner reports a local hackathon workstation with an NVIDIA GeForce RTX 5060 and an AMD Radeon 7900. This small-scale demonstration illustrates enterprise context; it does not claim a certified air gap, simultaneous execution of the same model or workload on both GPUs, or any VRAM specification.</a:t>
+            </a:r>
+          </a:p>
+          <a:p xmlns:a="http://schemas.openxmlformats.org/drawingml/2006/main">
+            <a:r>
+              <a:t>The workstation photo was supplied by the project owner and is placed with its full aspect ratio, without cropping.</a:t>
+            </a:r>
+          </a:p>
+        </p:txBody>
+      </p:sp>
+      <p:sp>
+        <p:nvSpPr>
+          <p:cNvPr id="4" name="Slide Number Placeholder 3"/>
+          <p:cNvSpPr>
+            <a:spLocks xmlns:a="http://schemas.openxmlformats.org/drawingml/2006/main" noGrp="1"/>
+          </p:cNvSpPr>
+          <p:nvPr>
+            <p:ph type="sldNum" idx="5"/>
+          </p:nvPr>
+        </p:nvSpPr>
+        <p:spPr/>
+        <p:txBody>
+          <a:bodyPr xmlns:a="http://schemas.openxmlformats.org/drawingml/2006/main"/>
+          <a:lstStyle xmlns:a="http://schemas.openxmlformats.org/drawingml/2006/main"/>
+          <a:p xmlns:a="http://schemas.openxmlformats.org/drawingml/2006/main"/>
+        </p:txBody>
+      </p:sp>
+    </p:spTree>
+  </p:cSld>
+  <p:clrMapOvr>
+    <a:masterClrMapping xmlns:a="http://schemas.openxmlformats.org/drawingml/2006/main"/>
+  </p:clrMapOvr>
+</p:notes>
+</file>
+
 <file path=ppt/slideLayouts/slideLayout1.xml><?xml version="1.0" encoding="utf-8"?>
 <p:sldLayout xmlns:p="http://schemas.openxmlformats.org/presentationml/2006/main" type="title">
   <p:cSld name="Title Slide">
@@ -5668,7 +5749,7 @@
                 <a:ea typeface="Helvetica Neue"/>
                 <a:cs typeface="Helvetica Neue"/>
               </a:rPr>
-              <a:t>3 / 5</a:t>
+              <a:t>4 / 6</a:t>
             </a:r>
           </a:p>
         </p:txBody>
@@ -7123,7 +7204,7 @@
                 <a:ea typeface="Helvetica Neue"/>
                 <a:cs typeface="Helvetica Neue"/>
               </a:rPr>
-              <a:t>4 / 5</a:t>
+              <a:t>5 / 6</a:t>
             </a:r>
           </a:p>
         </p:txBody>
@@ -8868,7 +8949,7 @@
                 <a:ea typeface="Helvetica Neue"/>
                 <a:cs typeface="Helvetica Neue"/>
               </a:rPr>
-              <a:t>5 / 5</a:t>
+              <a:t>6 / 6</a:t>
             </a:r>
           </a:p>
         </p:txBody>
@@ -10506,6 +10587,1494 @@
     <p:extLst>
       <p:ext uri="{BB962C8B-B14F-4D97-AF65-F5344CB8AC3E}">
         <p14:creationId xmlns:p14="http://schemas.microsoft.com/office/powerpoint/2010/main" val="56443760"/>
+      </p:ext>
+    </p:extLst>
+  </p:cSld>
+</p:sld>
+</file>
+
+<file path=ppt/slides/slide7.xml><?xml version="1.0" encoding="utf-8"?>
+<p:sld xmlns:p="http://schemas.openxmlformats.org/presentationml/2006/main">
+  <p:cSld>
+    <p:bg>
+      <p:bgPr>
+        <a:solidFill xmlns:a="http://schemas.openxmlformats.org/drawingml/2006/main">
+          <a:srgbClr val="181B18"/>
+        </a:solidFill>
+      </p:bgPr>
+    </p:bg>
+    <p:spTree>
+      <p:nvGrpSpPr>
+        <p:cNvPr id="1" name=""/>
+        <p:cNvGrpSpPr/>
+        <p:nvPr/>
+      </p:nvGrpSpPr>
+      <p:grpSpPr>
+        <a:xfrm xmlns:a="http://schemas.openxmlformats.org/drawingml/2006/main"/>
+      </p:grpSpPr>
+      <p:sp>
+        <p:nvSpPr>
+          <p:cNvPr id="11" name="Context label">
+            <a:extLst xmlns:a="http://schemas.openxmlformats.org/drawingml/2006/main">
+              <a:ext uri="{FF2B5EF4-FFF2-40B4-BE49-F238E27FC236}">
+                <a16:creationId xmlns:a16="http://schemas.microsoft.com/office/drawing/2014/main" id="{AB95B4D0-236C-4CF8-8717-16E087A6ADB5}"/>
+              </a:ext>
+            </a:extLst>
+          </p:cNvPr>
+          <p:cNvSpPr>
+            <a:spLocks xmlns:a="http://schemas.openxmlformats.org/drawingml/2006/main" noGrp="1"/>
+          </p:cNvSpPr>
+          <p:nvPr/>
+        </p:nvSpPr>
+        <p:spPr>
+          <a:xfrm xmlns:a="http://schemas.openxmlformats.org/drawingml/2006/main">
+            <a:off x="609600" y="361950"/>
+            <a:ext cx="10972800" cy="247650"/>
+          </a:xfrm>
+          <a:prstGeom xmlns:a="http://schemas.openxmlformats.org/drawingml/2006/main" prst="rect">
+            <a:avLst/>
+          </a:prstGeom>
+          <a:noFill xmlns:a="http://schemas.openxmlformats.org/drawingml/2006/main"/>
+          <a:ln xmlns:a="http://schemas.openxmlformats.org/drawingml/2006/main" w="0">
+            <a:noFill/>
+            <a:prstDash val="solid"/>
+          </a:ln>
+        </p:spPr>
+        <p:txBody>
+          <a:bodyPr xmlns:a="http://schemas.openxmlformats.org/drawingml/2006/main" wrap="square" lIns="0" tIns="0" rIns="0" bIns="0" anchor="t">
+            <a:normAutofit fontScale="100000"/>
+          </a:bodyPr>
+          <a:lstStyle xmlns:a="http://schemas.openxmlformats.org/drawingml/2006/main">
+            <a:defPPr algn="l">
+              <a:defRPr sz="1275" b="1">
+                <a:solidFill>
+                  <a:srgbClr val="D8B44E"/>
+                </a:solidFill>
+                <a:latin typeface="Helvetica Neue"/>
+                <a:ea typeface="Helvetica Neue"/>
+                <a:cs typeface="Helvetica Neue"/>
+              </a:defRPr>
+            </a:defPPr>
+            <a:lvl1pPr algn="l">
+              <a:defRPr sz="1275" b="1">
+                <a:solidFill>
+                  <a:srgbClr val="D8B44E"/>
+                </a:solidFill>
+                <a:latin typeface="Helvetica Neue"/>
+                <a:ea typeface="Helvetica Neue"/>
+                <a:cs typeface="Helvetica Neue"/>
+              </a:defRPr>
+            </a:lvl1pPr>
+            <a:lvl2pPr algn="l">
+              <a:defRPr sz="1275" b="1">
+                <a:solidFill>
+                  <a:srgbClr val="D8B44E"/>
+                </a:solidFill>
+                <a:latin typeface="Helvetica Neue"/>
+                <a:ea typeface="Helvetica Neue"/>
+                <a:cs typeface="Helvetica Neue"/>
+              </a:defRPr>
+            </a:lvl2pPr>
+            <a:lvl3pPr algn="l">
+              <a:defRPr sz="1275" b="1">
+                <a:solidFill>
+                  <a:srgbClr val="D8B44E"/>
+                </a:solidFill>
+                <a:latin typeface="Helvetica Neue"/>
+                <a:ea typeface="Helvetica Neue"/>
+                <a:cs typeface="Helvetica Neue"/>
+              </a:defRPr>
+            </a:lvl3pPr>
+            <a:lvl4pPr algn="l">
+              <a:defRPr sz="1275" b="1">
+                <a:solidFill>
+                  <a:srgbClr val="D8B44E"/>
+                </a:solidFill>
+                <a:latin typeface="Helvetica Neue"/>
+                <a:ea typeface="Helvetica Neue"/>
+                <a:cs typeface="Helvetica Neue"/>
+              </a:defRPr>
+            </a:lvl4pPr>
+            <a:lvl5pPr algn="l">
+              <a:defRPr sz="1275" b="1">
+                <a:solidFill>
+                  <a:srgbClr val="D8B44E"/>
+                </a:solidFill>
+                <a:latin typeface="Helvetica Neue"/>
+                <a:ea typeface="Helvetica Neue"/>
+                <a:cs typeface="Helvetica Neue"/>
+              </a:defRPr>
+            </a:lvl5pPr>
+            <a:lvl6pPr algn="l">
+              <a:defRPr sz="1275" b="1">
+                <a:solidFill>
+                  <a:srgbClr val="D8B44E"/>
+                </a:solidFill>
+                <a:latin typeface="Helvetica Neue"/>
+                <a:ea typeface="Helvetica Neue"/>
+                <a:cs typeface="Helvetica Neue"/>
+              </a:defRPr>
+            </a:lvl6pPr>
+            <a:lvl7pPr algn="l">
+              <a:defRPr sz="1275" b="1">
+                <a:solidFill>
+                  <a:srgbClr val="D8B44E"/>
+                </a:solidFill>
+                <a:latin typeface="Helvetica Neue"/>
+                <a:ea typeface="Helvetica Neue"/>
+                <a:cs typeface="Helvetica Neue"/>
+              </a:defRPr>
+            </a:lvl7pPr>
+            <a:lvl8pPr algn="l">
+              <a:defRPr sz="1275" b="1">
+                <a:solidFill>
+                  <a:srgbClr val="D8B44E"/>
+                </a:solidFill>
+                <a:latin typeface="Helvetica Neue"/>
+                <a:ea typeface="Helvetica Neue"/>
+                <a:cs typeface="Helvetica Neue"/>
+              </a:defRPr>
+            </a:lvl8pPr>
+            <a:lvl9pPr algn="l">
+              <a:defRPr sz="1275" b="1">
+                <a:solidFill>
+                  <a:srgbClr val="D8B44E"/>
+                </a:solidFill>
+                <a:latin typeface="Helvetica Neue"/>
+                <a:ea typeface="Helvetica Neue"/>
+                <a:cs typeface="Helvetica Neue"/>
+              </a:defRPr>
+            </a:lvl9pPr>
+          </a:lstStyle>
+          <a:p xmlns:a="http://schemas.openxmlformats.org/drawingml/2006/main">
+            <a:pPr algn="l">
+              <a:defRPr sz="1275" b="1">
+                <a:solidFill>
+                  <a:srgbClr val="D8B44E"/>
+                </a:solidFill>
+                <a:latin typeface="Helvetica Neue"/>
+                <a:ea typeface="Helvetica Neue"/>
+                <a:cs typeface="Helvetica Neue"/>
+              </a:defRPr>
+            </a:pPr>
+            <a:r>
+              <a:rPr sz="1275" b="1">
+                <a:solidFill>
+                  <a:srgbClr val="D8B44E"/>
+                </a:solidFill>
+                <a:latin typeface="Helvetica Neue"/>
+                <a:ea typeface="Helvetica Neue"/>
+                <a:cs typeface="Helvetica Neue"/>
+              </a:rPr>
+              <a:t>HACKATHON DEMO · ENTERPRISE CONTEXT</a:t>
+            </a:r>
+          </a:p>
+        </p:txBody>
+      </p:sp>
+      <p:sp>
+        <p:nvSpPr>
+          <p:cNvPr id="2" name="Slide title">
+            <a:extLst xmlns:a="http://schemas.openxmlformats.org/drawingml/2006/main">
+              <a:ext uri="{FF2B5EF4-FFF2-40B4-BE49-F238E27FC236}">
+                <a16:creationId xmlns:a16="http://schemas.microsoft.com/office/drawing/2014/main" id="{FAA9CF73-84BE-4187-B818-2A59C05E2A0A}"/>
+              </a:ext>
+            </a:extLst>
+          </p:cNvPr>
+          <p:cNvSpPr>
+            <a:spLocks xmlns:a="http://schemas.openxmlformats.org/drawingml/2006/main" noGrp="1"/>
+          </p:cNvSpPr>
+          <p:nvPr/>
+        </p:nvSpPr>
+        <p:spPr>
+          <a:xfrm xmlns:a="http://schemas.openxmlformats.org/drawingml/2006/main">
+            <a:off x="609600" y="742950"/>
+            <a:ext cx="10972800" cy="514350"/>
+          </a:xfrm>
+          <a:prstGeom xmlns:a="http://schemas.openxmlformats.org/drawingml/2006/main" prst="rect">
+            <a:avLst/>
+          </a:prstGeom>
+          <a:noFill xmlns:a="http://schemas.openxmlformats.org/drawingml/2006/main"/>
+          <a:ln xmlns:a="http://schemas.openxmlformats.org/drawingml/2006/main" w="0">
+            <a:noFill/>
+            <a:prstDash val="solid"/>
+          </a:ln>
+        </p:spPr>
+        <p:txBody>
+          <a:bodyPr xmlns:a="http://schemas.openxmlformats.org/drawingml/2006/main" wrap="square" lIns="0" tIns="0" rIns="0" bIns="0" anchor="t">
+            <a:normAutofit fontScale="100000"/>
+          </a:bodyPr>
+          <a:lstStyle xmlns:a="http://schemas.openxmlformats.org/drawingml/2006/main">
+            <a:defPPr algn="l">
+              <a:defRPr sz="3000" b="1">
+                <a:solidFill>
+                  <a:srgbClr val="F2F0E5"/>
+                </a:solidFill>
+                <a:latin typeface="Helvetica Neue"/>
+                <a:ea typeface="Helvetica Neue"/>
+                <a:cs typeface="Helvetica Neue"/>
+              </a:defRPr>
+            </a:defPPr>
+            <a:lvl1pPr algn="l">
+              <a:defRPr sz="3000" b="1">
+                <a:solidFill>
+                  <a:srgbClr val="F2F0E5"/>
+                </a:solidFill>
+                <a:latin typeface="Helvetica Neue"/>
+                <a:ea typeface="Helvetica Neue"/>
+                <a:cs typeface="Helvetica Neue"/>
+              </a:defRPr>
+            </a:lvl1pPr>
+            <a:lvl2pPr algn="l">
+              <a:defRPr sz="3000" b="1">
+                <a:solidFill>
+                  <a:srgbClr val="F2F0E5"/>
+                </a:solidFill>
+                <a:latin typeface="Helvetica Neue"/>
+                <a:ea typeface="Helvetica Neue"/>
+                <a:cs typeface="Helvetica Neue"/>
+              </a:defRPr>
+            </a:lvl2pPr>
+            <a:lvl3pPr algn="l">
+              <a:defRPr sz="3000" b="1">
+                <a:solidFill>
+                  <a:srgbClr val="F2F0E5"/>
+                </a:solidFill>
+                <a:latin typeface="Helvetica Neue"/>
+                <a:ea typeface="Helvetica Neue"/>
+                <a:cs typeface="Helvetica Neue"/>
+              </a:defRPr>
+            </a:lvl3pPr>
+            <a:lvl4pPr algn="l">
+              <a:defRPr sz="3000" b="1">
+                <a:solidFill>
+                  <a:srgbClr val="F2F0E5"/>
+                </a:solidFill>
+                <a:latin typeface="Helvetica Neue"/>
+                <a:ea typeface="Helvetica Neue"/>
+                <a:cs typeface="Helvetica Neue"/>
+              </a:defRPr>
+            </a:lvl4pPr>
+            <a:lvl5pPr algn="l">
+              <a:defRPr sz="3000" b="1">
+                <a:solidFill>
+                  <a:srgbClr val="F2F0E5"/>
+                </a:solidFill>
+                <a:latin typeface="Helvetica Neue"/>
+                <a:ea typeface="Helvetica Neue"/>
+                <a:cs typeface="Helvetica Neue"/>
+              </a:defRPr>
+            </a:lvl5pPr>
+            <a:lvl6pPr algn="l">
+              <a:defRPr sz="3000" b="1">
+                <a:solidFill>
+                  <a:srgbClr val="F2F0E5"/>
+                </a:solidFill>
+                <a:latin typeface="Helvetica Neue"/>
+                <a:ea typeface="Helvetica Neue"/>
+                <a:cs typeface="Helvetica Neue"/>
+              </a:defRPr>
+            </a:lvl6pPr>
+            <a:lvl7pPr algn="l">
+              <a:defRPr sz="3000" b="1">
+                <a:solidFill>
+                  <a:srgbClr val="F2F0E5"/>
+                </a:solidFill>
+                <a:latin typeface="Helvetica Neue"/>
+                <a:ea typeface="Helvetica Neue"/>
+                <a:cs typeface="Helvetica Neue"/>
+              </a:defRPr>
+            </a:lvl7pPr>
+            <a:lvl8pPr algn="l">
+              <a:defRPr sz="3000" b="1">
+                <a:solidFill>
+                  <a:srgbClr val="F2F0E5"/>
+                </a:solidFill>
+                <a:latin typeface="Helvetica Neue"/>
+                <a:ea typeface="Helvetica Neue"/>
+                <a:cs typeface="Helvetica Neue"/>
+              </a:defRPr>
+            </a:lvl8pPr>
+            <a:lvl9pPr algn="l">
+              <a:defRPr sz="3000" b="1">
+                <a:solidFill>
+                  <a:srgbClr val="F2F0E5"/>
+                </a:solidFill>
+                <a:latin typeface="Helvetica Neue"/>
+                <a:ea typeface="Helvetica Neue"/>
+                <a:cs typeface="Helvetica Neue"/>
+              </a:defRPr>
+            </a:lvl9pPr>
+          </a:lstStyle>
+          <a:p xmlns:a="http://schemas.openxmlformats.org/drawingml/2006/main">
+            <a:pPr algn="l">
+              <a:defRPr sz="3000" b="1">
+                <a:solidFill>
+                  <a:srgbClr val="F2F0E5"/>
+                </a:solidFill>
+                <a:latin typeface="Helvetica Neue"/>
+                <a:ea typeface="Helvetica Neue"/>
+                <a:cs typeface="Helvetica Neue"/>
+              </a:defRPr>
+            </a:pPr>
+            <a:r>
+              <a:rPr sz="3000" b="1">
+                <a:solidFill>
+                  <a:srgbClr val="F2F0E5"/>
+                </a:solidFill>
+                <a:latin typeface="Helvetica Neue"/>
+                <a:ea typeface="Helvetica Neue"/>
+                <a:cs typeface="Helvetica Neue"/>
+              </a:rPr>
+              <a:t>Isolated Enterprise Datacenter</a:t>
+            </a:r>
+          </a:p>
+        </p:txBody>
+      </p:sp>
+      <p:sp>
+        <p:nvSpPr>
+          <p:cNvPr id="3" name="Isolation and power budget">
+            <a:extLst xmlns:a="http://schemas.openxmlformats.org/drawingml/2006/main">
+              <a:ext uri="{FF2B5EF4-FFF2-40B4-BE49-F238E27FC236}">
+                <a16:creationId xmlns:a16="http://schemas.microsoft.com/office/drawing/2014/main" id="{393931EF-6FB5-4772-807E-F6EDB5133A67}"/>
+              </a:ext>
+            </a:extLst>
+          </p:cNvPr>
+          <p:cNvSpPr>
+            <a:spLocks xmlns:a="http://schemas.openxmlformats.org/drawingml/2006/main" noGrp="1"/>
+          </p:cNvSpPr>
+          <p:nvPr/>
+        </p:nvSpPr>
+        <p:spPr>
+          <a:xfrm xmlns:a="http://schemas.openxmlformats.org/drawingml/2006/main">
+            <a:off x="609600" y="1524000"/>
+            <a:ext cx="4953000" cy="1952625"/>
+          </a:xfrm>
+          <a:prstGeom xmlns:a="http://schemas.openxmlformats.org/drawingml/2006/main" prst="rect">
+            <a:avLst/>
+          </a:prstGeom>
+          <a:noFill xmlns:a="http://schemas.openxmlformats.org/drawingml/2006/main"/>
+          <a:ln xmlns:a="http://schemas.openxmlformats.org/drawingml/2006/main" w="0">
+            <a:noFill/>
+            <a:prstDash val="solid"/>
+          </a:ln>
+        </p:spPr>
+        <p:txBody>
+          <a:bodyPr xmlns:a="http://schemas.openxmlformats.org/drawingml/2006/main" wrap="square" lIns="0" tIns="0" rIns="0" bIns="0" anchor="t">
+            <a:normAutofit fontScale="100000"/>
+          </a:bodyPr>
+          <a:lstStyle xmlns:a="http://schemas.openxmlformats.org/drawingml/2006/main">
+            <a:defPPr algn="l">
+              <a:defRPr sz="1725">
+                <a:solidFill>
+                  <a:srgbClr val="F2F0E5"/>
+                </a:solidFill>
+                <a:latin typeface="Helvetica Neue"/>
+                <a:ea typeface="Helvetica Neue"/>
+                <a:cs typeface="Helvetica Neue"/>
+              </a:defRPr>
+            </a:defPPr>
+            <a:lvl1pPr algn="l">
+              <a:defRPr sz="1725">
+                <a:solidFill>
+                  <a:srgbClr val="F2F0E5"/>
+                </a:solidFill>
+                <a:latin typeface="Helvetica Neue"/>
+                <a:ea typeface="Helvetica Neue"/>
+                <a:cs typeface="Helvetica Neue"/>
+              </a:defRPr>
+            </a:lvl1pPr>
+            <a:lvl2pPr algn="l">
+              <a:defRPr sz="1725">
+                <a:solidFill>
+                  <a:srgbClr val="F2F0E5"/>
+                </a:solidFill>
+                <a:latin typeface="Helvetica Neue"/>
+                <a:ea typeface="Helvetica Neue"/>
+                <a:cs typeface="Helvetica Neue"/>
+              </a:defRPr>
+            </a:lvl2pPr>
+            <a:lvl3pPr algn="l">
+              <a:defRPr sz="1725">
+                <a:solidFill>
+                  <a:srgbClr val="F2F0E5"/>
+                </a:solidFill>
+                <a:latin typeface="Helvetica Neue"/>
+                <a:ea typeface="Helvetica Neue"/>
+                <a:cs typeface="Helvetica Neue"/>
+              </a:defRPr>
+            </a:lvl3pPr>
+            <a:lvl4pPr algn="l">
+              <a:defRPr sz="1725">
+                <a:solidFill>
+                  <a:srgbClr val="F2F0E5"/>
+                </a:solidFill>
+                <a:latin typeface="Helvetica Neue"/>
+                <a:ea typeface="Helvetica Neue"/>
+                <a:cs typeface="Helvetica Neue"/>
+              </a:defRPr>
+            </a:lvl4pPr>
+            <a:lvl5pPr algn="l">
+              <a:defRPr sz="1725">
+                <a:solidFill>
+                  <a:srgbClr val="F2F0E5"/>
+                </a:solidFill>
+                <a:latin typeface="Helvetica Neue"/>
+                <a:ea typeface="Helvetica Neue"/>
+                <a:cs typeface="Helvetica Neue"/>
+              </a:defRPr>
+            </a:lvl5pPr>
+            <a:lvl6pPr algn="l">
+              <a:defRPr sz="1725">
+                <a:solidFill>
+                  <a:srgbClr val="F2F0E5"/>
+                </a:solidFill>
+                <a:latin typeface="Helvetica Neue"/>
+                <a:ea typeface="Helvetica Neue"/>
+                <a:cs typeface="Helvetica Neue"/>
+              </a:defRPr>
+            </a:lvl6pPr>
+            <a:lvl7pPr algn="l">
+              <a:defRPr sz="1725">
+                <a:solidFill>
+                  <a:srgbClr val="F2F0E5"/>
+                </a:solidFill>
+                <a:latin typeface="Helvetica Neue"/>
+                <a:ea typeface="Helvetica Neue"/>
+                <a:cs typeface="Helvetica Neue"/>
+              </a:defRPr>
+            </a:lvl7pPr>
+            <a:lvl8pPr algn="l">
+              <a:defRPr sz="1725">
+                <a:solidFill>
+                  <a:srgbClr val="F2F0E5"/>
+                </a:solidFill>
+                <a:latin typeface="Helvetica Neue"/>
+                <a:ea typeface="Helvetica Neue"/>
+                <a:cs typeface="Helvetica Neue"/>
+              </a:defRPr>
+            </a:lvl8pPr>
+            <a:lvl9pPr algn="l">
+              <a:defRPr sz="1725">
+                <a:solidFill>
+                  <a:srgbClr val="F2F0E5"/>
+                </a:solidFill>
+                <a:latin typeface="Helvetica Neue"/>
+                <a:ea typeface="Helvetica Neue"/>
+                <a:cs typeface="Helvetica Neue"/>
+              </a:defRPr>
+            </a:lvl9pPr>
+          </a:lstStyle>
+          <a:p xmlns:a="http://schemas.openxmlformats.org/drawingml/2006/main">
+            <a:pPr algn="l">
+              <a:defRPr sz="1725">
+                <a:solidFill>
+                  <a:srgbClr val="F2F0E5"/>
+                </a:solidFill>
+                <a:latin typeface="Helvetica Neue"/>
+                <a:ea typeface="Helvetica Neue"/>
+                <a:cs typeface="Helvetica Neue"/>
+              </a:defRPr>
+            </a:pPr>
+            <a:r>
+              <a:rPr sz="1725">
+                <a:solidFill>
+                  <a:srgbClr val="F2F0E5"/>
+                </a:solidFill>
+                <a:latin typeface="Helvetica Neue"/>
+                <a:ea typeface="Helvetica Neue"/>
+                <a:cs typeface="Helvetica Neue"/>
+              </a:rPr>
+              <a:t>Isolated enterprise data centers process all LLM requests on hardware within their own perimeter, without internet access. Their power budget limits the inference capacity available to users.</a:t>
+            </a:r>
+          </a:p>
+        </p:txBody>
+      </p:sp>
+      <p:sp>
+        <p:nvSpPr>
+          <p:cNvPr id="4" name="Workstation label">
+            <a:extLst xmlns:a="http://schemas.openxmlformats.org/drawingml/2006/main">
+              <a:ext uri="{FF2B5EF4-FFF2-40B4-BE49-F238E27FC236}">
+                <a16:creationId xmlns:a16="http://schemas.microsoft.com/office/drawing/2014/main" id="{2BE1F7DC-DCB4-4531-9CD7-09247DAA9887}"/>
+              </a:ext>
+            </a:extLst>
+          </p:cNvPr>
+          <p:cNvSpPr>
+            <a:spLocks xmlns:a="http://schemas.openxmlformats.org/drawingml/2006/main" noGrp="1"/>
+          </p:cNvSpPr>
+          <p:nvPr/>
+        </p:nvSpPr>
+        <p:spPr>
+          <a:xfrm xmlns:a="http://schemas.openxmlformats.org/drawingml/2006/main">
+            <a:off x="609600" y="3752850"/>
+            <a:ext cx="4953000" cy="228600"/>
+          </a:xfrm>
+          <a:prstGeom xmlns:a="http://schemas.openxmlformats.org/drawingml/2006/main" prst="rect">
+            <a:avLst/>
+          </a:prstGeom>
+          <a:noFill xmlns:a="http://schemas.openxmlformats.org/drawingml/2006/main"/>
+          <a:ln xmlns:a="http://schemas.openxmlformats.org/drawingml/2006/main" w="0">
+            <a:noFill/>
+            <a:prstDash val="solid"/>
+          </a:ln>
+        </p:spPr>
+        <p:txBody>
+          <a:bodyPr xmlns:a="http://schemas.openxmlformats.org/drawingml/2006/main" wrap="square" lIns="0" tIns="0" rIns="0" bIns="0" anchor="t">
+            <a:normAutofit fontScale="100000"/>
+          </a:bodyPr>
+          <a:lstStyle xmlns:a="http://schemas.openxmlformats.org/drawingml/2006/main">
+            <a:defPPr algn="l">
+              <a:defRPr sz="1275" b="1">
+                <a:solidFill>
+                  <a:srgbClr val="D8B44E"/>
+                </a:solidFill>
+                <a:latin typeface="Helvetica Neue"/>
+                <a:ea typeface="Helvetica Neue"/>
+                <a:cs typeface="Helvetica Neue"/>
+              </a:defRPr>
+            </a:defPPr>
+            <a:lvl1pPr algn="l">
+              <a:defRPr sz="1275" b="1">
+                <a:solidFill>
+                  <a:srgbClr val="D8B44E"/>
+                </a:solidFill>
+                <a:latin typeface="Helvetica Neue"/>
+                <a:ea typeface="Helvetica Neue"/>
+                <a:cs typeface="Helvetica Neue"/>
+              </a:defRPr>
+            </a:lvl1pPr>
+            <a:lvl2pPr algn="l">
+              <a:defRPr sz="1275" b="1">
+                <a:solidFill>
+                  <a:srgbClr val="D8B44E"/>
+                </a:solidFill>
+                <a:latin typeface="Helvetica Neue"/>
+                <a:ea typeface="Helvetica Neue"/>
+                <a:cs typeface="Helvetica Neue"/>
+              </a:defRPr>
+            </a:lvl2pPr>
+            <a:lvl3pPr algn="l">
+              <a:defRPr sz="1275" b="1">
+                <a:solidFill>
+                  <a:srgbClr val="D8B44E"/>
+                </a:solidFill>
+                <a:latin typeface="Helvetica Neue"/>
+                <a:ea typeface="Helvetica Neue"/>
+                <a:cs typeface="Helvetica Neue"/>
+              </a:defRPr>
+            </a:lvl3pPr>
+            <a:lvl4pPr algn="l">
+              <a:defRPr sz="1275" b="1">
+                <a:solidFill>
+                  <a:srgbClr val="D8B44E"/>
+                </a:solidFill>
+                <a:latin typeface="Helvetica Neue"/>
+                <a:ea typeface="Helvetica Neue"/>
+                <a:cs typeface="Helvetica Neue"/>
+              </a:defRPr>
+            </a:lvl4pPr>
+            <a:lvl5pPr algn="l">
+              <a:defRPr sz="1275" b="1">
+                <a:solidFill>
+                  <a:srgbClr val="D8B44E"/>
+                </a:solidFill>
+                <a:latin typeface="Helvetica Neue"/>
+                <a:ea typeface="Helvetica Neue"/>
+                <a:cs typeface="Helvetica Neue"/>
+              </a:defRPr>
+            </a:lvl5pPr>
+            <a:lvl6pPr algn="l">
+              <a:defRPr sz="1275" b="1">
+                <a:solidFill>
+                  <a:srgbClr val="D8B44E"/>
+                </a:solidFill>
+                <a:latin typeface="Helvetica Neue"/>
+                <a:ea typeface="Helvetica Neue"/>
+                <a:cs typeface="Helvetica Neue"/>
+              </a:defRPr>
+            </a:lvl6pPr>
+            <a:lvl7pPr algn="l">
+              <a:defRPr sz="1275" b="1">
+                <a:solidFill>
+                  <a:srgbClr val="D8B44E"/>
+                </a:solidFill>
+                <a:latin typeface="Helvetica Neue"/>
+                <a:ea typeface="Helvetica Neue"/>
+                <a:cs typeface="Helvetica Neue"/>
+              </a:defRPr>
+            </a:lvl7pPr>
+            <a:lvl8pPr algn="l">
+              <a:defRPr sz="1275" b="1">
+                <a:solidFill>
+                  <a:srgbClr val="D8B44E"/>
+                </a:solidFill>
+                <a:latin typeface="Helvetica Neue"/>
+                <a:ea typeface="Helvetica Neue"/>
+                <a:cs typeface="Helvetica Neue"/>
+              </a:defRPr>
+            </a:lvl8pPr>
+            <a:lvl9pPr algn="l">
+              <a:defRPr sz="1275" b="1">
+                <a:solidFill>
+                  <a:srgbClr val="D8B44E"/>
+                </a:solidFill>
+                <a:latin typeface="Helvetica Neue"/>
+                <a:ea typeface="Helvetica Neue"/>
+                <a:cs typeface="Helvetica Neue"/>
+              </a:defRPr>
+            </a:lvl9pPr>
+          </a:lstStyle>
+          <a:p xmlns:a="http://schemas.openxmlformats.org/drawingml/2006/main">
+            <a:pPr algn="l">
+              <a:defRPr sz="1275" b="1">
+                <a:solidFill>
+                  <a:srgbClr val="D8B44E"/>
+                </a:solidFill>
+                <a:latin typeface="Helvetica Neue"/>
+                <a:ea typeface="Helvetica Neue"/>
+                <a:cs typeface="Helvetica Neue"/>
+              </a:defRPr>
+            </a:pPr>
+            <a:r>
+              <a:rPr sz="1275" b="1">
+                <a:solidFill>
+                  <a:srgbClr val="D8B44E"/>
+                </a:solidFill>
+                <a:latin typeface="Helvetica Neue"/>
+                <a:ea typeface="Helvetica Neue"/>
+                <a:cs typeface="Helvetica Neue"/>
+              </a:rPr>
+              <a:t>HACKATHON WORKSTATION</a:t>
+            </a:r>
+          </a:p>
+        </p:txBody>
+      </p:sp>
+      <p:sp>
+        <p:nvSpPr>
+          <p:cNvPr id="5" name="Workstation description">
+            <a:extLst xmlns:a="http://schemas.openxmlformats.org/drawingml/2006/main">
+              <a:ext uri="{FF2B5EF4-FFF2-40B4-BE49-F238E27FC236}">
+                <a16:creationId xmlns:a16="http://schemas.microsoft.com/office/drawing/2014/main" id="{F281CD8F-9BC8-4672-BEDD-0BA1F520374D}"/>
+              </a:ext>
+            </a:extLst>
+          </p:cNvPr>
+          <p:cNvSpPr>
+            <a:spLocks xmlns:a="http://schemas.openxmlformats.org/drawingml/2006/main" noGrp="1"/>
+          </p:cNvSpPr>
+          <p:nvPr/>
+        </p:nvSpPr>
+        <p:spPr>
+          <a:xfrm xmlns:a="http://schemas.openxmlformats.org/drawingml/2006/main">
+            <a:off x="609600" y="4114800"/>
+            <a:ext cx="4953000" cy="838200"/>
+          </a:xfrm>
+          <a:prstGeom xmlns:a="http://schemas.openxmlformats.org/drawingml/2006/main" prst="rect">
+            <a:avLst/>
+          </a:prstGeom>
+          <a:noFill xmlns:a="http://schemas.openxmlformats.org/drawingml/2006/main"/>
+          <a:ln xmlns:a="http://schemas.openxmlformats.org/drawingml/2006/main" w="0">
+            <a:noFill/>
+            <a:prstDash val="solid"/>
+          </a:ln>
+        </p:spPr>
+        <p:txBody>
+          <a:bodyPr xmlns:a="http://schemas.openxmlformats.org/drawingml/2006/main" wrap="square" lIns="0" tIns="0" rIns="0" bIns="0" anchor="t">
+            <a:normAutofit fontScale="100000"/>
+          </a:bodyPr>
+          <a:lstStyle xmlns:a="http://schemas.openxmlformats.org/drawingml/2006/main">
+            <a:defPPr algn="l">
+              <a:defRPr sz="1650">
+                <a:solidFill>
+                  <a:srgbClr val="F2F0E5"/>
+                </a:solidFill>
+                <a:latin typeface="Helvetica Neue"/>
+                <a:ea typeface="Helvetica Neue"/>
+                <a:cs typeface="Helvetica Neue"/>
+              </a:defRPr>
+            </a:defPPr>
+            <a:lvl1pPr algn="l">
+              <a:defRPr sz="1650">
+                <a:solidFill>
+                  <a:srgbClr val="F2F0E5"/>
+                </a:solidFill>
+                <a:latin typeface="Helvetica Neue"/>
+                <a:ea typeface="Helvetica Neue"/>
+                <a:cs typeface="Helvetica Neue"/>
+              </a:defRPr>
+            </a:lvl1pPr>
+            <a:lvl2pPr algn="l">
+              <a:defRPr sz="1650">
+                <a:solidFill>
+                  <a:srgbClr val="F2F0E5"/>
+                </a:solidFill>
+                <a:latin typeface="Helvetica Neue"/>
+                <a:ea typeface="Helvetica Neue"/>
+                <a:cs typeface="Helvetica Neue"/>
+              </a:defRPr>
+            </a:lvl2pPr>
+            <a:lvl3pPr algn="l">
+              <a:defRPr sz="1650">
+                <a:solidFill>
+                  <a:srgbClr val="F2F0E5"/>
+                </a:solidFill>
+                <a:latin typeface="Helvetica Neue"/>
+                <a:ea typeface="Helvetica Neue"/>
+                <a:cs typeface="Helvetica Neue"/>
+              </a:defRPr>
+            </a:lvl3pPr>
+            <a:lvl4pPr algn="l">
+              <a:defRPr sz="1650">
+                <a:solidFill>
+                  <a:srgbClr val="F2F0E5"/>
+                </a:solidFill>
+                <a:latin typeface="Helvetica Neue"/>
+                <a:ea typeface="Helvetica Neue"/>
+                <a:cs typeface="Helvetica Neue"/>
+              </a:defRPr>
+            </a:lvl4pPr>
+            <a:lvl5pPr algn="l">
+              <a:defRPr sz="1650">
+                <a:solidFill>
+                  <a:srgbClr val="F2F0E5"/>
+                </a:solidFill>
+                <a:latin typeface="Helvetica Neue"/>
+                <a:ea typeface="Helvetica Neue"/>
+                <a:cs typeface="Helvetica Neue"/>
+              </a:defRPr>
+            </a:lvl5pPr>
+            <a:lvl6pPr algn="l">
+              <a:defRPr sz="1650">
+                <a:solidFill>
+                  <a:srgbClr val="F2F0E5"/>
+                </a:solidFill>
+                <a:latin typeface="Helvetica Neue"/>
+                <a:ea typeface="Helvetica Neue"/>
+                <a:cs typeface="Helvetica Neue"/>
+              </a:defRPr>
+            </a:lvl6pPr>
+            <a:lvl7pPr algn="l">
+              <a:defRPr sz="1650">
+                <a:solidFill>
+                  <a:srgbClr val="F2F0E5"/>
+                </a:solidFill>
+                <a:latin typeface="Helvetica Neue"/>
+                <a:ea typeface="Helvetica Neue"/>
+                <a:cs typeface="Helvetica Neue"/>
+              </a:defRPr>
+            </a:lvl7pPr>
+            <a:lvl8pPr algn="l">
+              <a:defRPr sz="1650">
+                <a:solidFill>
+                  <a:srgbClr val="F2F0E5"/>
+                </a:solidFill>
+                <a:latin typeface="Helvetica Neue"/>
+                <a:ea typeface="Helvetica Neue"/>
+                <a:cs typeface="Helvetica Neue"/>
+              </a:defRPr>
+            </a:lvl8pPr>
+            <a:lvl9pPr algn="l">
+              <a:defRPr sz="1650">
+                <a:solidFill>
+                  <a:srgbClr val="F2F0E5"/>
+                </a:solidFill>
+                <a:latin typeface="Helvetica Neue"/>
+                <a:ea typeface="Helvetica Neue"/>
+                <a:cs typeface="Helvetica Neue"/>
+              </a:defRPr>
+            </a:lvl9pPr>
+          </a:lstStyle>
+          <a:p xmlns:a="http://schemas.openxmlformats.org/drawingml/2006/main">
+            <a:pPr algn="l">
+              <a:defRPr sz="1650">
+                <a:solidFill>
+                  <a:srgbClr val="F2F0E5"/>
+                </a:solidFill>
+                <a:latin typeface="Helvetica Neue"/>
+                <a:ea typeface="Helvetica Neue"/>
+                <a:cs typeface="Helvetica Neue"/>
+              </a:defRPr>
+            </a:pPr>
+            <a:r>
+              <a:rPr sz="1650">
+                <a:solidFill>
+                  <a:srgbClr val="F2F0E5"/>
+                </a:solidFill>
+                <a:latin typeface="Helvetica Neue"/>
+                <a:ea typeface="Helvetica Neue"/>
+                <a:cs typeface="Helvetica Neue"/>
+              </a:rPr>
+              <a:t>For a small-scale demonstration at the hackathon, we used a local workstation with two GPUs:</a:t>
+            </a:r>
+          </a:p>
+        </p:txBody>
+      </p:sp>
+      <p:sp>
+        <p:nvSpPr>
+          <p:cNvPr id="6" name="GPU model 1">
+            <a:extLst xmlns:a="http://schemas.openxmlformats.org/drawingml/2006/main">
+              <a:ext uri="{FF2B5EF4-FFF2-40B4-BE49-F238E27FC236}">
+                <a16:creationId xmlns:a16="http://schemas.microsoft.com/office/drawing/2014/main" id="{0C0B60D0-CA19-4CD3-A24F-D713B8D8C6DE}"/>
+              </a:ext>
+            </a:extLst>
+          </p:cNvPr>
+          <p:cNvSpPr>
+            <a:spLocks xmlns:a="http://schemas.openxmlformats.org/drawingml/2006/main" noGrp="1"/>
+          </p:cNvSpPr>
+          <p:nvPr/>
+        </p:nvSpPr>
+        <p:spPr>
+          <a:xfrm xmlns:a="http://schemas.openxmlformats.org/drawingml/2006/main">
+            <a:off x="609600" y="5048250"/>
+            <a:ext cx="4953000" cy="285750"/>
+          </a:xfrm>
+          <a:prstGeom xmlns:a="http://schemas.openxmlformats.org/drawingml/2006/main" prst="rect">
+            <a:avLst/>
+          </a:prstGeom>
+          <a:noFill xmlns:a="http://schemas.openxmlformats.org/drawingml/2006/main"/>
+          <a:ln xmlns:a="http://schemas.openxmlformats.org/drawingml/2006/main" w="0">
+            <a:noFill/>
+            <a:prstDash val="solid"/>
+          </a:ln>
+        </p:spPr>
+        <p:txBody>
+          <a:bodyPr xmlns:a="http://schemas.openxmlformats.org/drawingml/2006/main" wrap="square" lIns="0" tIns="0" rIns="0" bIns="0" anchor="t">
+            <a:normAutofit fontScale="100000"/>
+          </a:bodyPr>
+          <a:lstStyle xmlns:a="http://schemas.openxmlformats.org/drawingml/2006/main">
+            <a:defPPr algn="l">
+              <a:defRPr sz="1500">
+                <a:solidFill>
+                  <a:srgbClr val="C5CABC"/>
+                </a:solidFill>
+                <a:latin typeface="Helvetica Neue"/>
+                <a:ea typeface="Helvetica Neue"/>
+                <a:cs typeface="Helvetica Neue"/>
+              </a:defRPr>
+            </a:defPPr>
+            <a:lvl1pPr algn="l">
+              <a:defRPr sz="1500">
+                <a:solidFill>
+                  <a:srgbClr val="C5CABC"/>
+                </a:solidFill>
+                <a:latin typeface="Helvetica Neue"/>
+                <a:ea typeface="Helvetica Neue"/>
+                <a:cs typeface="Helvetica Neue"/>
+              </a:defRPr>
+            </a:lvl1pPr>
+            <a:lvl2pPr algn="l">
+              <a:defRPr sz="1500">
+                <a:solidFill>
+                  <a:srgbClr val="C5CABC"/>
+                </a:solidFill>
+                <a:latin typeface="Helvetica Neue"/>
+                <a:ea typeface="Helvetica Neue"/>
+                <a:cs typeface="Helvetica Neue"/>
+              </a:defRPr>
+            </a:lvl2pPr>
+            <a:lvl3pPr algn="l">
+              <a:defRPr sz="1500">
+                <a:solidFill>
+                  <a:srgbClr val="C5CABC"/>
+                </a:solidFill>
+                <a:latin typeface="Helvetica Neue"/>
+                <a:ea typeface="Helvetica Neue"/>
+                <a:cs typeface="Helvetica Neue"/>
+              </a:defRPr>
+            </a:lvl3pPr>
+            <a:lvl4pPr algn="l">
+              <a:defRPr sz="1500">
+                <a:solidFill>
+                  <a:srgbClr val="C5CABC"/>
+                </a:solidFill>
+                <a:latin typeface="Helvetica Neue"/>
+                <a:ea typeface="Helvetica Neue"/>
+                <a:cs typeface="Helvetica Neue"/>
+              </a:defRPr>
+            </a:lvl4pPr>
+            <a:lvl5pPr algn="l">
+              <a:defRPr sz="1500">
+                <a:solidFill>
+                  <a:srgbClr val="C5CABC"/>
+                </a:solidFill>
+                <a:latin typeface="Helvetica Neue"/>
+                <a:ea typeface="Helvetica Neue"/>
+                <a:cs typeface="Helvetica Neue"/>
+              </a:defRPr>
+            </a:lvl5pPr>
+            <a:lvl6pPr algn="l">
+              <a:defRPr sz="1500">
+                <a:solidFill>
+                  <a:srgbClr val="C5CABC"/>
+                </a:solidFill>
+                <a:latin typeface="Helvetica Neue"/>
+                <a:ea typeface="Helvetica Neue"/>
+                <a:cs typeface="Helvetica Neue"/>
+              </a:defRPr>
+            </a:lvl6pPr>
+            <a:lvl7pPr algn="l">
+              <a:defRPr sz="1500">
+                <a:solidFill>
+                  <a:srgbClr val="C5CABC"/>
+                </a:solidFill>
+                <a:latin typeface="Helvetica Neue"/>
+                <a:ea typeface="Helvetica Neue"/>
+                <a:cs typeface="Helvetica Neue"/>
+              </a:defRPr>
+            </a:lvl7pPr>
+            <a:lvl8pPr algn="l">
+              <a:defRPr sz="1500">
+                <a:solidFill>
+                  <a:srgbClr val="C5CABC"/>
+                </a:solidFill>
+                <a:latin typeface="Helvetica Neue"/>
+                <a:ea typeface="Helvetica Neue"/>
+                <a:cs typeface="Helvetica Neue"/>
+              </a:defRPr>
+            </a:lvl8pPr>
+            <a:lvl9pPr algn="l">
+              <a:defRPr sz="1500">
+                <a:solidFill>
+                  <a:srgbClr val="C5CABC"/>
+                </a:solidFill>
+                <a:latin typeface="Helvetica Neue"/>
+                <a:ea typeface="Helvetica Neue"/>
+                <a:cs typeface="Helvetica Neue"/>
+              </a:defRPr>
+            </a:lvl9pPr>
+          </a:lstStyle>
+          <a:p xmlns:a="http://schemas.openxmlformats.org/drawingml/2006/main">
+            <a:pPr algn="l">
+              <a:defRPr sz="1500">
+                <a:solidFill>
+                  <a:srgbClr val="C5CABC"/>
+                </a:solidFill>
+                <a:latin typeface="Helvetica Neue"/>
+                <a:ea typeface="Helvetica Neue"/>
+                <a:cs typeface="Helvetica Neue"/>
+              </a:defRPr>
+            </a:pPr>
+            <a:r>
+              <a:rPr sz="1500">
+                <a:solidFill>
+                  <a:srgbClr val="C5CABC"/>
+                </a:solidFill>
+                <a:latin typeface="Helvetica Neue"/>
+                <a:ea typeface="Helvetica Neue"/>
+                <a:cs typeface="Helvetica Neue"/>
+              </a:rPr>
+              <a:t>NVIDIA GeForce RTX 5060</a:t>
+            </a:r>
+          </a:p>
+        </p:txBody>
+      </p:sp>
+      <p:sp>
+        <p:nvSpPr>
+          <p:cNvPr id="7" name="GPU model 2">
+            <a:extLst xmlns:a="http://schemas.openxmlformats.org/drawingml/2006/main">
+              <a:ext uri="{FF2B5EF4-FFF2-40B4-BE49-F238E27FC236}">
+                <a16:creationId xmlns:a16="http://schemas.microsoft.com/office/drawing/2014/main" id="{702F3B73-810C-4FBD-8175-4BBA450D3783}"/>
+              </a:ext>
+            </a:extLst>
+          </p:cNvPr>
+          <p:cNvSpPr>
+            <a:spLocks xmlns:a="http://schemas.openxmlformats.org/drawingml/2006/main" noGrp="1"/>
+          </p:cNvSpPr>
+          <p:nvPr/>
+        </p:nvSpPr>
+        <p:spPr>
+          <a:xfrm xmlns:a="http://schemas.openxmlformats.org/drawingml/2006/main">
+            <a:off x="609600" y="5410200"/>
+            <a:ext cx="4953000" cy="285750"/>
+          </a:xfrm>
+          <a:prstGeom xmlns:a="http://schemas.openxmlformats.org/drawingml/2006/main" prst="rect">
+            <a:avLst/>
+          </a:prstGeom>
+          <a:noFill xmlns:a="http://schemas.openxmlformats.org/drawingml/2006/main"/>
+          <a:ln xmlns:a="http://schemas.openxmlformats.org/drawingml/2006/main" w="0">
+            <a:noFill/>
+            <a:prstDash val="solid"/>
+          </a:ln>
+        </p:spPr>
+        <p:txBody>
+          <a:bodyPr xmlns:a="http://schemas.openxmlformats.org/drawingml/2006/main" wrap="square" lIns="0" tIns="0" rIns="0" bIns="0" anchor="t">
+            <a:normAutofit fontScale="100000"/>
+          </a:bodyPr>
+          <a:lstStyle xmlns:a="http://schemas.openxmlformats.org/drawingml/2006/main">
+            <a:defPPr algn="l">
+              <a:defRPr sz="1500">
+                <a:solidFill>
+                  <a:srgbClr val="C5CABC"/>
+                </a:solidFill>
+                <a:latin typeface="Helvetica Neue"/>
+                <a:ea typeface="Helvetica Neue"/>
+                <a:cs typeface="Helvetica Neue"/>
+              </a:defRPr>
+            </a:defPPr>
+            <a:lvl1pPr algn="l">
+              <a:defRPr sz="1500">
+                <a:solidFill>
+                  <a:srgbClr val="C5CABC"/>
+                </a:solidFill>
+                <a:latin typeface="Helvetica Neue"/>
+                <a:ea typeface="Helvetica Neue"/>
+                <a:cs typeface="Helvetica Neue"/>
+              </a:defRPr>
+            </a:lvl1pPr>
+            <a:lvl2pPr algn="l">
+              <a:defRPr sz="1500">
+                <a:solidFill>
+                  <a:srgbClr val="C5CABC"/>
+                </a:solidFill>
+                <a:latin typeface="Helvetica Neue"/>
+                <a:ea typeface="Helvetica Neue"/>
+                <a:cs typeface="Helvetica Neue"/>
+              </a:defRPr>
+            </a:lvl2pPr>
+            <a:lvl3pPr algn="l">
+              <a:defRPr sz="1500">
+                <a:solidFill>
+                  <a:srgbClr val="C5CABC"/>
+                </a:solidFill>
+                <a:latin typeface="Helvetica Neue"/>
+                <a:ea typeface="Helvetica Neue"/>
+                <a:cs typeface="Helvetica Neue"/>
+              </a:defRPr>
+            </a:lvl3pPr>
+            <a:lvl4pPr algn="l">
+              <a:defRPr sz="1500">
+                <a:solidFill>
+                  <a:srgbClr val="C5CABC"/>
+                </a:solidFill>
+                <a:latin typeface="Helvetica Neue"/>
+                <a:ea typeface="Helvetica Neue"/>
+                <a:cs typeface="Helvetica Neue"/>
+              </a:defRPr>
+            </a:lvl4pPr>
+            <a:lvl5pPr algn="l">
+              <a:defRPr sz="1500">
+                <a:solidFill>
+                  <a:srgbClr val="C5CABC"/>
+                </a:solidFill>
+                <a:latin typeface="Helvetica Neue"/>
+                <a:ea typeface="Helvetica Neue"/>
+                <a:cs typeface="Helvetica Neue"/>
+              </a:defRPr>
+            </a:lvl5pPr>
+            <a:lvl6pPr algn="l">
+              <a:defRPr sz="1500">
+                <a:solidFill>
+                  <a:srgbClr val="C5CABC"/>
+                </a:solidFill>
+                <a:latin typeface="Helvetica Neue"/>
+                <a:ea typeface="Helvetica Neue"/>
+                <a:cs typeface="Helvetica Neue"/>
+              </a:defRPr>
+            </a:lvl6pPr>
+            <a:lvl7pPr algn="l">
+              <a:defRPr sz="1500">
+                <a:solidFill>
+                  <a:srgbClr val="C5CABC"/>
+                </a:solidFill>
+                <a:latin typeface="Helvetica Neue"/>
+                <a:ea typeface="Helvetica Neue"/>
+                <a:cs typeface="Helvetica Neue"/>
+              </a:defRPr>
+            </a:lvl7pPr>
+            <a:lvl8pPr algn="l">
+              <a:defRPr sz="1500">
+                <a:solidFill>
+                  <a:srgbClr val="C5CABC"/>
+                </a:solidFill>
+                <a:latin typeface="Helvetica Neue"/>
+                <a:ea typeface="Helvetica Neue"/>
+                <a:cs typeface="Helvetica Neue"/>
+              </a:defRPr>
+            </a:lvl8pPr>
+            <a:lvl9pPr algn="l">
+              <a:defRPr sz="1500">
+                <a:solidFill>
+                  <a:srgbClr val="C5CABC"/>
+                </a:solidFill>
+                <a:latin typeface="Helvetica Neue"/>
+                <a:ea typeface="Helvetica Neue"/>
+                <a:cs typeface="Helvetica Neue"/>
+              </a:defRPr>
+            </a:lvl9pPr>
+          </a:lstStyle>
+          <a:p xmlns:a="http://schemas.openxmlformats.org/drawingml/2006/main">
+            <a:pPr algn="l">
+              <a:defRPr sz="1500">
+                <a:solidFill>
+                  <a:srgbClr val="C5CABC"/>
+                </a:solidFill>
+                <a:latin typeface="Helvetica Neue"/>
+                <a:ea typeface="Helvetica Neue"/>
+                <a:cs typeface="Helvetica Neue"/>
+              </a:defRPr>
+            </a:pPr>
+            <a:r>
+              <a:rPr sz="1500">
+                <a:solidFill>
+                  <a:srgbClr val="C5CABC"/>
+                </a:solidFill>
+                <a:latin typeface="Helvetica Neue"/>
+                <a:ea typeface="Helvetica Neue"/>
+                <a:cs typeface="Helvetica Neue"/>
+              </a:rPr>
+              <a:t>AMD Radeon 7900</a:t>
+            </a:r>
+          </a:p>
+        </p:txBody>
+      </p:sp>
+      <p:pic>
+        <p:nvPicPr>
+          <p:cNvPr id="8" name="">
+            <a:extLst xmlns:a="http://schemas.openxmlformats.org/drawingml/2006/main">
+              <a:ext uri="{FF2B5EF4-FFF2-40B4-BE49-F238E27FC236}">
+                <a16:creationId xmlns:a16="http://schemas.microsoft.com/office/drawing/2014/main" id="{DC076A8B-1EA4-4D26-9282-78B9EA97881A}"/>
+              </a:ext>
+            </a:extLst>
+          </p:cNvPr>
+          <p:cNvPicPr>
+            <a:picLocks xmlns:a="http://schemas.openxmlformats.org/drawingml/2006/main" noChangeAspect="1"/>
+          </p:cNvPicPr>
+          <p:nvPr/>
+        </p:nvPicPr>
+        <p:blipFill>
+          <a:blip xmlns:r="http://schemas.openxmlformats.org/officeDocument/2006/relationships" xmlns:a="http://schemas.openxmlformats.org/drawingml/2006/main" r:embed="R1acd691011ab4899"/>
+          <a:stretch xmlns:a="http://schemas.openxmlformats.org/drawingml/2006/main"/>
+        </p:blipFill>
+        <p:spPr>
+          <a:xfrm xmlns:a="http://schemas.openxmlformats.org/drawingml/2006/main">
+            <a:off x="6019800" y="1600200"/>
+            <a:ext cx="5562600" cy="4171950"/>
+          </a:xfrm>
+          <a:prstGeom xmlns:a="http://schemas.openxmlformats.org/drawingml/2006/main" prst="rect">
+            <a:avLst/>
+          </a:prstGeom>
+        </p:spPr>
+      </p:pic>
+      <p:sp>
+        <p:nvSpPr>
+          <p:cNvPr id="9" name="Project footer">
+            <a:extLst xmlns:a="http://schemas.openxmlformats.org/drawingml/2006/main">
+              <a:ext uri="{FF2B5EF4-FFF2-40B4-BE49-F238E27FC236}">
+                <a16:creationId xmlns:a16="http://schemas.microsoft.com/office/drawing/2014/main" id="{B3A4E84E-AD81-4DB0-B7F0-7583B43C651E}"/>
+              </a:ext>
+            </a:extLst>
+          </p:cNvPr>
+          <p:cNvSpPr>
+            <a:spLocks xmlns:a="http://schemas.openxmlformats.org/drawingml/2006/main" noGrp="1"/>
+          </p:cNvSpPr>
+          <p:nvPr/>
+        </p:nvSpPr>
+        <p:spPr>
+          <a:xfrm xmlns:a="http://schemas.openxmlformats.org/drawingml/2006/main">
+            <a:off x="609600" y="6467475"/>
+            <a:ext cx="4953000" cy="190500"/>
+          </a:xfrm>
+          <a:prstGeom xmlns:a="http://schemas.openxmlformats.org/drawingml/2006/main" prst="rect">
+            <a:avLst/>
+          </a:prstGeom>
+          <a:noFill xmlns:a="http://schemas.openxmlformats.org/drawingml/2006/main"/>
+          <a:ln xmlns:a="http://schemas.openxmlformats.org/drawingml/2006/main" w="0">
+            <a:noFill/>
+            <a:prstDash val="solid"/>
+          </a:ln>
+        </p:spPr>
+        <p:txBody>
+          <a:bodyPr xmlns:a="http://schemas.openxmlformats.org/drawingml/2006/main" wrap="square" lIns="0" tIns="0" rIns="0" bIns="0" anchor="t">
+            <a:normAutofit fontScale="100000"/>
+          </a:bodyPr>
+          <a:lstStyle xmlns:a="http://schemas.openxmlformats.org/drawingml/2006/main">
+            <a:defPPr algn="l">
+              <a:defRPr sz="975">
+                <a:solidFill>
+                  <a:srgbClr val="C5CABC"/>
+                </a:solidFill>
+                <a:latin typeface="Helvetica Neue"/>
+                <a:ea typeface="Helvetica Neue"/>
+                <a:cs typeface="Helvetica Neue"/>
+              </a:defRPr>
+            </a:defPPr>
+            <a:lvl1pPr algn="l">
+              <a:defRPr sz="975">
+                <a:solidFill>
+                  <a:srgbClr val="C5CABC"/>
+                </a:solidFill>
+                <a:latin typeface="Helvetica Neue"/>
+                <a:ea typeface="Helvetica Neue"/>
+                <a:cs typeface="Helvetica Neue"/>
+              </a:defRPr>
+            </a:lvl1pPr>
+            <a:lvl2pPr algn="l">
+              <a:defRPr sz="975">
+                <a:solidFill>
+                  <a:srgbClr val="C5CABC"/>
+                </a:solidFill>
+                <a:latin typeface="Helvetica Neue"/>
+                <a:ea typeface="Helvetica Neue"/>
+                <a:cs typeface="Helvetica Neue"/>
+              </a:defRPr>
+            </a:lvl2pPr>
+            <a:lvl3pPr algn="l">
+              <a:defRPr sz="975">
+                <a:solidFill>
+                  <a:srgbClr val="C5CABC"/>
+                </a:solidFill>
+                <a:latin typeface="Helvetica Neue"/>
+                <a:ea typeface="Helvetica Neue"/>
+                <a:cs typeface="Helvetica Neue"/>
+              </a:defRPr>
+            </a:lvl3pPr>
+            <a:lvl4pPr algn="l">
+              <a:defRPr sz="975">
+                <a:solidFill>
+                  <a:srgbClr val="C5CABC"/>
+                </a:solidFill>
+                <a:latin typeface="Helvetica Neue"/>
+                <a:ea typeface="Helvetica Neue"/>
+                <a:cs typeface="Helvetica Neue"/>
+              </a:defRPr>
+            </a:lvl4pPr>
+            <a:lvl5pPr algn="l">
+              <a:defRPr sz="975">
+                <a:solidFill>
+                  <a:srgbClr val="C5CABC"/>
+                </a:solidFill>
+                <a:latin typeface="Helvetica Neue"/>
+                <a:ea typeface="Helvetica Neue"/>
+                <a:cs typeface="Helvetica Neue"/>
+              </a:defRPr>
+            </a:lvl5pPr>
+            <a:lvl6pPr algn="l">
+              <a:defRPr sz="975">
+                <a:solidFill>
+                  <a:srgbClr val="C5CABC"/>
+                </a:solidFill>
+                <a:latin typeface="Helvetica Neue"/>
+                <a:ea typeface="Helvetica Neue"/>
+                <a:cs typeface="Helvetica Neue"/>
+              </a:defRPr>
+            </a:lvl6pPr>
+            <a:lvl7pPr algn="l">
+              <a:defRPr sz="975">
+                <a:solidFill>
+                  <a:srgbClr val="C5CABC"/>
+                </a:solidFill>
+                <a:latin typeface="Helvetica Neue"/>
+                <a:ea typeface="Helvetica Neue"/>
+                <a:cs typeface="Helvetica Neue"/>
+              </a:defRPr>
+            </a:lvl7pPr>
+            <a:lvl8pPr algn="l">
+              <a:defRPr sz="975">
+                <a:solidFill>
+                  <a:srgbClr val="C5CABC"/>
+                </a:solidFill>
+                <a:latin typeface="Helvetica Neue"/>
+                <a:ea typeface="Helvetica Neue"/>
+                <a:cs typeface="Helvetica Neue"/>
+              </a:defRPr>
+            </a:lvl8pPr>
+            <a:lvl9pPr algn="l">
+              <a:defRPr sz="975">
+                <a:solidFill>
+                  <a:srgbClr val="C5CABC"/>
+                </a:solidFill>
+                <a:latin typeface="Helvetica Neue"/>
+                <a:ea typeface="Helvetica Neue"/>
+                <a:cs typeface="Helvetica Neue"/>
+              </a:defRPr>
+            </a:lvl9pPr>
+          </a:lstStyle>
+          <a:p xmlns:a="http://schemas.openxmlformats.org/drawingml/2006/main">
+            <a:pPr algn="l">
+              <a:defRPr sz="975">
+                <a:solidFill>
+                  <a:srgbClr val="C5CABC"/>
+                </a:solidFill>
+                <a:latin typeface="Helvetica Neue"/>
+                <a:ea typeface="Helvetica Neue"/>
+                <a:cs typeface="Helvetica Neue"/>
+              </a:defRPr>
+            </a:pPr>
+            <a:r>
+              <a:rPr sz="975">
+                <a:solidFill>
+                  <a:srgbClr val="C5CABC"/>
+                </a:solidFill>
+                <a:latin typeface="Helvetica Neue"/>
+                <a:ea typeface="Helvetica Neue"/>
+                <a:cs typeface="Helvetica Neue"/>
+              </a:rPr>
+              <a:t>TEAM AC/DC · HACKATHON PROJECT</a:t>
+            </a:r>
+          </a:p>
+        </p:txBody>
+      </p:sp>
+      <p:sp>
+        <p:nvSpPr>
+          <p:cNvPr id="10" name="Slide number">
+            <a:extLst xmlns:a="http://schemas.openxmlformats.org/drawingml/2006/main">
+              <a:ext uri="{FF2B5EF4-FFF2-40B4-BE49-F238E27FC236}">
+                <a16:creationId xmlns:a16="http://schemas.microsoft.com/office/drawing/2014/main" id="{3B44BE11-DE70-43E6-BBCC-2B09BA37273B}"/>
+              </a:ext>
+            </a:extLst>
+          </p:cNvPr>
+          <p:cNvSpPr>
+            <a:spLocks xmlns:a="http://schemas.openxmlformats.org/drawingml/2006/main" noGrp="1"/>
+          </p:cNvSpPr>
+          <p:nvPr/>
+        </p:nvSpPr>
+        <p:spPr>
+          <a:xfrm xmlns:a="http://schemas.openxmlformats.org/drawingml/2006/main">
+            <a:off x="10953750" y="6467475"/>
+            <a:ext cx="628650" cy="190500"/>
+          </a:xfrm>
+          <a:prstGeom xmlns:a="http://schemas.openxmlformats.org/drawingml/2006/main" prst="rect">
+            <a:avLst/>
+          </a:prstGeom>
+          <a:noFill xmlns:a="http://schemas.openxmlformats.org/drawingml/2006/main"/>
+          <a:ln xmlns:a="http://schemas.openxmlformats.org/drawingml/2006/main" w="0">
+            <a:noFill/>
+            <a:prstDash val="solid"/>
+          </a:ln>
+        </p:spPr>
+        <p:txBody>
+          <a:bodyPr xmlns:a="http://schemas.openxmlformats.org/drawingml/2006/main" wrap="square" lIns="0" tIns="0" rIns="0" bIns="0" anchor="t">
+            <a:normAutofit fontScale="100000"/>
+          </a:bodyPr>
+          <a:lstStyle xmlns:a="http://schemas.openxmlformats.org/drawingml/2006/main">
+            <a:defPPr algn="r">
+              <a:defRPr sz="975">
+                <a:solidFill>
+                  <a:srgbClr val="C5CABC"/>
+                </a:solidFill>
+                <a:latin typeface="Helvetica Neue"/>
+                <a:ea typeface="Helvetica Neue"/>
+                <a:cs typeface="Helvetica Neue"/>
+              </a:defRPr>
+            </a:defPPr>
+            <a:lvl1pPr algn="r">
+              <a:defRPr sz="975">
+                <a:solidFill>
+                  <a:srgbClr val="C5CABC"/>
+                </a:solidFill>
+                <a:latin typeface="Helvetica Neue"/>
+                <a:ea typeface="Helvetica Neue"/>
+                <a:cs typeface="Helvetica Neue"/>
+              </a:defRPr>
+            </a:lvl1pPr>
+            <a:lvl2pPr algn="r">
+              <a:defRPr sz="975">
+                <a:solidFill>
+                  <a:srgbClr val="C5CABC"/>
+                </a:solidFill>
+                <a:latin typeface="Helvetica Neue"/>
+                <a:ea typeface="Helvetica Neue"/>
+                <a:cs typeface="Helvetica Neue"/>
+              </a:defRPr>
+            </a:lvl2pPr>
+            <a:lvl3pPr algn="r">
+              <a:defRPr sz="975">
+                <a:solidFill>
+                  <a:srgbClr val="C5CABC"/>
+                </a:solidFill>
+                <a:latin typeface="Helvetica Neue"/>
+                <a:ea typeface="Helvetica Neue"/>
+                <a:cs typeface="Helvetica Neue"/>
+              </a:defRPr>
+            </a:lvl3pPr>
+            <a:lvl4pPr algn="r">
+              <a:defRPr sz="975">
+                <a:solidFill>
+                  <a:srgbClr val="C5CABC"/>
+                </a:solidFill>
+                <a:latin typeface="Helvetica Neue"/>
+                <a:ea typeface="Helvetica Neue"/>
+                <a:cs typeface="Helvetica Neue"/>
+              </a:defRPr>
+            </a:lvl4pPr>
+            <a:lvl5pPr algn="r">
+              <a:defRPr sz="975">
+                <a:solidFill>
+                  <a:srgbClr val="C5CABC"/>
+                </a:solidFill>
+                <a:latin typeface="Helvetica Neue"/>
+                <a:ea typeface="Helvetica Neue"/>
+                <a:cs typeface="Helvetica Neue"/>
+              </a:defRPr>
+            </a:lvl5pPr>
+            <a:lvl6pPr algn="r">
+              <a:defRPr sz="975">
+                <a:solidFill>
+                  <a:srgbClr val="C5CABC"/>
+                </a:solidFill>
+                <a:latin typeface="Helvetica Neue"/>
+                <a:ea typeface="Helvetica Neue"/>
+                <a:cs typeface="Helvetica Neue"/>
+              </a:defRPr>
+            </a:lvl6pPr>
+            <a:lvl7pPr algn="r">
+              <a:defRPr sz="975">
+                <a:solidFill>
+                  <a:srgbClr val="C5CABC"/>
+                </a:solidFill>
+                <a:latin typeface="Helvetica Neue"/>
+                <a:ea typeface="Helvetica Neue"/>
+                <a:cs typeface="Helvetica Neue"/>
+              </a:defRPr>
+            </a:lvl7pPr>
+            <a:lvl8pPr algn="r">
+              <a:defRPr sz="975">
+                <a:solidFill>
+                  <a:srgbClr val="C5CABC"/>
+                </a:solidFill>
+                <a:latin typeface="Helvetica Neue"/>
+                <a:ea typeface="Helvetica Neue"/>
+                <a:cs typeface="Helvetica Neue"/>
+              </a:defRPr>
+            </a:lvl8pPr>
+            <a:lvl9pPr algn="r">
+              <a:defRPr sz="975">
+                <a:solidFill>
+                  <a:srgbClr val="C5CABC"/>
+                </a:solidFill>
+                <a:latin typeface="Helvetica Neue"/>
+                <a:ea typeface="Helvetica Neue"/>
+                <a:cs typeface="Helvetica Neue"/>
+              </a:defRPr>
+            </a:lvl9pPr>
+          </a:lstStyle>
+          <a:p xmlns:a="http://schemas.openxmlformats.org/drawingml/2006/main">
+            <a:pPr algn="r">
+              <a:defRPr sz="975">
+                <a:solidFill>
+                  <a:srgbClr val="C5CABC"/>
+                </a:solidFill>
+                <a:latin typeface="Helvetica Neue"/>
+                <a:ea typeface="Helvetica Neue"/>
+                <a:cs typeface="Helvetica Neue"/>
+              </a:defRPr>
+            </a:pPr>
+            <a:r>
+              <a:rPr sz="975">
+                <a:solidFill>
+                  <a:srgbClr val="C5CABC"/>
+                </a:solidFill>
+                <a:latin typeface="Helvetica Neue"/>
+                <a:ea typeface="Helvetica Neue"/>
+                <a:cs typeface="Helvetica Neue"/>
+              </a:rPr>
+              <a:t>2 / 6</a:t>
+            </a:r>
+          </a:p>
+        </p:txBody>
+      </p:sp>
+    </p:spTree>
+    <p:extLst>
+      <p:ext uri="{BB962C8B-B14F-4D97-AF65-F5344CB8AC3E}">
+        <p14:creationId xmlns:p14="http://schemas.microsoft.com/office/powerpoint/2010/main" val="790524231"/>
       </p:ext>
     </p:extLst>
   </p:cSld>

</xml_diff>

<commit_message>
Add decoder-depth screenshots and captions after the measurement trace
</commit_message>
<xml_diff>
--- a/docs/hackathon-pitch.pptx
+++ b/docs/hackathon-pitch.pptx
@@ -11,6 +11,8 @@
     <p:sldId xmlns:r="http://schemas.openxmlformats.org/officeDocument/2006/relationships" id="256" r:id="R660419e85dd74a48"/>
     <p:sldId xmlns:r="http://schemas.openxmlformats.org/officeDocument/2006/relationships" id="262" r:id="RisolatedDatacenter"/>
     <p:sldId xmlns:r="http://schemas.openxmlformats.org/officeDocument/2006/relationships" id="261" r:id="R52456b13680949ee"/>
+    <p:sldId xmlns:r="http://schemas.openxmlformats.org/officeDocument/2006/relationships" id="263" r:id="RdepthTraces"/>
+    <p:sldId xmlns:r="http://schemas.openxmlformats.org/officeDocument/2006/relationships" id="264" r:id="RdepthReadings"/>
     <p:sldId xmlns:r="http://schemas.openxmlformats.org/officeDocument/2006/relationships" id="257" r:id="Rfe21568811e04f53"/>
     <p:sldId xmlns:r="http://schemas.openxmlformats.org/officeDocument/2006/relationships" id="258" r:id="R1955cd6be8b14f23"/>
     <p:sldId xmlns:r="http://schemas.openxmlformats.org/officeDocument/2006/relationships" id="259" r:id="Rddb042aa9ef1403a"/>
@@ -852,6 +854,166 @@
 </p:notes>
 </file>
 
+<file path=ppt/notesSlides/notesSlide8.xml><?xml version="1.0" encoding="utf-8"?>
+<p:notes xmlns:p="http://schemas.openxmlformats.org/presentationml/2006/main">
+  <p:cSld>
+    <p:spTree>
+      <p:nvGrpSpPr>
+        <p:cNvPr id="1" name=""/>
+        <p:cNvGrpSpPr/>
+        <p:nvPr/>
+      </p:nvGrpSpPr>
+      <p:grpSpPr>
+        <a:xfrm xmlns:a="http://schemas.openxmlformats.org/drawingml/2006/main"/>
+      </p:grpSpPr>
+      <p:sp>
+        <p:nvSpPr>
+          <p:cNvPr id="2" name="Slide Image Placeholder 1"/>
+          <p:cNvSpPr>
+            <a:spLocks xmlns:a="http://schemas.openxmlformats.org/drawingml/2006/main" noGrp="1"/>
+          </p:cNvSpPr>
+          <p:nvPr>
+            <p:ph type="sldImg" idx="0"/>
+          </p:nvPr>
+        </p:nvSpPr>
+        <p:spPr/>
+      </p:sp>
+      <p:sp>
+        <p:nvSpPr>
+          <p:cNvPr id="3" name="Notes Placeholder 2"/>
+          <p:cNvSpPr>
+            <a:spLocks xmlns:a="http://schemas.openxmlformats.org/drawingml/2006/main" noGrp="1"/>
+          </p:cNvSpPr>
+          <p:nvPr>
+            <p:ph type="body" idx="1"/>
+          </p:nvPr>
+        </p:nvSpPr>
+        <p:spPr/>
+        <p:txBody>
+          <a:bodyPr xmlns:a="http://schemas.openxmlformats.org/drawingml/2006/main"/>
+          <a:lstStyle xmlns:a="http://schemas.openxmlformats.org/drawingml/2006/main"/>
+          <a:p xmlns:a="http://schemas.openxmlformats.org/drawingml/2006/main">
+            <a:r>
+              <a:t>User-supplied screenshot: decoder-depth-traces.jpg, placed as a single full-aspect image without cropping or recreating the curves.</a:t>
+            </a:r>
+          </a:p>
+          <a:p xmlns:a="http://schemas.openxmlformats.org/drawingml/2006/main">
+            <a:r>
+              <a:t>The top plot is apparent power in VA. Dashed lower curves are labeled estimated energy in J/token with PF = 1 assumed. The chart reports one selected trial and shows a bounded Catmull–Rom display.</a:t>
+            </a:r>
+          </a:p>
+          <a:p xmlns:a="http://schemas.openxmlformats.org/drawingml/2006/main">
+            <a:r>
+              <a:t>The screenshot does not report true power in W or measured energy in Wh. No raw time series or token counts were supplied.</a:t>
+            </a:r>
+          </a:p>
+        </p:txBody>
+      </p:sp>
+      <p:sp>
+        <p:nvSpPr>
+          <p:cNvPr id="4" name="Slide Number Placeholder 3"/>
+          <p:cNvSpPr>
+            <a:spLocks xmlns:a="http://schemas.openxmlformats.org/drawingml/2006/main" noGrp="1"/>
+          </p:cNvSpPr>
+          <p:nvPr>
+            <p:ph type="sldNum" idx="5"/>
+          </p:nvPr>
+        </p:nvSpPr>
+        <p:spPr/>
+        <p:txBody>
+          <a:bodyPr xmlns:a="http://schemas.openxmlformats.org/drawingml/2006/main"/>
+          <a:lstStyle xmlns:a="http://schemas.openxmlformats.org/drawingml/2006/main"/>
+          <a:p xmlns:a="http://schemas.openxmlformats.org/drawingml/2006/main"/>
+        </p:txBody>
+      </p:sp>
+    </p:spTree>
+  </p:cSld>
+  <p:clrMapOvr>
+    <a:masterClrMapping xmlns:a="http://schemas.openxmlformats.org/drawingml/2006/main"/>
+  </p:clrMapOvr>
+</p:notes>
+</file>
+
+<file path=ppt/notesSlides/notesSlide9.xml><?xml version="1.0" encoding="utf-8"?>
+<p:notes xmlns:p="http://schemas.openxmlformats.org/presentationml/2006/main">
+  <p:cSld>
+    <p:spTree>
+      <p:nvGrpSpPr>
+        <p:cNvPr id="1" name=""/>
+        <p:cNvGrpSpPr/>
+        <p:nvPr/>
+      </p:nvGrpSpPr>
+      <p:grpSpPr>
+        <a:xfrm xmlns:a="http://schemas.openxmlformats.org/drawingml/2006/main"/>
+      </p:grpSpPr>
+      <p:sp>
+        <p:nvSpPr>
+          <p:cNvPr id="2" name="Slide Image Placeholder 1"/>
+          <p:cNvSpPr>
+            <a:spLocks xmlns:a="http://schemas.openxmlformats.org/drawingml/2006/main" noGrp="1"/>
+          </p:cNvSpPr>
+          <p:nvPr>
+            <p:ph type="sldImg" idx="0"/>
+          </p:nvPr>
+        </p:nvSpPr>
+        <p:spPr/>
+      </p:sp>
+      <p:sp>
+        <p:nvSpPr>
+          <p:cNvPr id="3" name="Notes Placeholder 2"/>
+          <p:cNvSpPr>
+            <a:spLocks xmlns:a="http://schemas.openxmlformats.org/drawingml/2006/main" noGrp="1"/>
+          </p:cNvSpPr>
+          <p:nvPr>
+            <p:ph type="body" idx="1"/>
+          </p:nvPr>
+        </p:nvSpPr>
+        <p:spPr/>
+        <p:txBody>
+          <a:bodyPr xmlns:a="http://schemas.openxmlformats.org/drawingml/2006/main"/>
+          <a:lstStyle xmlns:a="http://schemas.openxmlformats.org/drawingml/2006/main"/>
+          <a:p xmlns:a="http://schemas.openxmlformats.org/drawingml/2006/main">
+            <a:r>
+              <a:t>User-supplied screenshot: decoder-depth-batch-readings.jpg, displayed as a full-aspect image.</a:t>
+            </a:r>
+          </a:p>
+          <a:p xmlns:a="http://schemas.openxmlformats.org/drawingml/2006/main">
+            <a:r>
+              <a:t>The screenshot labels these as UT61B circuit, selected-trial reported summaries. It shows 16-layer, 32-layer, depth48-before and depth48-after runs. Displayed J/token ratios are estimates assuming PF = 1; VA and VA·s are apparent quantities.</a:t>
+            </a:r>
+          </a:p>
+          <a:p xmlns:a="http://schemas.openxmlformats.org/drawingml/2006/main">
+            <a:r>
+              <a:t>Run durations differ and quality results are not shown. The slide does not claim measured real energy in Wh, verified savings, or results beyond this selected trial.</a:t>
+            </a:r>
+          </a:p>
+        </p:txBody>
+      </p:sp>
+      <p:sp>
+        <p:nvSpPr>
+          <p:cNvPr id="4" name="Slide Number Placeholder 3"/>
+          <p:cNvSpPr>
+            <a:spLocks xmlns:a="http://schemas.openxmlformats.org/drawingml/2006/main" noGrp="1"/>
+          </p:cNvSpPr>
+          <p:nvPr>
+            <p:ph type="sldNum" idx="5"/>
+          </p:nvPr>
+        </p:nvSpPr>
+        <p:spPr/>
+        <p:txBody>
+          <a:bodyPr xmlns:a="http://schemas.openxmlformats.org/drawingml/2006/main"/>
+          <a:lstStyle xmlns:a="http://schemas.openxmlformats.org/drawingml/2006/main"/>
+          <a:p xmlns:a="http://schemas.openxmlformats.org/drawingml/2006/main"/>
+        </p:txBody>
+      </p:sp>
+    </p:spTree>
+  </p:cSld>
+  <p:clrMapOvr>
+    <a:masterClrMapping xmlns:a="http://schemas.openxmlformats.org/drawingml/2006/main"/>
+  </p:clrMapOvr>
+</p:notes>
+</file>
+
 <file path=ppt/slideLayouts/slideLayout1.xml><?xml version="1.0" encoding="utf-8"?>
 <p:sldLayout xmlns:p="http://schemas.openxmlformats.org/presentationml/2006/main" type="title">
   <p:cSld name="Title Slide">
@@ -5749,7 +5911,7 @@
                 <a:ea typeface="Helvetica Neue"/>
                 <a:cs typeface="Helvetica Neue"/>
               </a:rPr>
-              <a:t>4 / 6</a:t>
+              <a:t>6 / 8</a:t>
             </a:r>
           </a:p>
         </p:txBody>
@@ -7204,7 +7366,7 @@
                 <a:ea typeface="Helvetica Neue"/>
                 <a:cs typeface="Helvetica Neue"/>
               </a:rPr>
-              <a:t>5 / 6</a:t>
+              <a:t>7 / 8</a:t>
             </a:r>
           </a:p>
         </p:txBody>
@@ -8949,7 +9111,7 @@
                 <a:ea typeface="Helvetica Neue"/>
                 <a:cs typeface="Helvetica Neue"/>
               </a:rPr>
-              <a:t>6 / 6</a:t>
+              <a:t>8 / 8</a:t>
             </a:r>
           </a:p>
         </p:txBody>
@@ -12066,7 +12228,7 @@
                 <a:ea typeface="Helvetica Neue"/>
                 <a:cs typeface="Helvetica Neue"/>
               </a:rPr>
-              <a:t>2 / 6</a:t>
+              <a:t>2 / 8</a:t>
             </a:r>
           </a:p>
         </p:txBody>
@@ -12075,6 +12237,1869 @@
     <p:extLst>
       <p:ext uri="{BB962C8B-B14F-4D97-AF65-F5344CB8AC3E}">
         <p14:creationId xmlns:p14="http://schemas.microsoft.com/office/powerpoint/2010/main" val="790524231"/>
+      </p:ext>
+    </p:extLst>
+  </p:cSld>
+</p:sld>
+</file>
+
+<file path=ppt/slides/slide8.xml><?xml version="1.0" encoding="utf-8"?>
+<p:sld xmlns:p="http://schemas.openxmlformats.org/presentationml/2006/main">
+  <p:cSld>
+    <p:bg>
+      <p:bgPr>
+        <a:solidFill xmlns:a="http://schemas.openxmlformats.org/drawingml/2006/main">
+          <a:srgbClr val="181B18"/>
+        </a:solidFill>
+      </p:bgPr>
+    </p:bg>
+    <p:spTree>
+      <p:nvGrpSpPr>
+        <p:cNvPr id="1" name=""/>
+        <p:cNvGrpSpPr/>
+        <p:nvPr/>
+      </p:nvGrpSpPr>
+      <p:grpSpPr>
+        <a:xfrm xmlns:a="http://schemas.openxmlformats.org/drawingml/2006/main"/>
+      </p:grpSpPr>
+      <p:sp>
+        <p:nvSpPr>
+          <p:cNvPr id="7" name="Decoder-layer comparison context label">
+            <a:extLst xmlns:a="http://schemas.openxmlformats.org/drawingml/2006/main">
+              <a:ext uri="{FF2B5EF4-FFF2-40B4-BE49-F238E27FC236}">
+                <a16:creationId xmlns:a16="http://schemas.microsoft.com/office/drawing/2014/main" id="{2FECC6D0-C717-455D-B240-DD3D764E3721}"/>
+              </a:ext>
+            </a:extLst>
+          </p:cNvPr>
+          <p:cNvSpPr>
+            <a:spLocks xmlns:a="http://schemas.openxmlformats.org/drawingml/2006/main" noGrp="1"/>
+          </p:cNvSpPr>
+          <p:nvPr/>
+        </p:nvSpPr>
+        <p:spPr>
+          <a:xfrm xmlns:a="http://schemas.openxmlformats.org/drawingml/2006/main">
+            <a:off x="609600" y="361950"/>
+            <a:ext cx="4762500" cy="238125"/>
+          </a:xfrm>
+          <a:prstGeom xmlns:a="http://schemas.openxmlformats.org/drawingml/2006/main" prst="rect">
+            <a:avLst/>
+          </a:prstGeom>
+          <a:noFill xmlns:a="http://schemas.openxmlformats.org/drawingml/2006/main"/>
+          <a:ln xmlns:a="http://schemas.openxmlformats.org/drawingml/2006/main" w="0">
+            <a:noFill/>
+            <a:prstDash val="solid"/>
+          </a:ln>
+        </p:spPr>
+        <p:txBody>
+          <a:bodyPr xmlns:a="http://schemas.openxmlformats.org/drawingml/2006/main" wrap="square" lIns="0" tIns="0" rIns="0" bIns="0" anchor="t">
+            <a:normAutofit fontScale="100000"/>
+          </a:bodyPr>
+          <a:lstStyle xmlns:a="http://schemas.openxmlformats.org/drawingml/2006/main">
+            <a:defPPr algn="l">
+              <a:defRPr sz="1275" b="1">
+                <a:solidFill>
+                  <a:srgbClr val="D8B44E"/>
+                </a:solidFill>
+                <a:latin typeface="Helvetica Neue"/>
+                <a:ea typeface="Helvetica Neue"/>
+                <a:cs typeface="Helvetica Neue"/>
+              </a:defRPr>
+            </a:defPPr>
+            <a:lvl1pPr algn="l">
+              <a:defRPr sz="1275" b="1">
+                <a:solidFill>
+                  <a:srgbClr val="D8B44E"/>
+                </a:solidFill>
+                <a:latin typeface="Helvetica Neue"/>
+                <a:ea typeface="Helvetica Neue"/>
+                <a:cs typeface="Helvetica Neue"/>
+              </a:defRPr>
+            </a:lvl1pPr>
+            <a:lvl2pPr algn="l">
+              <a:defRPr sz="1275" b="1">
+                <a:solidFill>
+                  <a:srgbClr val="D8B44E"/>
+                </a:solidFill>
+                <a:latin typeface="Helvetica Neue"/>
+                <a:ea typeface="Helvetica Neue"/>
+                <a:cs typeface="Helvetica Neue"/>
+              </a:defRPr>
+            </a:lvl2pPr>
+            <a:lvl3pPr algn="l">
+              <a:defRPr sz="1275" b="1">
+                <a:solidFill>
+                  <a:srgbClr val="D8B44E"/>
+                </a:solidFill>
+                <a:latin typeface="Helvetica Neue"/>
+                <a:ea typeface="Helvetica Neue"/>
+                <a:cs typeface="Helvetica Neue"/>
+              </a:defRPr>
+            </a:lvl3pPr>
+            <a:lvl4pPr algn="l">
+              <a:defRPr sz="1275" b="1">
+                <a:solidFill>
+                  <a:srgbClr val="D8B44E"/>
+                </a:solidFill>
+                <a:latin typeface="Helvetica Neue"/>
+                <a:ea typeface="Helvetica Neue"/>
+                <a:cs typeface="Helvetica Neue"/>
+              </a:defRPr>
+            </a:lvl4pPr>
+            <a:lvl5pPr algn="l">
+              <a:defRPr sz="1275" b="1">
+                <a:solidFill>
+                  <a:srgbClr val="D8B44E"/>
+                </a:solidFill>
+                <a:latin typeface="Helvetica Neue"/>
+                <a:ea typeface="Helvetica Neue"/>
+                <a:cs typeface="Helvetica Neue"/>
+              </a:defRPr>
+            </a:lvl5pPr>
+            <a:lvl6pPr algn="l">
+              <a:defRPr sz="1275" b="1">
+                <a:solidFill>
+                  <a:srgbClr val="D8B44E"/>
+                </a:solidFill>
+                <a:latin typeface="Helvetica Neue"/>
+                <a:ea typeface="Helvetica Neue"/>
+                <a:cs typeface="Helvetica Neue"/>
+              </a:defRPr>
+            </a:lvl6pPr>
+            <a:lvl7pPr algn="l">
+              <a:defRPr sz="1275" b="1">
+                <a:solidFill>
+                  <a:srgbClr val="D8B44E"/>
+                </a:solidFill>
+                <a:latin typeface="Helvetica Neue"/>
+                <a:ea typeface="Helvetica Neue"/>
+                <a:cs typeface="Helvetica Neue"/>
+              </a:defRPr>
+            </a:lvl7pPr>
+            <a:lvl8pPr algn="l">
+              <a:defRPr sz="1275" b="1">
+                <a:solidFill>
+                  <a:srgbClr val="D8B44E"/>
+                </a:solidFill>
+                <a:latin typeface="Helvetica Neue"/>
+                <a:ea typeface="Helvetica Neue"/>
+                <a:cs typeface="Helvetica Neue"/>
+              </a:defRPr>
+            </a:lvl8pPr>
+            <a:lvl9pPr algn="l">
+              <a:defRPr sz="1275" b="1">
+                <a:solidFill>
+                  <a:srgbClr val="D8B44E"/>
+                </a:solidFill>
+                <a:latin typeface="Helvetica Neue"/>
+                <a:ea typeface="Helvetica Neue"/>
+                <a:cs typeface="Helvetica Neue"/>
+              </a:defRPr>
+            </a:lvl9pPr>
+          </a:lstStyle>
+          <a:p xmlns:a="http://schemas.openxmlformats.org/drawingml/2006/main">
+            <a:pPr algn="l">
+              <a:defRPr sz="1275" b="1">
+                <a:solidFill>
+                  <a:srgbClr val="D8B44E"/>
+                </a:solidFill>
+                <a:latin typeface="Helvetica Neue"/>
+                <a:ea typeface="Helvetica Neue"/>
+                <a:cs typeface="Helvetica Neue"/>
+              </a:defRPr>
+            </a:pPr>
+            <a:r>
+              <a:rPr sz="1275" b="1">
+                <a:solidFill>
+                  <a:srgbClr val="D8B44E"/>
+                </a:solidFill>
+                <a:latin typeface="Helvetica Neue"/>
+                <a:ea typeface="Helvetica Neue"/>
+                <a:cs typeface="Helvetica Neue"/>
+              </a:rPr>
+              <a:t>TRIAL 1</a:t>
+            </a:r>
+          </a:p>
+        </p:txBody>
+      </p:sp>
+      <p:sp>
+        <p:nvSpPr>
+          <p:cNvPr id="2" name="Decoder-layer comparison title">
+            <a:extLst xmlns:a="http://schemas.openxmlformats.org/drawingml/2006/main">
+              <a:ext uri="{FF2B5EF4-FFF2-40B4-BE49-F238E27FC236}">
+                <a16:creationId xmlns:a16="http://schemas.microsoft.com/office/drawing/2014/main" id="{CBFC54FF-42E2-4371-B234-4F84C569E9FC}"/>
+              </a:ext>
+            </a:extLst>
+          </p:cNvPr>
+          <p:cNvSpPr>
+            <a:spLocks xmlns:a="http://schemas.openxmlformats.org/drawingml/2006/main" noGrp="1"/>
+          </p:cNvSpPr>
+          <p:nvPr/>
+        </p:nvSpPr>
+        <p:spPr>
+          <a:xfrm xmlns:a="http://schemas.openxmlformats.org/drawingml/2006/main">
+            <a:off x="609600" y="733425"/>
+            <a:ext cx="4762500" cy="504825"/>
+          </a:xfrm>
+          <a:prstGeom xmlns:a="http://schemas.openxmlformats.org/drawingml/2006/main" prst="rect">
+            <a:avLst/>
+          </a:prstGeom>
+          <a:noFill xmlns:a="http://schemas.openxmlformats.org/drawingml/2006/main"/>
+          <a:ln xmlns:a="http://schemas.openxmlformats.org/drawingml/2006/main" w="0">
+            <a:noFill/>
+            <a:prstDash val="solid"/>
+          </a:ln>
+        </p:spPr>
+        <p:txBody>
+          <a:bodyPr xmlns:a="http://schemas.openxmlformats.org/drawingml/2006/main" wrap="square" lIns="0" tIns="0" rIns="0" bIns="0" anchor="t">
+            <a:normAutofit fontScale="100000"/>
+          </a:bodyPr>
+          <a:lstStyle xmlns:a="http://schemas.openxmlformats.org/drawingml/2006/main">
+            <a:defPPr algn="l">
+              <a:defRPr sz="2625" b="1">
+                <a:solidFill>
+                  <a:srgbClr val="F2F0E5"/>
+                </a:solidFill>
+                <a:latin typeface="Helvetica Neue"/>
+                <a:ea typeface="Helvetica Neue"/>
+                <a:cs typeface="Helvetica Neue"/>
+              </a:defRPr>
+            </a:defPPr>
+            <a:lvl1pPr algn="l">
+              <a:defRPr sz="2625" b="1">
+                <a:solidFill>
+                  <a:srgbClr val="F2F0E5"/>
+                </a:solidFill>
+                <a:latin typeface="Helvetica Neue"/>
+                <a:ea typeface="Helvetica Neue"/>
+                <a:cs typeface="Helvetica Neue"/>
+              </a:defRPr>
+            </a:lvl1pPr>
+            <a:lvl2pPr algn="l">
+              <a:defRPr sz="2625" b="1">
+                <a:solidFill>
+                  <a:srgbClr val="F2F0E5"/>
+                </a:solidFill>
+                <a:latin typeface="Helvetica Neue"/>
+                <a:ea typeface="Helvetica Neue"/>
+                <a:cs typeface="Helvetica Neue"/>
+              </a:defRPr>
+            </a:lvl2pPr>
+            <a:lvl3pPr algn="l">
+              <a:defRPr sz="2625" b="1">
+                <a:solidFill>
+                  <a:srgbClr val="F2F0E5"/>
+                </a:solidFill>
+                <a:latin typeface="Helvetica Neue"/>
+                <a:ea typeface="Helvetica Neue"/>
+                <a:cs typeface="Helvetica Neue"/>
+              </a:defRPr>
+            </a:lvl3pPr>
+            <a:lvl4pPr algn="l">
+              <a:defRPr sz="2625" b="1">
+                <a:solidFill>
+                  <a:srgbClr val="F2F0E5"/>
+                </a:solidFill>
+                <a:latin typeface="Helvetica Neue"/>
+                <a:ea typeface="Helvetica Neue"/>
+                <a:cs typeface="Helvetica Neue"/>
+              </a:defRPr>
+            </a:lvl4pPr>
+            <a:lvl5pPr algn="l">
+              <a:defRPr sz="2625" b="1">
+                <a:solidFill>
+                  <a:srgbClr val="F2F0E5"/>
+                </a:solidFill>
+                <a:latin typeface="Helvetica Neue"/>
+                <a:ea typeface="Helvetica Neue"/>
+                <a:cs typeface="Helvetica Neue"/>
+              </a:defRPr>
+            </a:lvl5pPr>
+            <a:lvl6pPr algn="l">
+              <a:defRPr sz="2625" b="1">
+                <a:solidFill>
+                  <a:srgbClr val="F2F0E5"/>
+                </a:solidFill>
+                <a:latin typeface="Helvetica Neue"/>
+                <a:ea typeface="Helvetica Neue"/>
+                <a:cs typeface="Helvetica Neue"/>
+              </a:defRPr>
+            </a:lvl6pPr>
+            <a:lvl7pPr algn="l">
+              <a:defRPr sz="2625" b="1">
+                <a:solidFill>
+                  <a:srgbClr val="F2F0E5"/>
+                </a:solidFill>
+                <a:latin typeface="Helvetica Neue"/>
+                <a:ea typeface="Helvetica Neue"/>
+                <a:cs typeface="Helvetica Neue"/>
+              </a:defRPr>
+            </a:lvl7pPr>
+            <a:lvl8pPr algn="l">
+              <a:defRPr sz="2625" b="1">
+                <a:solidFill>
+                  <a:srgbClr val="F2F0E5"/>
+                </a:solidFill>
+                <a:latin typeface="Helvetica Neue"/>
+                <a:ea typeface="Helvetica Neue"/>
+                <a:cs typeface="Helvetica Neue"/>
+              </a:defRPr>
+            </a:lvl8pPr>
+            <a:lvl9pPr algn="l">
+              <a:defRPr sz="2625" b="1">
+                <a:solidFill>
+                  <a:srgbClr val="F2F0E5"/>
+                </a:solidFill>
+                <a:latin typeface="Helvetica Neue"/>
+                <a:ea typeface="Helvetica Neue"/>
+                <a:cs typeface="Helvetica Neue"/>
+              </a:defRPr>
+            </a:lvl9pPr>
+          </a:lstStyle>
+          <a:p xmlns:a="http://schemas.openxmlformats.org/drawingml/2006/main">
+            <a:pPr algn="l">
+              <a:defRPr sz="2625" b="1">
+                <a:solidFill>
+                  <a:srgbClr val="F2F0E5"/>
+                </a:solidFill>
+                <a:latin typeface="Helvetica Neue"/>
+                <a:ea typeface="Helvetica Neue"/>
+                <a:cs typeface="Helvetica Neue"/>
+              </a:defRPr>
+            </a:pPr>
+            <a:r>
+              <a:rPr sz="2625" b="1">
+                <a:solidFill>
+                  <a:srgbClr val="F2F0E5"/>
+                </a:solidFill>
+                <a:latin typeface="Helvetica Neue"/>
+                <a:ea typeface="Helvetica Neue"/>
+                <a:cs typeface="Helvetica Neue"/>
+              </a:rPr>
+              <a:t>Decoder-layer comparison</a:t>
+            </a:r>
+          </a:p>
+        </p:txBody>
+      </p:sp>
+      <p:sp>
+        <p:nvSpPr>
+          <p:cNvPr id="3" name="Decoder-layer comparison caption">
+            <a:extLst xmlns:a="http://schemas.openxmlformats.org/drawingml/2006/main">
+              <a:ext uri="{FF2B5EF4-FFF2-40B4-BE49-F238E27FC236}">
+                <a16:creationId xmlns:a16="http://schemas.microsoft.com/office/drawing/2014/main" id="{31590791-C553-4A01-B2C3-1EB727C5EB58}"/>
+              </a:ext>
+            </a:extLst>
+          </p:cNvPr>
+          <p:cNvSpPr>
+            <a:spLocks xmlns:a="http://schemas.openxmlformats.org/drawingml/2006/main" noGrp="1"/>
+          </p:cNvSpPr>
+          <p:nvPr/>
+        </p:nvSpPr>
+        <p:spPr>
+          <a:xfrm xmlns:a="http://schemas.openxmlformats.org/drawingml/2006/main">
+            <a:off x="609600" y="1581150"/>
+            <a:ext cx="4762500" cy="2305050"/>
+          </a:xfrm>
+          <a:prstGeom xmlns:a="http://schemas.openxmlformats.org/drawingml/2006/main" prst="rect">
+            <a:avLst/>
+          </a:prstGeom>
+          <a:noFill xmlns:a="http://schemas.openxmlformats.org/drawingml/2006/main"/>
+          <a:ln xmlns:a="http://schemas.openxmlformats.org/drawingml/2006/main" w="0">
+            <a:noFill/>
+            <a:prstDash val="solid"/>
+          </a:ln>
+        </p:spPr>
+        <p:txBody>
+          <a:bodyPr xmlns:a="http://schemas.openxmlformats.org/drawingml/2006/main" wrap="square" lIns="0" tIns="0" rIns="0" bIns="0" anchor="t">
+            <a:normAutofit fontScale="100000"/>
+          </a:bodyPr>
+          <a:lstStyle xmlns:a="http://schemas.openxmlformats.org/drawingml/2006/main">
+            <a:defPPr algn="l">
+              <a:defRPr sz="1800">
+                <a:solidFill>
+                  <a:srgbClr val="F2F0E5"/>
+                </a:solidFill>
+                <a:latin typeface="Helvetica Neue"/>
+                <a:ea typeface="Helvetica Neue"/>
+                <a:cs typeface="Helvetica Neue"/>
+              </a:defRPr>
+            </a:defPPr>
+            <a:lvl1pPr algn="l">
+              <a:defRPr sz="1800">
+                <a:solidFill>
+                  <a:srgbClr val="F2F0E5"/>
+                </a:solidFill>
+                <a:latin typeface="Helvetica Neue"/>
+                <a:ea typeface="Helvetica Neue"/>
+                <a:cs typeface="Helvetica Neue"/>
+              </a:defRPr>
+            </a:lvl1pPr>
+            <a:lvl2pPr algn="l">
+              <a:defRPr sz="1800">
+                <a:solidFill>
+                  <a:srgbClr val="F2F0E5"/>
+                </a:solidFill>
+                <a:latin typeface="Helvetica Neue"/>
+                <a:ea typeface="Helvetica Neue"/>
+                <a:cs typeface="Helvetica Neue"/>
+              </a:defRPr>
+            </a:lvl2pPr>
+            <a:lvl3pPr algn="l">
+              <a:defRPr sz="1800">
+                <a:solidFill>
+                  <a:srgbClr val="F2F0E5"/>
+                </a:solidFill>
+                <a:latin typeface="Helvetica Neue"/>
+                <a:ea typeface="Helvetica Neue"/>
+                <a:cs typeface="Helvetica Neue"/>
+              </a:defRPr>
+            </a:lvl3pPr>
+            <a:lvl4pPr algn="l">
+              <a:defRPr sz="1800">
+                <a:solidFill>
+                  <a:srgbClr val="F2F0E5"/>
+                </a:solidFill>
+                <a:latin typeface="Helvetica Neue"/>
+                <a:ea typeface="Helvetica Neue"/>
+                <a:cs typeface="Helvetica Neue"/>
+              </a:defRPr>
+            </a:lvl4pPr>
+            <a:lvl5pPr algn="l">
+              <a:defRPr sz="1800">
+                <a:solidFill>
+                  <a:srgbClr val="F2F0E5"/>
+                </a:solidFill>
+                <a:latin typeface="Helvetica Neue"/>
+                <a:ea typeface="Helvetica Neue"/>
+                <a:cs typeface="Helvetica Neue"/>
+              </a:defRPr>
+            </a:lvl5pPr>
+            <a:lvl6pPr algn="l">
+              <a:defRPr sz="1800">
+                <a:solidFill>
+                  <a:srgbClr val="F2F0E5"/>
+                </a:solidFill>
+                <a:latin typeface="Helvetica Neue"/>
+                <a:ea typeface="Helvetica Neue"/>
+                <a:cs typeface="Helvetica Neue"/>
+              </a:defRPr>
+            </a:lvl6pPr>
+            <a:lvl7pPr algn="l">
+              <a:defRPr sz="1800">
+                <a:solidFill>
+                  <a:srgbClr val="F2F0E5"/>
+                </a:solidFill>
+                <a:latin typeface="Helvetica Neue"/>
+                <a:ea typeface="Helvetica Neue"/>
+                <a:cs typeface="Helvetica Neue"/>
+              </a:defRPr>
+            </a:lvl7pPr>
+            <a:lvl8pPr algn="l">
+              <a:defRPr sz="1800">
+                <a:solidFill>
+                  <a:srgbClr val="F2F0E5"/>
+                </a:solidFill>
+                <a:latin typeface="Helvetica Neue"/>
+                <a:ea typeface="Helvetica Neue"/>
+                <a:cs typeface="Helvetica Neue"/>
+              </a:defRPr>
+            </a:lvl8pPr>
+            <a:lvl9pPr algn="l">
+              <a:defRPr sz="1800">
+                <a:solidFill>
+                  <a:srgbClr val="F2F0E5"/>
+                </a:solidFill>
+                <a:latin typeface="Helvetica Neue"/>
+                <a:ea typeface="Helvetica Neue"/>
+                <a:cs typeface="Helvetica Neue"/>
+              </a:defRPr>
+            </a:lvl9pPr>
+          </a:lstStyle>
+          <a:p xmlns:a="http://schemas.openxmlformats.org/drawingml/2006/main">
+            <a:pPr algn="l">
+              <a:defRPr sz="1800">
+                <a:solidFill>
+                  <a:srgbClr val="F2F0E5"/>
+                </a:solidFill>
+                <a:latin typeface="Helvetica Neue"/>
+                <a:ea typeface="Helvetica Neue"/>
+                <a:cs typeface="Helvetica Neue"/>
+              </a:defRPr>
+            </a:pPr>
+            <a:r>
+              <a:rPr sz="1800">
+                <a:solidFill>
+                  <a:srgbClr val="F2F0E5"/>
+                </a:solidFill>
+                <a:latin typeface="Helvetica Neue"/>
+                <a:ea typeface="Helvetica Neue"/>
+                <a:cs typeface="Helvetica Neue"/>
+              </a:rPr>
+              <a:t>Trial 1 compares 16-, 32- and 48-layer configurations, including a repeat 48-layer run. Solid curves show apparent power (VA). Dashed curves show estimated J/token assuming PF = 1.</a:t>
+            </a:r>
+          </a:p>
+        </p:txBody>
+      </p:sp>
+      <p:pic>
+        <p:nvPicPr>
+          <p:cNvPr id="4" name="Decoder-layer comparison source screenshot">
+            <a:extLst xmlns:a="http://schemas.openxmlformats.org/drawingml/2006/main">
+              <a:ext uri="{FF2B5EF4-FFF2-40B4-BE49-F238E27FC236}">
+                <a16:creationId xmlns:a16="http://schemas.microsoft.com/office/drawing/2014/main" id="{7F2BC981-8403-4AAD-98C8-6327D0905C04}"/>
+              </a:ext>
+            </a:extLst>
+          </p:cNvPr>
+          <p:cNvPicPr>
+            <a:picLocks xmlns:a="http://schemas.openxmlformats.org/drawingml/2006/main" noChangeAspect="1"/>
+          </p:cNvPicPr>
+          <p:nvPr/>
+        </p:nvPicPr>
+        <p:blipFill>
+          <a:blip xmlns:r="http://schemas.openxmlformats.org/officeDocument/2006/relationships" xmlns:a="http://schemas.openxmlformats.org/drawingml/2006/main" r:embed="R083f007eaa4e4b85"/>
+          <a:stretch xmlns:a="http://schemas.openxmlformats.org/drawingml/2006/main"/>
+        </p:blipFill>
+        <p:spPr>
+          <a:xfrm xmlns:a="http://schemas.openxmlformats.org/drawingml/2006/main">
+            <a:off x="5857875" y="381557"/>
+            <a:ext cx="5715000" cy="5942486"/>
+          </a:xfrm>
+          <a:prstGeom xmlns:a="http://schemas.openxmlformats.org/drawingml/2006/main" prst="rect">
+            <a:avLst/>
+          </a:prstGeom>
+        </p:spPr>
+      </p:pic>
+      <p:sp>
+        <p:nvSpPr>
+          <p:cNvPr id="5" name="Project footer">
+            <a:extLst xmlns:a="http://schemas.openxmlformats.org/drawingml/2006/main">
+              <a:ext uri="{FF2B5EF4-FFF2-40B4-BE49-F238E27FC236}">
+                <a16:creationId xmlns:a16="http://schemas.microsoft.com/office/drawing/2014/main" id="{B4087F20-7360-4A10-9733-4BDDDC918045}"/>
+              </a:ext>
+            </a:extLst>
+          </p:cNvPr>
+          <p:cNvSpPr>
+            <a:spLocks xmlns:a="http://schemas.openxmlformats.org/drawingml/2006/main" noGrp="1"/>
+          </p:cNvSpPr>
+          <p:nvPr/>
+        </p:nvSpPr>
+        <p:spPr>
+          <a:xfrm xmlns:a="http://schemas.openxmlformats.org/drawingml/2006/main">
+            <a:off x="609600" y="6467475"/>
+            <a:ext cx="4953000" cy="190500"/>
+          </a:xfrm>
+          <a:prstGeom xmlns:a="http://schemas.openxmlformats.org/drawingml/2006/main" prst="rect">
+            <a:avLst/>
+          </a:prstGeom>
+          <a:noFill xmlns:a="http://schemas.openxmlformats.org/drawingml/2006/main"/>
+          <a:ln xmlns:a="http://schemas.openxmlformats.org/drawingml/2006/main" w="0">
+            <a:noFill/>
+            <a:prstDash val="solid"/>
+          </a:ln>
+        </p:spPr>
+        <p:txBody>
+          <a:bodyPr xmlns:a="http://schemas.openxmlformats.org/drawingml/2006/main" wrap="square" lIns="0" tIns="0" rIns="0" bIns="0" anchor="t">
+            <a:normAutofit fontScale="100000"/>
+          </a:bodyPr>
+          <a:lstStyle xmlns:a="http://schemas.openxmlformats.org/drawingml/2006/main">
+            <a:defPPr algn="l">
+              <a:defRPr sz="975">
+                <a:solidFill>
+                  <a:srgbClr val="C5CABC"/>
+                </a:solidFill>
+                <a:latin typeface="Helvetica Neue"/>
+                <a:ea typeface="Helvetica Neue"/>
+                <a:cs typeface="Helvetica Neue"/>
+              </a:defRPr>
+            </a:defPPr>
+            <a:lvl1pPr algn="l">
+              <a:defRPr sz="975">
+                <a:solidFill>
+                  <a:srgbClr val="C5CABC"/>
+                </a:solidFill>
+                <a:latin typeface="Helvetica Neue"/>
+                <a:ea typeface="Helvetica Neue"/>
+                <a:cs typeface="Helvetica Neue"/>
+              </a:defRPr>
+            </a:lvl1pPr>
+            <a:lvl2pPr algn="l">
+              <a:defRPr sz="975">
+                <a:solidFill>
+                  <a:srgbClr val="C5CABC"/>
+                </a:solidFill>
+                <a:latin typeface="Helvetica Neue"/>
+                <a:ea typeface="Helvetica Neue"/>
+                <a:cs typeface="Helvetica Neue"/>
+              </a:defRPr>
+            </a:lvl2pPr>
+            <a:lvl3pPr algn="l">
+              <a:defRPr sz="975">
+                <a:solidFill>
+                  <a:srgbClr val="C5CABC"/>
+                </a:solidFill>
+                <a:latin typeface="Helvetica Neue"/>
+                <a:ea typeface="Helvetica Neue"/>
+                <a:cs typeface="Helvetica Neue"/>
+              </a:defRPr>
+            </a:lvl3pPr>
+            <a:lvl4pPr algn="l">
+              <a:defRPr sz="975">
+                <a:solidFill>
+                  <a:srgbClr val="C5CABC"/>
+                </a:solidFill>
+                <a:latin typeface="Helvetica Neue"/>
+                <a:ea typeface="Helvetica Neue"/>
+                <a:cs typeface="Helvetica Neue"/>
+              </a:defRPr>
+            </a:lvl4pPr>
+            <a:lvl5pPr algn="l">
+              <a:defRPr sz="975">
+                <a:solidFill>
+                  <a:srgbClr val="C5CABC"/>
+                </a:solidFill>
+                <a:latin typeface="Helvetica Neue"/>
+                <a:ea typeface="Helvetica Neue"/>
+                <a:cs typeface="Helvetica Neue"/>
+              </a:defRPr>
+            </a:lvl5pPr>
+            <a:lvl6pPr algn="l">
+              <a:defRPr sz="975">
+                <a:solidFill>
+                  <a:srgbClr val="C5CABC"/>
+                </a:solidFill>
+                <a:latin typeface="Helvetica Neue"/>
+                <a:ea typeface="Helvetica Neue"/>
+                <a:cs typeface="Helvetica Neue"/>
+              </a:defRPr>
+            </a:lvl6pPr>
+            <a:lvl7pPr algn="l">
+              <a:defRPr sz="975">
+                <a:solidFill>
+                  <a:srgbClr val="C5CABC"/>
+                </a:solidFill>
+                <a:latin typeface="Helvetica Neue"/>
+                <a:ea typeface="Helvetica Neue"/>
+                <a:cs typeface="Helvetica Neue"/>
+              </a:defRPr>
+            </a:lvl7pPr>
+            <a:lvl8pPr algn="l">
+              <a:defRPr sz="975">
+                <a:solidFill>
+                  <a:srgbClr val="C5CABC"/>
+                </a:solidFill>
+                <a:latin typeface="Helvetica Neue"/>
+                <a:ea typeface="Helvetica Neue"/>
+                <a:cs typeface="Helvetica Neue"/>
+              </a:defRPr>
+            </a:lvl8pPr>
+            <a:lvl9pPr algn="l">
+              <a:defRPr sz="975">
+                <a:solidFill>
+                  <a:srgbClr val="C5CABC"/>
+                </a:solidFill>
+                <a:latin typeface="Helvetica Neue"/>
+                <a:ea typeface="Helvetica Neue"/>
+                <a:cs typeface="Helvetica Neue"/>
+              </a:defRPr>
+            </a:lvl9pPr>
+          </a:lstStyle>
+          <a:p xmlns:a="http://schemas.openxmlformats.org/drawingml/2006/main">
+            <a:pPr algn="l">
+              <a:defRPr sz="975">
+                <a:solidFill>
+                  <a:srgbClr val="C5CABC"/>
+                </a:solidFill>
+                <a:latin typeface="Helvetica Neue"/>
+                <a:ea typeface="Helvetica Neue"/>
+                <a:cs typeface="Helvetica Neue"/>
+              </a:defRPr>
+            </a:pPr>
+            <a:r>
+              <a:rPr sz="975">
+                <a:solidFill>
+                  <a:srgbClr val="C5CABC"/>
+                </a:solidFill>
+                <a:latin typeface="Helvetica Neue"/>
+                <a:ea typeface="Helvetica Neue"/>
+                <a:cs typeface="Helvetica Neue"/>
+              </a:rPr>
+              <a:t>TEAM AC/DC · HACKATHON PROJECT</a:t>
+            </a:r>
+          </a:p>
+        </p:txBody>
+      </p:sp>
+      <p:sp>
+        <p:nvSpPr>
+          <p:cNvPr id="6" name="Slide number">
+            <a:extLst xmlns:a="http://schemas.openxmlformats.org/drawingml/2006/main">
+              <a:ext uri="{FF2B5EF4-FFF2-40B4-BE49-F238E27FC236}">
+                <a16:creationId xmlns:a16="http://schemas.microsoft.com/office/drawing/2014/main" id="{18ED43CE-A80F-408F-9644-E950C8534B84}"/>
+              </a:ext>
+            </a:extLst>
+          </p:cNvPr>
+          <p:cNvSpPr>
+            <a:spLocks xmlns:a="http://schemas.openxmlformats.org/drawingml/2006/main" noGrp="1"/>
+          </p:cNvSpPr>
+          <p:nvPr/>
+        </p:nvSpPr>
+        <p:spPr>
+          <a:xfrm xmlns:a="http://schemas.openxmlformats.org/drawingml/2006/main">
+            <a:off x="10906125" y="6467475"/>
+            <a:ext cx="676275" cy="190500"/>
+          </a:xfrm>
+          <a:prstGeom xmlns:a="http://schemas.openxmlformats.org/drawingml/2006/main" prst="rect">
+            <a:avLst/>
+          </a:prstGeom>
+          <a:noFill xmlns:a="http://schemas.openxmlformats.org/drawingml/2006/main"/>
+          <a:ln xmlns:a="http://schemas.openxmlformats.org/drawingml/2006/main" w="0">
+            <a:noFill/>
+            <a:prstDash val="solid"/>
+          </a:ln>
+        </p:spPr>
+        <p:txBody>
+          <a:bodyPr xmlns:a="http://schemas.openxmlformats.org/drawingml/2006/main" wrap="square" lIns="0" tIns="0" rIns="0" bIns="0" anchor="t">
+            <a:normAutofit fontScale="100000"/>
+          </a:bodyPr>
+          <a:lstStyle xmlns:a="http://schemas.openxmlformats.org/drawingml/2006/main">
+            <a:defPPr algn="r">
+              <a:defRPr sz="975">
+                <a:solidFill>
+                  <a:srgbClr val="C5CABC"/>
+                </a:solidFill>
+                <a:latin typeface="Helvetica Neue"/>
+                <a:ea typeface="Helvetica Neue"/>
+                <a:cs typeface="Helvetica Neue"/>
+              </a:defRPr>
+            </a:defPPr>
+            <a:lvl1pPr algn="r">
+              <a:defRPr sz="975">
+                <a:solidFill>
+                  <a:srgbClr val="C5CABC"/>
+                </a:solidFill>
+                <a:latin typeface="Helvetica Neue"/>
+                <a:ea typeface="Helvetica Neue"/>
+                <a:cs typeface="Helvetica Neue"/>
+              </a:defRPr>
+            </a:lvl1pPr>
+            <a:lvl2pPr algn="r">
+              <a:defRPr sz="975">
+                <a:solidFill>
+                  <a:srgbClr val="C5CABC"/>
+                </a:solidFill>
+                <a:latin typeface="Helvetica Neue"/>
+                <a:ea typeface="Helvetica Neue"/>
+                <a:cs typeface="Helvetica Neue"/>
+              </a:defRPr>
+            </a:lvl2pPr>
+            <a:lvl3pPr algn="r">
+              <a:defRPr sz="975">
+                <a:solidFill>
+                  <a:srgbClr val="C5CABC"/>
+                </a:solidFill>
+                <a:latin typeface="Helvetica Neue"/>
+                <a:ea typeface="Helvetica Neue"/>
+                <a:cs typeface="Helvetica Neue"/>
+              </a:defRPr>
+            </a:lvl3pPr>
+            <a:lvl4pPr algn="r">
+              <a:defRPr sz="975">
+                <a:solidFill>
+                  <a:srgbClr val="C5CABC"/>
+                </a:solidFill>
+                <a:latin typeface="Helvetica Neue"/>
+                <a:ea typeface="Helvetica Neue"/>
+                <a:cs typeface="Helvetica Neue"/>
+              </a:defRPr>
+            </a:lvl4pPr>
+            <a:lvl5pPr algn="r">
+              <a:defRPr sz="975">
+                <a:solidFill>
+                  <a:srgbClr val="C5CABC"/>
+                </a:solidFill>
+                <a:latin typeface="Helvetica Neue"/>
+                <a:ea typeface="Helvetica Neue"/>
+                <a:cs typeface="Helvetica Neue"/>
+              </a:defRPr>
+            </a:lvl5pPr>
+            <a:lvl6pPr algn="r">
+              <a:defRPr sz="975">
+                <a:solidFill>
+                  <a:srgbClr val="C5CABC"/>
+                </a:solidFill>
+                <a:latin typeface="Helvetica Neue"/>
+                <a:ea typeface="Helvetica Neue"/>
+                <a:cs typeface="Helvetica Neue"/>
+              </a:defRPr>
+            </a:lvl6pPr>
+            <a:lvl7pPr algn="r">
+              <a:defRPr sz="975">
+                <a:solidFill>
+                  <a:srgbClr val="C5CABC"/>
+                </a:solidFill>
+                <a:latin typeface="Helvetica Neue"/>
+                <a:ea typeface="Helvetica Neue"/>
+                <a:cs typeface="Helvetica Neue"/>
+              </a:defRPr>
+            </a:lvl7pPr>
+            <a:lvl8pPr algn="r">
+              <a:defRPr sz="975">
+                <a:solidFill>
+                  <a:srgbClr val="C5CABC"/>
+                </a:solidFill>
+                <a:latin typeface="Helvetica Neue"/>
+                <a:ea typeface="Helvetica Neue"/>
+                <a:cs typeface="Helvetica Neue"/>
+              </a:defRPr>
+            </a:lvl8pPr>
+            <a:lvl9pPr algn="r">
+              <a:defRPr sz="975">
+                <a:solidFill>
+                  <a:srgbClr val="C5CABC"/>
+                </a:solidFill>
+                <a:latin typeface="Helvetica Neue"/>
+                <a:ea typeface="Helvetica Neue"/>
+                <a:cs typeface="Helvetica Neue"/>
+              </a:defRPr>
+            </a:lvl9pPr>
+          </a:lstStyle>
+          <a:p xmlns:a="http://schemas.openxmlformats.org/drawingml/2006/main">
+            <a:pPr algn="r">
+              <a:defRPr sz="975">
+                <a:solidFill>
+                  <a:srgbClr val="C5CABC"/>
+                </a:solidFill>
+                <a:latin typeface="Helvetica Neue"/>
+                <a:ea typeface="Helvetica Neue"/>
+                <a:cs typeface="Helvetica Neue"/>
+              </a:defRPr>
+            </a:pPr>
+            <a:r>
+              <a:rPr sz="975">
+                <a:solidFill>
+                  <a:srgbClr val="C5CABC"/>
+                </a:solidFill>
+                <a:latin typeface="Helvetica Neue"/>
+                <a:ea typeface="Helvetica Neue"/>
+                <a:cs typeface="Helvetica Neue"/>
+              </a:rPr>
+              <a:t>4 / 8</a:t>
+            </a:r>
+          </a:p>
+        </p:txBody>
+      </p:sp>
+    </p:spTree>
+    <p:extLst>
+      <p:ext uri="{BB962C8B-B14F-4D97-AF65-F5344CB8AC3E}">
+        <p14:creationId xmlns:p14="http://schemas.microsoft.com/office/powerpoint/2010/main" val="582323456"/>
+      </p:ext>
+    </p:extLst>
+  </p:cSld>
+</p:sld>
+</file>
+
+<file path=ppt/slides/slide9.xml><?xml version="1.0" encoding="utf-8"?>
+<p:sld xmlns:p="http://schemas.openxmlformats.org/presentationml/2006/main">
+  <p:cSld>
+    <p:bg>
+      <p:bgPr>
+        <a:solidFill xmlns:a="http://schemas.openxmlformats.org/drawingml/2006/main">
+          <a:srgbClr val="181B18"/>
+        </a:solidFill>
+      </p:bgPr>
+    </p:bg>
+    <p:spTree>
+      <p:nvGrpSpPr>
+        <p:cNvPr id="1" name=""/>
+        <p:cNvGrpSpPr/>
+        <p:nvPr/>
+      </p:nvGrpSpPr>
+      <p:grpSpPr>
+        <a:xfrm xmlns:a="http://schemas.openxmlformats.org/drawingml/2006/main"/>
+      </p:grpSpPr>
+      <p:sp>
+        <p:nvSpPr>
+          <p:cNvPr id="8" name="Batch readings context label">
+            <a:extLst xmlns:a="http://schemas.openxmlformats.org/drawingml/2006/main">
+              <a:ext uri="{FF2B5EF4-FFF2-40B4-BE49-F238E27FC236}">
+                <a16:creationId xmlns:a16="http://schemas.microsoft.com/office/drawing/2014/main" id="{CAC12F52-0528-4B76-9B78-84C0D218183B}"/>
+              </a:ext>
+            </a:extLst>
+          </p:cNvPr>
+          <p:cNvSpPr>
+            <a:spLocks xmlns:a="http://schemas.openxmlformats.org/drawingml/2006/main" noGrp="1"/>
+          </p:cNvSpPr>
+          <p:nvPr/>
+        </p:nvSpPr>
+        <p:spPr>
+          <a:xfrm xmlns:a="http://schemas.openxmlformats.org/drawingml/2006/main">
+            <a:off x="609600" y="361950"/>
+            <a:ext cx="4095750" cy="238125"/>
+          </a:xfrm>
+          <a:prstGeom xmlns:a="http://schemas.openxmlformats.org/drawingml/2006/main" prst="rect">
+            <a:avLst/>
+          </a:prstGeom>
+          <a:noFill xmlns:a="http://schemas.openxmlformats.org/drawingml/2006/main"/>
+          <a:ln xmlns:a="http://schemas.openxmlformats.org/drawingml/2006/main" w="0">
+            <a:noFill/>
+            <a:prstDash val="solid"/>
+          </a:ln>
+        </p:spPr>
+        <p:txBody>
+          <a:bodyPr xmlns:a="http://schemas.openxmlformats.org/drawingml/2006/main" wrap="square" lIns="0" tIns="0" rIns="0" bIns="0" anchor="t">
+            <a:normAutofit fontScale="100000"/>
+          </a:bodyPr>
+          <a:lstStyle xmlns:a="http://schemas.openxmlformats.org/drawingml/2006/main">
+            <a:defPPr algn="l">
+              <a:defRPr sz="1275" b="1">
+                <a:solidFill>
+                  <a:srgbClr val="D8B44E"/>
+                </a:solidFill>
+                <a:latin typeface="Helvetica Neue"/>
+                <a:ea typeface="Helvetica Neue"/>
+                <a:cs typeface="Helvetica Neue"/>
+              </a:defRPr>
+            </a:defPPr>
+            <a:lvl1pPr algn="l">
+              <a:defRPr sz="1275" b="1">
+                <a:solidFill>
+                  <a:srgbClr val="D8B44E"/>
+                </a:solidFill>
+                <a:latin typeface="Helvetica Neue"/>
+                <a:ea typeface="Helvetica Neue"/>
+                <a:cs typeface="Helvetica Neue"/>
+              </a:defRPr>
+            </a:lvl1pPr>
+            <a:lvl2pPr algn="l">
+              <a:defRPr sz="1275" b="1">
+                <a:solidFill>
+                  <a:srgbClr val="D8B44E"/>
+                </a:solidFill>
+                <a:latin typeface="Helvetica Neue"/>
+                <a:ea typeface="Helvetica Neue"/>
+                <a:cs typeface="Helvetica Neue"/>
+              </a:defRPr>
+            </a:lvl2pPr>
+            <a:lvl3pPr algn="l">
+              <a:defRPr sz="1275" b="1">
+                <a:solidFill>
+                  <a:srgbClr val="D8B44E"/>
+                </a:solidFill>
+                <a:latin typeface="Helvetica Neue"/>
+                <a:ea typeface="Helvetica Neue"/>
+                <a:cs typeface="Helvetica Neue"/>
+              </a:defRPr>
+            </a:lvl3pPr>
+            <a:lvl4pPr algn="l">
+              <a:defRPr sz="1275" b="1">
+                <a:solidFill>
+                  <a:srgbClr val="D8B44E"/>
+                </a:solidFill>
+                <a:latin typeface="Helvetica Neue"/>
+                <a:ea typeface="Helvetica Neue"/>
+                <a:cs typeface="Helvetica Neue"/>
+              </a:defRPr>
+            </a:lvl4pPr>
+            <a:lvl5pPr algn="l">
+              <a:defRPr sz="1275" b="1">
+                <a:solidFill>
+                  <a:srgbClr val="D8B44E"/>
+                </a:solidFill>
+                <a:latin typeface="Helvetica Neue"/>
+                <a:ea typeface="Helvetica Neue"/>
+                <a:cs typeface="Helvetica Neue"/>
+              </a:defRPr>
+            </a:lvl5pPr>
+            <a:lvl6pPr algn="l">
+              <a:defRPr sz="1275" b="1">
+                <a:solidFill>
+                  <a:srgbClr val="D8B44E"/>
+                </a:solidFill>
+                <a:latin typeface="Helvetica Neue"/>
+                <a:ea typeface="Helvetica Neue"/>
+                <a:cs typeface="Helvetica Neue"/>
+              </a:defRPr>
+            </a:lvl6pPr>
+            <a:lvl7pPr algn="l">
+              <a:defRPr sz="1275" b="1">
+                <a:solidFill>
+                  <a:srgbClr val="D8B44E"/>
+                </a:solidFill>
+                <a:latin typeface="Helvetica Neue"/>
+                <a:ea typeface="Helvetica Neue"/>
+                <a:cs typeface="Helvetica Neue"/>
+              </a:defRPr>
+            </a:lvl7pPr>
+            <a:lvl8pPr algn="l">
+              <a:defRPr sz="1275" b="1">
+                <a:solidFill>
+                  <a:srgbClr val="D8B44E"/>
+                </a:solidFill>
+                <a:latin typeface="Helvetica Neue"/>
+                <a:ea typeface="Helvetica Neue"/>
+                <a:cs typeface="Helvetica Neue"/>
+              </a:defRPr>
+            </a:lvl8pPr>
+            <a:lvl9pPr algn="l">
+              <a:defRPr sz="1275" b="1">
+                <a:solidFill>
+                  <a:srgbClr val="D8B44E"/>
+                </a:solidFill>
+                <a:latin typeface="Helvetica Neue"/>
+                <a:ea typeface="Helvetica Neue"/>
+                <a:cs typeface="Helvetica Neue"/>
+              </a:defRPr>
+            </a:lvl9pPr>
+          </a:lstStyle>
+          <a:p xmlns:a="http://schemas.openxmlformats.org/drawingml/2006/main">
+            <a:pPr algn="l">
+              <a:defRPr sz="1275" b="1">
+                <a:solidFill>
+                  <a:srgbClr val="D8B44E"/>
+                </a:solidFill>
+                <a:latin typeface="Helvetica Neue"/>
+                <a:ea typeface="Helvetica Neue"/>
+                <a:cs typeface="Helvetica Neue"/>
+              </a:defRPr>
+            </a:pPr>
+            <a:r>
+              <a:rPr sz="1275" b="1">
+                <a:solidFill>
+                  <a:srgbClr val="D8B44E"/>
+                </a:solidFill>
+                <a:latin typeface="Helvetica Neue"/>
+                <a:ea typeface="Helvetica Neue"/>
+                <a:cs typeface="Helvetica Neue"/>
+              </a:rPr>
+              <a:t>SELECTED TRIAL</a:t>
+            </a:r>
+          </a:p>
+        </p:txBody>
+      </p:sp>
+      <p:sp>
+        <p:nvSpPr>
+          <p:cNvPr id="2" name="Batch readings title">
+            <a:extLst xmlns:a="http://schemas.openxmlformats.org/drawingml/2006/main">
+              <a:ext uri="{FF2B5EF4-FFF2-40B4-BE49-F238E27FC236}">
+                <a16:creationId xmlns:a16="http://schemas.microsoft.com/office/drawing/2014/main" id="{7B771280-0CF6-486B-ADF7-5E9BF6FB2205}"/>
+              </a:ext>
+            </a:extLst>
+          </p:cNvPr>
+          <p:cNvSpPr>
+            <a:spLocks xmlns:a="http://schemas.openxmlformats.org/drawingml/2006/main" noGrp="1"/>
+          </p:cNvSpPr>
+          <p:nvPr/>
+        </p:nvSpPr>
+        <p:spPr>
+          <a:xfrm xmlns:a="http://schemas.openxmlformats.org/drawingml/2006/main">
+            <a:off x="609600" y="733425"/>
+            <a:ext cx="4095750" cy="504825"/>
+          </a:xfrm>
+          <a:prstGeom xmlns:a="http://schemas.openxmlformats.org/drawingml/2006/main" prst="rect">
+            <a:avLst/>
+          </a:prstGeom>
+          <a:noFill xmlns:a="http://schemas.openxmlformats.org/drawingml/2006/main"/>
+          <a:ln xmlns:a="http://schemas.openxmlformats.org/drawingml/2006/main" w="0">
+            <a:noFill/>
+            <a:prstDash val="solid"/>
+          </a:ln>
+        </p:spPr>
+        <p:txBody>
+          <a:bodyPr xmlns:a="http://schemas.openxmlformats.org/drawingml/2006/main" wrap="square" lIns="0" tIns="0" rIns="0" bIns="0" anchor="t">
+            <a:normAutofit fontScale="100000"/>
+          </a:bodyPr>
+          <a:lstStyle xmlns:a="http://schemas.openxmlformats.org/drawingml/2006/main">
+            <a:defPPr algn="l">
+              <a:defRPr sz="3000" b="1">
+                <a:solidFill>
+                  <a:srgbClr val="F2F0E5"/>
+                </a:solidFill>
+                <a:latin typeface="Helvetica Neue"/>
+                <a:ea typeface="Helvetica Neue"/>
+                <a:cs typeface="Helvetica Neue"/>
+              </a:defRPr>
+            </a:defPPr>
+            <a:lvl1pPr algn="l">
+              <a:defRPr sz="3000" b="1">
+                <a:solidFill>
+                  <a:srgbClr val="F2F0E5"/>
+                </a:solidFill>
+                <a:latin typeface="Helvetica Neue"/>
+                <a:ea typeface="Helvetica Neue"/>
+                <a:cs typeface="Helvetica Neue"/>
+              </a:defRPr>
+            </a:lvl1pPr>
+            <a:lvl2pPr algn="l">
+              <a:defRPr sz="3000" b="1">
+                <a:solidFill>
+                  <a:srgbClr val="F2F0E5"/>
+                </a:solidFill>
+                <a:latin typeface="Helvetica Neue"/>
+                <a:ea typeface="Helvetica Neue"/>
+                <a:cs typeface="Helvetica Neue"/>
+              </a:defRPr>
+            </a:lvl2pPr>
+            <a:lvl3pPr algn="l">
+              <a:defRPr sz="3000" b="1">
+                <a:solidFill>
+                  <a:srgbClr val="F2F0E5"/>
+                </a:solidFill>
+                <a:latin typeface="Helvetica Neue"/>
+                <a:ea typeface="Helvetica Neue"/>
+                <a:cs typeface="Helvetica Neue"/>
+              </a:defRPr>
+            </a:lvl3pPr>
+            <a:lvl4pPr algn="l">
+              <a:defRPr sz="3000" b="1">
+                <a:solidFill>
+                  <a:srgbClr val="F2F0E5"/>
+                </a:solidFill>
+                <a:latin typeface="Helvetica Neue"/>
+                <a:ea typeface="Helvetica Neue"/>
+                <a:cs typeface="Helvetica Neue"/>
+              </a:defRPr>
+            </a:lvl4pPr>
+            <a:lvl5pPr algn="l">
+              <a:defRPr sz="3000" b="1">
+                <a:solidFill>
+                  <a:srgbClr val="F2F0E5"/>
+                </a:solidFill>
+                <a:latin typeface="Helvetica Neue"/>
+                <a:ea typeface="Helvetica Neue"/>
+                <a:cs typeface="Helvetica Neue"/>
+              </a:defRPr>
+            </a:lvl5pPr>
+            <a:lvl6pPr algn="l">
+              <a:defRPr sz="3000" b="1">
+                <a:solidFill>
+                  <a:srgbClr val="F2F0E5"/>
+                </a:solidFill>
+                <a:latin typeface="Helvetica Neue"/>
+                <a:ea typeface="Helvetica Neue"/>
+                <a:cs typeface="Helvetica Neue"/>
+              </a:defRPr>
+            </a:lvl6pPr>
+            <a:lvl7pPr algn="l">
+              <a:defRPr sz="3000" b="1">
+                <a:solidFill>
+                  <a:srgbClr val="F2F0E5"/>
+                </a:solidFill>
+                <a:latin typeface="Helvetica Neue"/>
+                <a:ea typeface="Helvetica Neue"/>
+                <a:cs typeface="Helvetica Neue"/>
+              </a:defRPr>
+            </a:lvl7pPr>
+            <a:lvl8pPr algn="l">
+              <a:defRPr sz="3000" b="1">
+                <a:solidFill>
+                  <a:srgbClr val="F2F0E5"/>
+                </a:solidFill>
+                <a:latin typeface="Helvetica Neue"/>
+                <a:ea typeface="Helvetica Neue"/>
+                <a:cs typeface="Helvetica Neue"/>
+              </a:defRPr>
+            </a:lvl8pPr>
+            <a:lvl9pPr algn="l">
+              <a:defRPr sz="3000" b="1">
+                <a:solidFill>
+                  <a:srgbClr val="F2F0E5"/>
+                </a:solidFill>
+                <a:latin typeface="Helvetica Neue"/>
+                <a:ea typeface="Helvetica Neue"/>
+                <a:cs typeface="Helvetica Neue"/>
+              </a:defRPr>
+            </a:lvl9pPr>
+          </a:lstStyle>
+          <a:p xmlns:a="http://schemas.openxmlformats.org/drawingml/2006/main">
+            <a:pPr algn="l">
+              <a:defRPr sz="3000" b="1">
+                <a:solidFill>
+                  <a:srgbClr val="F2F0E5"/>
+                </a:solidFill>
+                <a:latin typeface="Helvetica Neue"/>
+                <a:ea typeface="Helvetica Neue"/>
+                <a:cs typeface="Helvetica Neue"/>
+              </a:defRPr>
+            </a:pPr>
+            <a:r>
+              <a:rPr sz="3000" b="1">
+                <a:solidFill>
+                  <a:srgbClr val="F2F0E5"/>
+                </a:solidFill>
+                <a:latin typeface="Helvetica Neue"/>
+                <a:ea typeface="Helvetica Neue"/>
+                <a:cs typeface="Helvetica Neue"/>
+              </a:rPr>
+              <a:t>Batch readings</a:t>
+            </a:r>
+          </a:p>
+        </p:txBody>
+      </p:sp>
+      <p:sp>
+        <p:nvSpPr>
+          <p:cNvPr id="3" name="Batch readings caption">
+            <a:extLst xmlns:a="http://schemas.openxmlformats.org/drawingml/2006/main">
+              <a:ext uri="{FF2B5EF4-FFF2-40B4-BE49-F238E27FC236}">
+                <a16:creationId xmlns:a16="http://schemas.microsoft.com/office/drawing/2014/main" id="{67948862-17C7-4804-8558-3D1460B39AEE}"/>
+              </a:ext>
+            </a:extLst>
+          </p:cNvPr>
+          <p:cNvSpPr>
+            <a:spLocks xmlns:a="http://schemas.openxmlformats.org/drawingml/2006/main" noGrp="1"/>
+          </p:cNvSpPr>
+          <p:nvPr/>
+        </p:nvSpPr>
+        <p:spPr>
+          <a:xfrm xmlns:a="http://schemas.openxmlformats.org/drawingml/2006/main">
+            <a:off x="609600" y="1581150"/>
+            <a:ext cx="4095750" cy="2305050"/>
+          </a:xfrm>
+          <a:prstGeom xmlns:a="http://schemas.openxmlformats.org/drawingml/2006/main" prst="rect">
+            <a:avLst/>
+          </a:prstGeom>
+          <a:noFill xmlns:a="http://schemas.openxmlformats.org/drawingml/2006/main"/>
+          <a:ln xmlns:a="http://schemas.openxmlformats.org/drawingml/2006/main" w="0">
+            <a:noFill/>
+            <a:prstDash val="solid"/>
+          </a:ln>
+        </p:spPr>
+        <p:txBody>
+          <a:bodyPr xmlns:a="http://schemas.openxmlformats.org/drawingml/2006/main" wrap="square" lIns="0" tIns="0" rIns="0" bIns="0" anchor="t">
+            <a:normAutofit fontScale="100000"/>
+          </a:bodyPr>
+          <a:lstStyle xmlns:a="http://schemas.openxmlformats.org/drawingml/2006/main">
+            <a:defPPr algn="l">
+              <a:defRPr sz="1800">
+                <a:solidFill>
+                  <a:srgbClr val="F2F0E5"/>
+                </a:solidFill>
+                <a:latin typeface="Helvetica Neue"/>
+                <a:ea typeface="Helvetica Neue"/>
+                <a:cs typeface="Helvetica Neue"/>
+              </a:defRPr>
+            </a:defPPr>
+            <a:lvl1pPr algn="l">
+              <a:defRPr sz="1800">
+                <a:solidFill>
+                  <a:srgbClr val="F2F0E5"/>
+                </a:solidFill>
+                <a:latin typeface="Helvetica Neue"/>
+                <a:ea typeface="Helvetica Neue"/>
+                <a:cs typeface="Helvetica Neue"/>
+              </a:defRPr>
+            </a:lvl1pPr>
+            <a:lvl2pPr algn="l">
+              <a:defRPr sz="1800">
+                <a:solidFill>
+                  <a:srgbClr val="F2F0E5"/>
+                </a:solidFill>
+                <a:latin typeface="Helvetica Neue"/>
+                <a:ea typeface="Helvetica Neue"/>
+                <a:cs typeface="Helvetica Neue"/>
+              </a:defRPr>
+            </a:lvl2pPr>
+            <a:lvl3pPr algn="l">
+              <a:defRPr sz="1800">
+                <a:solidFill>
+                  <a:srgbClr val="F2F0E5"/>
+                </a:solidFill>
+                <a:latin typeface="Helvetica Neue"/>
+                <a:ea typeface="Helvetica Neue"/>
+                <a:cs typeface="Helvetica Neue"/>
+              </a:defRPr>
+            </a:lvl3pPr>
+            <a:lvl4pPr algn="l">
+              <a:defRPr sz="1800">
+                <a:solidFill>
+                  <a:srgbClr val="F2F0E5"/>
+                </a:solidFill>
+                <a:latin typeface="Helvetica Neue"/>
+                <a:ea typeface="Helvetica Neue"/>
+                <a:cs typeface="Helvetica Neue"/>
+              </a:defRPr>
+            </a:lvl4pPr>
+            <a:lvl5pPr algn="l">
+              <a:defRPr sz="1800">
+                <a:solidFill>
+                  <a:srgbClr val="F2F0E5"/>
+                </a:solidFill>
+                <a:latin typeface="Helvetica Neue"/>
+                <a:ea typeface="Helvetica Neue"/>
+                <a:cs typeface="Helvetica Neue"/>
+              </a:defRPr>
+            </a:lvl5pPr>
+            <a:lvl6pPr algn="l">
+              <a:defRPr sz="1800">
+                <a:solidFill>
+                  <a:srgbClr val="F2F0E5"/>
+                </a:solidFill>
+                <a:latin typeface="Helvetica Neue"/>
+                <a:ea typeface="Helvetica Neue"/>
+                <a:cs typeface="Helvetica Neue"/>
+              </a:defRPr>
+            </a:lvl6pPr>
+            <a:lvl7pPr algn="l">
+              <a:defRPr sz="1800">
+                <a:solidFill>
+                  <a:srgbClr val="F2F0E5"/>
+                </a:solidFill>
+                <a:latin typeface="Helvetica Neue"/>
+                <a:ea typeface="Helvetica Neue"/>
+                <a:cs typeface="Helvetica Neue"/>
+              </a:defRPr>
+            </a:lvl7pPr>
+            <a:lvl8pPr algn="l">
+              <a:defRPr sz="1800">
+                <a:solidFill>
+                  <a:srgbClr val="F2F0E5"/>
+                </a:solidFill>
+                <a:latin typeface="Helvetica Neue"/>
+                <a:ea typeface="Helvetica Neue"/>
+                <a:cs typeface="Helvetica Neue"/>
+              </a:defRPr>
+            </a:lvl8pPr>
+            <a:lvl9pPr algn="l">
+              <a:defRPr sz="1800">
+                <a:solidFill>
+                  <a:srgbClr val="F2F0E5"/>
+                </a:solidFill>
+                <a:latin typeface="Helvetica Neue"/>
+                <a:ea typeface="Helvetica Neue"/>
+                <a:cs typeface="Helvetica Neue"/>
+              </a:defRPr>
+            </a:lvl9pPr>
+          </a:lstStyle>
+          <a:p xmlns:a="http://schemas.openxmlformats.org/drawingml/2006/main">
+            <a:pPr algn="l">
+              <a:defRPr sz="1800">
+                <a:solidFill>
+                  <a:srgbClr val="F2F0E5"/>
+                </a:solidFill>
+                <a:latin typeface="Helvetica Neue"/>
+                <a:ea typeface="Helvetica Neue"/>
+                <a:cs typeface="Helvetica Neue"/>
+              </a:defRPr>
+            </a:pPr>
+            <a:r>
+              <a:rPr sz="1800">
+                <a:solidFill>
+                  <a:srgbClr val="F2F0E5"/>
+                </a:solidFill>
+                <a:latin typeface="Helvetica Neue"/>
+                <a:ea typeface="Helvetica Neue"/>
+                <a:cs typeface="Helvetica Neue"/>
+              </a:rPr>
+              <a:t>In this selected trial, the 16-layer run shows an estimated 2.03 J/token at PF = 1, compared with 5.45 J/token for the initial 48-layer run.</a:t>
+            </a:r>
+          </a:p>
+        </p:txBody>
+      </p:sp>
+      <p:sp>
+        <p:nvSpPr>
+          <p:cNvPr id="4" name="Batch readings qualifier">
+            <a:extLst xmlns:a="http://schemas.openxmlformats.org/drawingml/2006/main">
+              <a:ext uri="{FF2B5EF4-FFF2-40B4-BE49-F238E27FC236}">
+                <a16:creationId xmlns:a16="http://schemas.microsoft.com/office/drawing/2014/main" id="{9B93DFB6-E649-4D1C-AEC7-E55A158557DE}"/>
+              </a:ext>
+            </a:extLst>
+          </p:cNvPr>
+          <p:cNvSpPr>
+            <a:spLocks xmlns:a="http://schemas.openxmlformats.org/drawingml/2006/main" noGrp="1"/>
+          </p:cNvSpPr>
+          <p:nvPr/>
+        </p:nvSpPr>
+        <p:spPr>
+          <a:xfrm xmlns:a="http://schemas.openxmlformats.org/drawingml/2006/main">
+            <a:off x="609600" y="4019550"/>
+            <a:ext cx="4095750" cy="1257300"/>
+          </a:xfrm>
+          <a:prstGeom xmlns:a="http://schemas.openxmlformats.org/drawingml/2006/main" prst="rect">
+            <a:avLst/>
+          </a:prstGeom>
+          <a:noFill xmlns:a="http://schemas.openxmlformats.org/drawingml/2006/main"/>
+          <a:ln xmlns:a="http://schemas.openxmlformats.org/drawingml/2006/main" w="0">
+            <a:noFill/>
+            <a:prstDash val="solid"/>
+          </a:ln>
+        </p:spPr>
+        <p:txBody>
+          <a:bodyPr xmlns:a="http://schemas.openxmlformats.org/drawingml/2006/main" wrap="square" lIns="0" tIns="0" rIns="0" bIns="0" anchor="t">
+            <a:normAutofit fontScale="100000"/>
+          </a:bodyPr>
+          <a:lstStyle xmlns:a="http://schemas.openxmlformats.org/drawingml/2006/main">
+            <a:defPPr algn="l">
+              <a:defRPr sz="1575">
+                <a:solidFill>
+                  <a:srgbClr val="C5CABC"/>
+                </a:solidFill>
+                <a:latin typeface="Helvetica Neue"/>
+                <a:ea typeface="Helvetica Neue"/>
+                <a:cs typeface="Helvetica Neue"/>
+              </a:defRPr>
+            </a:defPPr>
+            <a:lvl1pPr algn="l">
+              <a:defRPr sz="1575">
+                <a:solidFill>
+                  <a:srgbClr val="C5CABC"/>
+                </a:solidFill>
+                <a:latin typeface="Helvetica Neue"/>
+                <a:ea typeface="Helvetica Neue"/>
+                <a:cs typeface="Helvetica Neue"/>
+              </a:defRPr>
+            </a:lvl1pPr>
+            <a:lvl2pPr algn="l">
+              <a:defRPr sz="1575">
+                <a:solidFill>
+                  <a:srgbClr val="C5CABC"/>
+                </a:solidFill>
+                <a:latin typeface="Helvetica Neue"/>
+                <a:ea typeface="Helvetica Neue"/>
+                <a:cs typeface="Helvetica Neue"/>
+              </a:defRPr>
+            </a:lvl2pPr>
+            <a:lvl3pPr algn="l">
+              <a:defRPr sz="1575">
+                <a:solidFill>
+                  <a:srgbClr val="C5CABC"/>
+                </a:solidFill>
+                <a:latin typeface="Helvetica Neue"/>
+                <a:ea typeface="Helvetica Neue"/>
+                <a:cs typeface="Helvetica Neue"/>
+              </a:defRPr>
+            </a:lvl3pPr>
+            <a:lvl4pPr algn="l">
+              <a:defRPr sz="1575">
+                <a:solidFill>
+                  <a:srgbClr val="C5CABC"/>
+                </a:solidFill>
+                <a:latin typeface="Helvetica Neue"/>
+                <a:ea typeface="Helvetica Neue"/>
+                <a:cs typeface="Helvetica Neue"/>
+              </a:defRPr>
+            </a:lvl4pPr>
+            <a:lvl5pPr algn="l">
+              <a:defRPr sz="1575">
+                <a:solidFill>
+                  <a:srgbClr val="C5CABC"/>
+                </a:solidFill>
+                <a:latin typeface="Helvetica Neue"/>
+                <a:ea typeface="Helvetica Neue"/>
+                <a:cs typeface="Helvetica Neue"/>
+              </a:defRPr>
+            </a:lvl5pPr>
+            <a:lvl6pPr algn="l">
+              <a:defRPr sz="1575">
+                <a:solidFill>
+                  <a:srgbClr val="C5CABC"/>
+                </a:solidFill>
+                <a:latin typeface="Helvetica Neue"/>
+                <a:ea typeface="Helvetica Neue"/>
+                <a:cs typeface="Helvetica Neue"/>
+              </a:defRPr>
+            </a:lvl6pPr>
+            <a:lvl7pPr algn="l">
+              <a:defRPr sz="1575">
+                <a:solidFill>
+                  <a:srgbClr val="C5CABC"/>
+                </a:solidFill>
+                <a:latin typeface="Helvetica Neue"/>
+                <a:ea typeface="Helvetica Neue"/>
+                <a:cs typeface="Helvetica Neue"/>
+              </a:defRPr>
+            </a:lvl7pPr>
+            <a:lvl8pPr algn="l">
+              <a:defRPr sz="1575">
+                <a:solidFill>
+                  <a:srgbClr val="C5CABC"/>
+                </a:solidFill>
+                <a:latin typeface="Helvetica Neue"/>
+                <a:ea typeface="Helvetica Neue"/>
+                <a:cs typeface="Helvetica Neue"/>
+              </a:defRPr>
+            </a:lvl8pPr>
+            <a:lvl9pPr algn="l">
+              <a:defRPr sz="1575">
+                <a:solidFill>
+                  <a:srgbClr val="C5CABC"/>
+                </a:solidFill>
+                <a:latin typeface="Helvetica Neue"/>
+                <a:ea typeface="Helvetica Neue"/>
+                <a:cs typeface="Helvetica Neue"/>
+              </a:defRPr>
+            </a:lvl9pPr>
+          </a:lstStyle>
+          <a:p xmlns:a="http://schemas.openxmlformats.org/drawingml/2006/main">
+            <a:pPr algn="l">
+              <a:defRPr sz="1575">
+                <a:solidFill>
+                  <a:srgbClr val="C5CABC"/>
+                </a:solidFill>
+                <a:latin typeface="Helvetica Neue"/>
+                <a:ea typeface="Helvetica Neue"/>
+                <a:cs typeface="Helvetica Neue"/>
+              </a:defRPr>
+            </a:pPr>
+            <a:r>
+              <a:rPr sz="1575">
+                <a:solidFill>
+                  <a:srgbClr val="C5CABC"/>
+                </a:solidFill>
+                <a:latin typeface="Helvetica Neue"/>
+                <a:ea typeface="Helvetica Neue"/>
+                <a:cs typeface="Helvetica Neue"/>
+              </a:rPr>
+              <a:t>Run durations differ, and quality results are not shown.</a:t>
+            </a:r>
+          </a:p>
+        </p:txBody>
+      </p:sp>
+      <p:pic>
+        <p:nvPicPr>
+          <p:cNvPr id="5" name="Batch readings source screenshot">
+            <a:extLst xmlns:a="http://schemas.openxmlformats.org/drawingml/2006/main">
+              <a:ext uri="{FF2B5EF4-FFF2-40B4-BE49-F238E27FC236}">
+                <a16:creationId xmlns:a16="http://schemas.microsoft.com/office/drawing/2014/main" id="{A2DECDFD-232D-408F-8225-8B8E5FAE8FA9}"/>
+              </a:ext>
+            </a:extLst>
+          </p:cNvPr>
+          <p:cNvPicPr>
+            <a:picLocks xmlns:a="http://schemas.openxmlformats.org/drawingml/2006/main" noChangeAspect="1"/>
+          </p:cNvPicPr>
+          <p:nvPr/>
+        </p:nvPicPr>
+        <p:blipFill>
+          <a:blip xmlns:r="http://schemas.openxmlformats.org/officeDocument/2006/relationships" xmlns:a="http://schemas.openxmlformats.org/drawingml/2006/main" r:embed="R83658bc59e7f4855"/>
+          <a:stretch xmlns:a="http://schemas.openxmlformats.org/drawingml/2006/main"/>
+        </p:blipFill>
+        <p:spPr>
+          <a:xfrm xmlns:a="http://schemas.openxmlformats.org/drawingml/2006/main">
+            <a:off x="5238750" y="526770"/>
+            <a:ext cx="6343650" cy="5585386"/>
+          </a:xfrm>
+          <a:prstGeom xmlns:a="http://schemas.openxmlformats.org/drawingml/2006/main" prst="rect">
+            <a:avLst/>
+          </a:prstGeom>
+        </p:spPr>
+      </p:pic>
+      <p:sp>
+        <p:nvSpPr>
+          <p:cNvPr id="6" name="Project footer">
+            <a:extLst xmlns:a="http://schemas.openxmlformats.org/drawingml/2006/main">
+              <a:ext uri="{FF2B5EF4-FFF2-40B4-BE49-F238E27FC236}">
+                <a16:creationId xmlns:a16="http://schemas.microsoft.com/office/drawing/2014/main" id="{A4B1F818-6A92-420C-8595-732ABC986149}"/>
+              </a:ext>
+            </a:extLst>
+          </p:cNvPr>
+          <p:cNvSpPr>
+            <a:spLocks xmlns:a="http://schemas.openxmlformats.org/drawingml/2006/main" noGrp="1"/>
+          </p:cNvSpPr>
+          <p:nvPr/>
+        </p:nvSpPr>
+        <p:spPr>
+          <a:xfrm xmlns:a="http://schemas.openxmlformats.org/drawingml/2006/main">
+            <a:off x="609600" y="6467475"/>
+            <a:ext cx="4953000" cy="190500"/>
+          </a:xfrm>
+          <a:prstGeom xmlns:a="http://schemas.openxmlformats.org/drawingml/2006/main" prst="rect">
+            <a:avLst/>
+          </a:prstGeom>
+          <a:noFill xmlns:a="http://schemas.openxmlformats.org/drawingml/2006/main"/>
+          <a:ln xmlns:a="http://schemas.openxmlformats.org/drawingml/2006/main" w="0">
+            <a:noFill/>
+            <a:prstDash val="solid"/>
+          </a:ln>
+        </p:spPr>
+        <p:txBody>
+          <a:bodyPr xmlns:a="http://schemas.openxmlformats.org/drawingml/2006/main" wrap="square" lIns="0" tIns="0" rIns="0" bIns="0" anchor="t">
+            <a:normAutofit fontScale="100000"/>
+          </a:bodyPr>
+          <a:lstStyle xmlns:a="http://schemas.openxmlformats.org/drawingml/2006/main">
+            <a:defPPr algn="l">
+              <a:defRPr sz="975">
+                <a:solidFill>
+                  <a:srgbClr val="C5CABC"/>
+                </a:solidFill>
+                <a:latin typeface="Helvetica Neue"/>
+                <a:ea typeface="Helvetica Neue"/>
+                <a:cs typeface="Helvetica Neue"/>
+              </a:defRPr>
+            </a:defPPr>
+            <a:lvl1pPr algn="l">
+              <a:defRPr sz="975">
+                <a:solidFill>
+                  <a:srgbClr val="C5CABC"/>
+                </a:solidFill>
+                <a:latin typeface="Helvetica Neue"/>
+                <a:ea typeface="Helvetica Neue"/>
+                <a:cs typeface="Helvetica Neue"/>
+              </a:defRPr>
+            </a:lvl1pPr>
+            <a:lvl2pPr algn="l">
+              <a:defRPr sz="975">
+                <a:solidFill>
+                  <a:srgbClr val="C5CABC"/>
+                </a:solidFill>
+                <a:latin typeface="Helvetica Neue"/>
+                <a:ea typeface="Helvetica Neue"/>
+                <a:cs typeface="Helvetica Neue"/>
+              </a:defRPr>
+            </a:lvl2pPr>
+            <a:lvl3pPr algn="l">
+              <a:defRPr sz="975">
+                <a:solidFill>
+                  <a:srgbClr val="C5CABC"/>
+                </a:solidFill>
+                <a:latin typeface="Helvetica Neue"/>
+                <a:ea typeface="Helvetica Neue"/>
+                <a:cs typeface="Helvetica Neue"/>
+              </a:defRPr>
+            </a:lvl3pPr>
+            <a:lvl4pPr algn="l">
+              <a:defRPr sz="975">
+                <a:solidFill>
+                  <a:srgbClr val="C5CABC"/>
+                </a:solidFill>
+                <a:latin typeface="Helvetica Neue"/>
+                <a:ea typeface="Helvetica Neue"/>
+                <a:cs typeface="Helvetica Neue"/>
+              </a:defRPr>
+            </a:lvl4pPr>
+            <a:lvl5pPr algn="l">
+              <a:defRPr sz="975">
+                <a:solidFill>
+                  <a:srgbClr val="C5CABC"/>
+                </a:solidFill>
+                <a:latin typeface="Helvetica Neue"/>
+                <a:ea typeface="Helvetica Neue"/>
+                <a:cs typeface="Helvetica Neue"/>
+              </a:defRPr>
+            </a:lvl5pPr>
+            <a:lvl6pPr algn="l">
+              <a:defRPr sz="975">
+                <a:solidFill>
+                  <a:srgbClr val="C5CABC"/>
+                </a:solidFill>
+                <a:latin typeface="Helvetica Neue"/>
+                <a:ea typeface="Helvetica Neue"/>
+                <a:cs typeface="Helvetica Neue"/>
+              </a:defRPr>
+            </a:lvl6pPr>
+            <a:lvl7pPr algn="l">
+              <a:defRPr sz="975">
+                <a:solidFill>
+                  <a:srgbClr val="C5CABC"/>
+                </a:solidFill>
+                <a:latin typeface="Helvetica Neue"/>
+                <a:ea typeface="Helvetica Neue"/>
+                <a:cs typeface="Helvetica Neue"/>
+              </a:defRPr>
+            </a:lvl7pPr>
+            <a:lvl8pPr algn="l">
+              <a:defRPr sz="975">
+                <a:solidFill>
+                  <a:srgbClr val="C5CABC"/>
+                </a:solidFill>
+                <a:latin typeface="Helvetica Neue"/>
+                <a:ea typeface="Helvetica Neue"/>
+                <a:cs typeface="Helvetica Neue"/>
+              </a:defRPr>
+            </a:lvl8pPr>
+            <a:lvl9pPr algn="l">
+              <a:defRPr sz="975">
+                <a:solidFill>
+                  <a:srgbClr val="C5CABC"/>
+                </a:solidFill>
+                <a:latin typeface="Helvetica Neue"/>
+                <a:ea typeface="Helvetica Neue"/>
+                <a:cs typeface="Helvetica Neue"/>
+              </a:defRPr>
+            </a:lvl9pPr>
+          </a:lstStyle>
+          <a:p xmlns:a="http://schemas.openxmlformats.org/drawingml/2006/main">
+            <a:pPr algn="l">
+              <a:defRPr sz="975">
+                <a:solidFill>
+                  <a:srgbClr val="C5CABC"/>
+                </a:solidFill>
+                <a:latin typeface="Helvetica Neue"/>
+                <a:ea typeface="Helvetica Neue"/>
+                <a:cs typeface="Helvetica Neue"/>
+              </a:defRPr>
+            </a:pPr>
+            <a:r>
+              <a:rPr sz="975">
+                <a:solidFill>
+                  <a:srgbClr val="C5CABC"/>
+                </a:solidFill>
+                <a:latin typeface="Helvetica Neue"/>
+                <a:ea typeface="Helvetica Neue"/>
+                <a:cs typeface="Helvetica Neue"/>
+              </a:rPr>
+              <a:t>TEAM AC/DC · HACKATHON PROJECT</a:t>
+            </a:r>
+          </a:p>
+        </p:txBody>
+      </p:sp>
+      <p:sp>
+        <p:nvSpPr>
+          <p:cNvPr id="7" name="Slide number">
+            <a:extLst xmlns:a="http://schemas.openxmlformats.org/drawingml/2006/main">
+              <a:ext uri="{FF2B5EF4-FFF2-40B4-BE49-F238E27FC236}">
+                <a16:creationId xmlns:a16="http://schemas.microsoft.com/office/drawing/2014/main" id="{8FCD37F4-BE86-47AF-827A-E27330F96DAE}"/>
+              </a:ext>
+            </a:extLst>
+          </p:cNvPr>
+          <p:cNvSpPr>
+            <a:spLocks xmlns:a="http://schemas.openxmlformats.org/drawingml/2006/main" noGrp="1"/>
+          </p:cNvSpPr>
+          <p:nvPr/>
+        </p:nvSpPr>
+        <p:spPr>
+          <a:xfrm xmlns:a="http://schemas.openxmlformats.org/drawingml/2006/main">
+            <a:off x="10906125" y="6467475"/>
+            <a:ext cx="676275" cy="190500"/>
+          </a:xfrm>
+          <a:prstGeom xmlns:a="http://schemas.openxmlformats.org/drawingml/2006/main" prst="rect">
+            <a:avLst/>
+          </a:prstGeom>
+          <a:noFill xmlns:a="http://schemas.openxmlformats.org/drawingml/2006/main"/>
+          <a:ln xmlns:a="http://schemas.openxmlformats.org/drawingml/2006/main" w="0">
+            <a:noFill/>
+            <a:prstDash val="solid"/>
+          </a:ln>
+        </p:spPr>
+        <p:txBody>
+          <a:bodyPr xmlns:a="http://schemas.openxmlformats.org/drawingml/2006/main" wrap="square" lIns="0" tIns="0" rIns="0" bIns="0" anchor="t">
+            <a:normAutofit fontScale="100000"/>
+          </a:bodyPr>
+          <a:lstStyle xmlns:a="http://schemas.openxmlformats.org/drawingml/2006/main">
+            <a:defPPr algn="r">
+              <a:defRPr sz="975">
+                <a:solidFill>
+                  <a:srgbClr val="C5CABC"/>
+                </a:solidFill>
+                <a:latin typeface="Helvetica Neue"/>
+                <a:ea typeface="Helvetica Neue"/>
+                <a:cs typeface="Helvetica Neue"/>
+              </a:defRPr>
+            </a:defPPr>
+            <a:lvl1pPr algn="r">
+              <a:defRPr sz="975">
+                <a:solidFill>
+                  <a:srgbClr val="C5CABC"/>
+                </a:solidFill>
+                <a:latin typeface="Helvetica Neue"/>
+                <a:ea typeface="Helvetica Neue"/>
+                <a:cs typeface="Helvetica Neue"/>
+              </a:defRPr>
+            </a:lvl1pPr>
+            <a:lvl2pPr algn="r">
+              <a:defRPr sz="975">
+                <a:solidFill>
+                  <a:srgbClr val="C5CABC"/>
+                </a:solidFill>
+                <a:latin typeface="Helvetica Neue"/>
+                <a:ea typeface="Helvetica Neue"/>
+                <a:cs typeface="Helvetica Neue"/>
+              </a:defRPr>
+            </a:lvl2pPr>
+            <a:lvl3pPr algn="r">
+              <a:defRPr sz="975">
+                <a:solidFill>
+                  <a:srgbClr val="C5CABC"/>
+                </a:solidFill>
+                <a:latin typeface="Helvetica Neue"/>
+                <a:ea typeface="Helvetica Neue"/>
+                <a:cs typeface="Helvetica Neue"/>
+              </a:defRPr>
+            </a:lvl3pPr>
+            <a:lvl4pPr algn="r">
+              <a:defRPr sz="975">
+                <a:solidFill>
+                  <a:srgbClr val="C5CABC"/>
+                </a:solidFill>
+                <a:latin typeface="Helvetica Neue"/>
+                <a:ea typeface="Helvetica Neue"/>
+                <a:cs typeface="Helvetica Neue"/>
+              </a:defRPr>
+            </a:lvl4pPr>
+            <a:lvl5pPr algn="r">
+              <a:defRPr sz="975">
+                <a:solidFill>
+                  <a:srgbClr val="C5CABC"/>
+                </a:solidFill>
+                <a:latin typeface="Helvetica Neue"/>
+                <a:ea typeface="Helvetica Neue"/>
+                <a:cs typeface="Helvetica Neue"/>
+              </a:defRPr>
+            </a:lvl5pPr>
+            <a:lvl6pPr algn="r">
+              <a:defRPr sz="975">
+                <a:solidFill>
+                  <a:srgbClr val="C5CABC"/>
+                </a:solidFill>
+                <a:latin typeface="Helvetica Neue"/>
+                <a:ea typeface="Helvetica Neue"/>
+                <a:cs typeface="Helvetica Neue"/>
+              </a:defRPr>
+            </a:lvl6pPr>
+            <a:lvl7pPr algn="r">
+              <a:defRPr sz="975">
+                <a:solidFill>
+                  <a:srgbClr val="C5CABC"/>
+                </a:solidFill>
+                <a:latin typeface="Helvetica Neue"/>
+                <a:ea typeface="Helvetica Neue"/>
+                <a:cs typeface="Helvetica Neue"/>
+              </a:defRPr>
+            </a:lvl7pPr>
+            <a:lvl8pPr algn="r">
+              <a:defRPr sz="975">
+                <a:solidFill>
+                  <a:srgbClr val="C5CABC"/>
+                </a:solidFill>
+                <a:latin typeface="Helvetica Neue"/>
+                <a:ea typeface="Helvetica Neue"/>
+                <a:cs typeface="Helvetica Neue"/>
+              </a:defRPr>
+            </a:lvl8pPr>
+            <a:lvl9pPr algn="r">
+              <a:defRPr sz="975">
+                <a:solidFill>
+                  <a:srgbClr val="C5CABC"/>
+                </a:solidFill>
+                <a:latin typeface="Helvetica Neue"/>
+                <a:ea typeface="Helvetica Neue"/>
+                <a:cs typeface="Helvetica Neue"/>
+              </a:defRPr>
+            </a:lvl9pPr>
+          </a:lstStyle>
+          <a:p xmlns:a="http://schemas.openxmlformats.org/drawingml/2006/main">
+            <a:pPr algn="r">
+              <a:defRPr sz="975">
+                <a:solidFill>
+                  <a:srgbClr val="C5CABC"/>
+                </a:solidFill>
+                <a:latin typeface="Helvetica Neue"/>
+                <a:ea typeface="Helvetica Neue"/>
+                <a:cs typeface="Helvetica Neue"/>
+              </a:defRPr>
+            </a:pPr>
+            <a:r>
+              <a:rPr sz="975">
+                <a:solidFill>
+                  <a:srgbClr val="C5CABC"/>
+                </a:solidFill>
+                <a:latin typeface="Helvetica Neue"/>
+                <a:ea typeface="Helvetica Neue"/>
+                <a:cs typeface="Helvetica Neue"/>
+              </a:rPr>
+              <a:t>5 / 8</a:t>
+            </a:r>
+          </a:p>
+        </p:txBody>
+      </p:sp>
+    </p:spTree>
+    <p:extLst>
+      <p:ext uri="{BB962C8B-B14F-4D97-AF65-F5344CB8AC3E}">
+        <p14:creationId xmlns:p14="http://schemas.microsoft.com/office/powerpoint/2010/main" val="2039118202"/>
       </p:ext>
     </p:extLst>
   </p:cSld>

</xml_diff>